<commit_message>
docs(deck): regenerate the oral-defense deck with the illustrated slides
Carries the pending presentation work: the build-deck generator now emits the
image-bearing slides, and the regenerated pptx, FAQ, slide plan and validation
report follow. Also ignores Office lock files (~$*.pptx) so a deck left open in
PowerPoint no longer shows up as an untracked artifact.

Co-authored-by: Copilot <223556219+Copilot@users.noreply.github.com>
Copilot-Session: 6f86afe7-0a78-4753-8d86-653e8c200a26
</commit_message>
<xml_diff>
--- a/docs/presentation/NovaSteel-Oral-Defense.pptx
+++ b/docs/presentation/NovaSteel-Oral-Defense.pptx
@@ -31,9 +31,10 @@
     <p:sldId id="279" r:id="rId25"/>
     <p:sldId id="280" r:id="rId26"/>
     <p:sldId id="281" r:id="rId27"/>
+    <p:sldId id="282" r:id="rId28"/>
   </p:sldIdLst>
   <p:notesMasterIdLst>
-    <p:notesMasterId r:id="rId28"/>
+    <p:notesMasterId r:id="rId29"/>
   </p:notesMasterIdLst>
   <p:sldSz cx="12191695" cy="6858000"/>
   <p:notesSz cx="6858000" cy="12191695"/>
@@ -2153,6 +2154,94 @@
 </p:notes>
 </file>
 
+<file path=ppt/notesSlides/notesSlide27.xml><?xml version="1.0" encoding="utf-8"?>
+<p:notes xmlns:a="http://schemas.openxmlformats.org/drawingml/2006/main" xmlns:r="http://schemas.openxmlformats.org/officeDocument/2006/relationships" xmlns:p="http://schemas.openxmlformats.org/presentationml/2006/main">
+  <p:cSld>
+    <p:spTree>
+      <p:nvGrpSpPr>
+        <p:cNvPr id="1" name=""/>
+        <p:cNvGrpSpPr/>
+        <p:nvPr/>
+      </p:nvGrpSpPr>
+      <p:grpSpPr>
+        <a:xfrm>
+          <a:off x="0" y="0"/>
+          <a:ext cx="0" cy="0"/>
+          <a:chOff x="0" y="0"/>
+          <a:chExt cx="0" cy="0"/>
+        </a:xfrm>
+      </p:grpSpPr>
+      <p:sp>
+        <p:nvSpPr>
+          <p:cNvPr id="2" name="Slide Image Placeholder 1"/>
+          <p:cNvSpPr>
+            <a:spLocks noGrp="1" noRot="1" noChangeAspect="1"/>
+          </p:cNvSpPr>
+          <p:nvPr>
+            <p:ph type="sldImg"/>
+          </p:nvPr>
+        </p:nvSpPr>
+        <p:spPr/>
+      </p:sp>
+      <p:sp>
+        <p:nvSpPr>
+          <p:cNvPr id="3" name="Notes Placeholder 2"/>
+          <p:cNvSpPr>
+            <a:spLocks noGrp="1"/>
+          </p:cNvSpPr>
+          <p:nvPr>
+            <p:ph type="body" idx="1"/>
+          </p:nvPr>
+        </p:nvSpPr>
+        <p:spPr/>
+        <p:txBody>
+          <a:bodyPr/>
+          <a:lstStyle/>
+          <a:p>
+            <a:r>
+              <a:rPr lang="en-US" dirty="0"/>
+              <a:t>This is the question I want. Not writing to the furnace is a decision, not a gap. Setpoints, interlocks, and control logic live at Purdue levels zero to two, under IEC 61511 safety-instrumented functions and vendor certification, and our conduit across that boundary is outbound-only by design.,But the platform is not a read-only dashboard. It writes decisions: an approved energy dispatch, a maintenance work order, a published procedure, and an append-only record of who decided what against which model version. That is a decision system of record.,Actuation is a Phase 2 conversation and it starts with guarded write-back to CMMS and MES under human approval and thresholds, never a direct control action. Advice that is wrong costs a rejection; a setpoint that is wrong can cost an eight-million-euro event.</a:t>
+            </a:r>
+            <a:endParaRPr lang="en-US" dirty="0"/>
+          </a:p>
+        </p:txBody>
+      </p:sp>
+      <p:sp>
+        <p:nvSpPr>
+          <p:cNvPr id="4" name="Slide Number Placeholder 3"/>
+          <p:cNvSpPr>
+            <a:spLocks noGrp="1"/>
+          </p:cNvSpPr>
+          <p:nvPr>
+            <p:ph type="sldNum" sz="quarter" idx="10"/>
+          </p:nvPr>
+        </p:nvSpPr>
+        <p:spPr/>
+        <p:txBody>
+          <a:bodyPr/>
+          <a:lstStyle/>
+          <a:p>
+            <a:fld id="{F7021451-1387-4CA6-816F-3879F97B5CBC}" type="slidenum">
+              <a:rPr lang="en-US"/>
+              <a:t>27</a:t>
+            </a:fld>
+            <a:endParaRPr lang="en-US"/>
+          </a:p>
+        </p:txBody>
+      </p:sp>
+    </p:spTree>
+    <p:extLst>
+      <p:ext uri="{BB962C8B-B14F-4D97-AF65-F5344CB8AC3E}">
+        <p14:creationId xmlns:p14="http://schemas.microsoft.com/office/powerpoint/2010/main" val="1024086991"/>
+      </p:ext>
+    </p:extLst>
+  </p:cSld>
+  <p:clrMapOvr>
+    <a:masterClrMapping/>
+  </p:clrMapOvr>
+</p:notes>
+</file>
+
 <file path=ppt/notesSlides/notesSlide3.xml><?xml version="1.0" encoding="utf-8"?>
 <p:notes xmlns:a="http://schemas.openxmlformats.org/drawingml/2006/main" xmlns:r="http://schemas.openxmlformats.org/officeDocument/2006/relationships" xmlns:p="http://schemas.openxmlformats.org/presentationml/2006/main">
   <p:cSld>
@@ -8226,10 +8315,6 @@
             <a:prstDash val="solid"/>
           </a:ln>
         </p:spPr>
-        <p:txBody>
-          <a:bodyPr/>
-          <a:p/>
-        </p:txBody>
       </p:sp>
       <p:sp>
         <p:nvSpPr>
@@ -8257,10 +8342,6 @@
             <a:prstDash val="solid"/>
           </a:ln>
         </p:spPr>
-        <p:txBody>
-          <a:bodyPr/>
-          <a:p/>
-        </p:txBody>
       </p:sp>
       <p:sp>
         <p:nvSpPr>
@@ -8286,10 +8367,6 @@
             <a:prstDash val="solid"/>
           </a:ln>
         </p:spPr>
-        <p:txBody>
-          <a:bodyPr/>
-          <a:p/>
-        </p:txBody>
       </p:sp>
       <p:sp>
         <p:nvSpPr>
@@ -8397,10 +8474,6 @@
             <a:prstDash val="solid"/>
           </a:ln>
         </p:spPr>
-        <p:txBody>
-          <a:bodyPr/>
-          <a:p/>
-        </p:txBody>
       </p:sp>
       <p:sp>
         <p:nvSpPr>
@@ -8508,10 +8581,6 @@
             <a:prstDash val="solid"/>
           </a:ln>
         </p:spPr>
-        <p:txBody>
-          <a:bodyPr/>
-          <a:p/>
-        </p:txBody>
       </p:sp>
       <p:sp>
         <p:nvSpPr>
@@ -8602,10 +8671,6 @@
             <a:prstDash val="solid"/>
           </a:ln>
         </p:spPr>
-        <p:txBody>
-          <a:bodyPr/>
-          <a:p/>
-        </p:txBody>
       </p:sp>
       <p:sp>
         <p:nvSpPr>
@@ -8672,10 +8737,6 @@
             <a:prstDash val="solid"/>
           </a:ln>
         </p:spPr>
-        <p:txBody>
-          <a:bodyPr/>
-          <a:p/>
-        </p:txBody>
       </p:sp>
       <p:sp>
         <p:nvSpPr>
@@ -8742,10 +8803,6 @@
             <a:prstDash val="solid"/>
           </a:ln>
         </p:spPr>
-        <p:txBody>
-          <a:bodyPr/>
-          <a:p/>
-        </p:txBody>
       </p:sp>
       <p:sp>
         <p:nvSpPr>
@@ -8812,10 +8869,6 @@
             <a:prstDash val="solid"/>
           </a:ln>
         </p:spPr>
-        <p:txBody>
-          <a:bodyPr/>
-          <a:p/>
-        </p:txBody>
       </p:sp>
       <p:sp>
         <p:nvSpPr>
@@ -8882,10 +8935,6 @@
             <a:prstDash val="solid"/>
           </a:ln>
         </p:spPr>
-        <p:txBody>
-          <a:bodyPr/>
-          <a:p/>
-        </p:txBody>
       </p:sp>
       <p:sp>
         <p:nvSpPr>
@@ -8909,10 +8958,6 @@
             <a:prstDash val="solid"/>
           </a:ln>
         </p:spPr>
-        <p:txBody>
-          <a:bodyPr/>
-          <a:p/>
-        </p:txBody>
       </p:sp>
       <p:sp>
         <p:nvSpPr>
@@ -8936,10 +8981,6 @@
             <a:prstDash val="solid"/>
           </a:ln>
         </p:spPr>
-        <p:txBody>
-          <a:bodyPr/>
-          <a:p/>
-        </p:txBody>
       </p:sp>
       <p:sp>
         <p:nvSpPr>
@@ -8963,10 +9004,6 @@
             <a:prstDash val="solid"/>
           </a:ln>
         </p:spPr>
-        <p:txBody>
-          <a:bodyPr/>
-          <a:p/>
-        </p:txBody>
       </p:sp>
       <p:sp>
         <p:nvSpPr>
@@ -8990,10 +9027,6 @@
             <a:prstDash val="solid"/>
           </a:ln>
         </p:spPr>
-        <p:txBody>
-          <a:bodyPr/>
-          <a:p/>
-        </p:txBody>
       </p:sp>
       <p:sp>
         <p:nvSpPr>
@@ -9019,10 +9052,6 @@
             <a:prstDash val="solid"/>
           </a:ln>
         </p:spPr>
-        <p:txBody>
-          <a:bodyPr/>
-          <a:p/>
-        </p:txBody>
       </p:sp>
       <p:sp>
         <p:nvSpPr>
@@ -9059,7 +9088,7 @@
                 <a:ea typeface="Aptos" pitchFamily="34" charset="-122"/>
                 <a:cs typeface="Aptos" pitchFamily="34" charset="-120"/>
               </a:rPr>
-              <a:t>18.69</a:t>
+              <a:t>16.8</a:t>
             </a:r>
             <a:endParaRPr lang="en-US" sz="720" dirty="0"/>
           </a:p>
@@ -9100,7 +9129,7 @@
                 <a:ea typeface="Aptos" pitchFamily="34" charset="-122"/>
                 <a:cs typeface="Aptos" pitchFamily="34" charset="-120"/>
               </a:rPr>
-              <a:t>19.65</a:t>
+              <a:t>21.0</a:t>
             </a:r>
             <a:endParaRPr lang="en-US" sz="830" dirty="0"/>
           </a:p>
@@ -9141,7 +9170,7 @@
                 <a:ea typeface="Aptos" pitchFamily="34" charset="-122"/>
                 <a:cs typeface="Aptos" pitchFamily="34" charset="-120"/>
               </a:rPr>
-              <a:t>20.61</a:t>
+              <a:t>27.5</a:t>
             </a:r>
             <a:endParaRPr lang="en-US" sz="720" dirty="0"/>
           </a:p>
@@ -9294,10 +9323,6 @@
             <a:prstDash val="solid"/>
           </a:ln>
         </p:spPr>
-        <p:txBody>
-          <a:bodyPr/>
-          <a:p/>
-        </p:txBody>
       </p:sp>
       <p:sp>
         <p:nvSpPr>
@@ -9334,7 +9359,7 @@
                 <a:ea typeface="Aptos" pitchFamily="34" charset="-122"/>
                 <a:cs typeface="Aptos" pitchFamily="34" charset="-120"/>
               </a:rPr>
-              <a:t>RISK 0.90 | HIGH</a:t>
+              <a:t>RISK 0.87 | HIGH</a:t>
             </a:r>
             <a:endParaRPr lang="en-US" sz="720" dirty="0"/>
           </a:p>
@@ -9364,10 +9389,6 @@
             <a:prstDash val="solid"/>
           </a:ln>
         </p:spPr>
-        <p:txBody>
-          <a:bodyPr/>
-          <a:p/>
-        </p:txBody>
       </p:sp>
       <p:sp>
         <p:nvSpPr>
@@ -9475,10 +9496,6 @@
             <a:prstDash val="solid"/>
           </a:ln>
         </p:spPr>
-        <p:txBody>
-          <a:bodyPr/>
-          <a:p/>
-        </p:txBody>
       </p:sp>
       <p:sp>
         <p:nvSpPr>
@@ -9504,10 +9521,6 @@
             <a:prstDash val="solid"/>
           </a:ln>
         </p:spPr>
-        <p:txBody>
-          <a:bodyPr/>
-          <a:p/>
-        </p:txBody>
       </p:sp>
       <p:sp>
         <p:nvSpPr>
@@ -9574,10 +9587,6 @@
             <a:prstDash val="solid"/>
           </a:ln>
         </p:spPr>
-        <p:txBody>
-          <a:bodyPr/>
-          <a:p/>
-        </p:txBody>
       </p:sp>
       <p:sp>
         <p:nvSpPr>
@@ -9603,10 +9612,6 @@
             <a:prstDash val="solid"/>
           </a:ln>
         </p:spPr>
-        <p:txBody>
-          <a:bodyPr/>
-          <a:p/>
-        </p:txBody>
       </p:sp>
       <p:sp>
         <p:nvSpPr>
@@ -9673,10 +9678,6 @@
             <a:prstDash val="solid"/>
           </a:ln>
         </p:spPr>
-        <p:txBody>
-          <a:bodyPr/>
-          <a:p/>
-        </p:txBody>
       </p:sp>
       <p:sp>
         <p:nvSpPr>
@@ -9702,10 +9703,6 @@
             <a:prstDash val="solid"/>
           </a:ln>
         </p:spPr>
-        <p:txBody>
-          <a:bodyPr/>
-          <a:p/>
-        </p:txBody>
       </p:sp>
       <p:sp>
         <p:nvSpPr>
@@ -9731,10 +9728,6 @@
             <a:prstDash val="solid"/>
           </a:ln>
         </p:spPr>
-        <p:txBody>
-          <a:bodyPr/>
-          <a:p/>
-        </p:txBody>
       </p:sp>
       <p:sp>
         <p:nvSpPr>
@@ -9760,10 +9753,6 @@
             <a:prstDash val="solid"/>
           </a:ln>
         </p:spPr>
-        <p:txBody>
-          <a:bodyPr/>
-          <a:p/>
-        </p:txBody>
       </p:sp>
       <p:sp>
         <p:nvSpPr>
@@ -9830,10 +9819,6 @@
             <a:prstDash val="solid"/>
           </a:ln>
         </p:spPr>
-        <p:txBody>
-          <a:bodyPr/>
-          <a:p/>
-        </p:txBody>
       </p:sp>
       <p:sp>
         <p:nvSpPr>
@@ -9859,10 +9844,6 @@
             <a:prstDash val="solid"/>
           </a:ln>
         </p:spPr>
-        <p:txBody>
-          <a:bodyPr/>
-          <a:p/>
-        </p:txBody>
       </p:sp>
       <p:sp>
         <p:nvSpPr>
@@ -9929,10 +9910,6 @@
             <a:prstDash val="solid"/>
           </a:ln>
         </p:spPr>
-        <p:txBody>
-          <a:bodyPr/>
-          <a:p/>
-        </p:txBody>
       </p:sp>
       <p:sp>
         <p:nvSpPr>
@@ -9958,10 +9935,6 @@
             <a:prstDash val="solid"/>
           </a:ln>
         </p:spPr>
-        <p:txBody>
-          <a:bodyPr/>
-          <a:p/>
-        </p:txBody>
       </p:sp>
       <p:sp>
         <p:nvSpPr>
@@ -10028,10 +10001,6 @@
             <a:prstDash val="solid"/>
           </a:ln>
         </p:spPr>
-        <p:txBody>
-          <a:bodyPr/>
-          <a:p/>
-        </p:txBody>
       </p:sp>
       <p:sp>
         <p:nvSpPr>
@@ -10057,10 +10026,6 @@
             <a:prstDash val="solid"/>
           </a:ln>
         </p:spPr>
-        <p:txBody>
-          <a:bodyPr/>
-          <a:p/>
-        </p:txBody>
       </p:sp>
       <p:sp>
         <p:nvSpPr>
@@ -10168,10 +10133,6 @@
             <a:prstDash val="solid"/>
           </a:ln>
         </p:spPr>
-        <p:txBody>
-          <a:bodyPr/>
-          <a:p/>
-        </p:txBody>
       </p:sp>
       <p:sp>
         <p:nvSpPr>
@@ -10197,10 +10158,6 @@
             <a:prstDash val="solid"/>
           </a:ln>
         </p:spPr>
-        <p:txBody>
-          <a:bodyPr/>
-          <a:p/>
-        </p:txBody>
       </p:sp>
       <p:sp>
         <p:nvSpPr>
@@ -10342,10 +10299,6 @@
             <a:prstDash val="solid"/>
           </a:ln>
         </p:spPr>
-        <p:txBody>
-          <a:bodyPr/>
-          <a:p/>
-        </p:txBody>
       </p:sp>
       <p:sp>
         <p:nvSpPr>
@@ -10373,10 +10326,6 @@
             <a:prstDash val="solid"/>
           </a:ln>
         </p:spPr>
-        <p:txBody>
-          <a:bodyPr/>
-          <a:p/>
-        </p:txBody>
       </p:sp>
       <p:sp>
         <p:nvSpPr>
@@ -10402,10 +10351,6 @@
             <a:prstDash val="solid"/>
           </a:ln>
         </p:spPr>
-        <p:txBody>
-          <a:bodyPr/>
-          <a:p/>
-        </p:txBody>
       </p:sp>
       <p:sp>
         <p:nvSpPr>
@@ -10513,10 +10458,6 @@
             <a:prstDash val="solid"/>
           </a:ln>
         </p:spPr>
-        <p:txBody>
-          <a:bodyPr/>
-          <a:p/>
-        </p:txBody>
       </p:sp>
       <p:sp>
         <p:nvSpPr>
@@ -10624,10 +10565,6 @@
             <a:prstDash val="solid"/>
           </a:ln>
         </p:spPr>
-        <p:txBody>
-          <a:bodyPr/>
-          <a:p/>
-        </p:txBody>
       </p:sp>
       <p:sp>
         <p:nvSpPr>
@@ -10694,10 +10631,6 @@
             <a:prstDash val="solid"/>
           </a:ln>
         </p:spPr>
-        <p:txBody>
-          <a:bodyPr/>
-          <a:p/>
-        </p:txBody>
       </p:sp>
       <p:sp>
         <p:nvSpPr>
@@ -10723,10 +10656,6 @@
             <a:prstDash val="solid"/>
           </a:ln>
         </p:spPr>
-        <p:txBody>
-          <a:bodyPr/>
-          <a:p/>
-        </p:txBody>
       </p:sp>
       <p:sp>
         <p:nvSpPr>
@@ -10791,10 +10720,6 @@
             <a:prstDash val="solid"/>
           </a:ln>
         </p:spPr>
-        <p:txBody>
-          <a:bodyPr/>
-          <a:p/>
-        </p:txBody>
       </p:sp>
       <p:sp>
         <p:nvSpPr>
@@ -10818,10 +10743,6 @@
             <a:prstDash val="solid"/>
           </a:ln>
         </p:spPr>
-        <p:txBody>
-          <a:bodyPr/>
-          <a:p/>
-        </p:txBody>
       </p:sp>
       <p:sp>
         <p:nvSpPr>
@@ -10845,10 +10766,6 @@
             <a:prstDash val="solid"/>
           </a:ln>
         </p:spPr>
-        <p:txBody>
-          <a:bodyPr/>
-          <a:p/>
-        </p:txBody>
       </p:sp>
       <p:sp>
         <p:nvSpPr>
@@ -10872,10 +10789,6 @@
             <a:prstDash val="solid"/>
           </a:ln>
         </p:spPr>
-        <p:txBody>
-          <a:bodyPr/>
-          <a:p/>
-        </p:txBody>
       </p:sp>
       <p:sp>
         <p:nvSpPr>
@@ -10899,10 +10812,6 @@
             <a:prstDash val="solid"/>
           </a:ln>
         </p:spPr>
-        <p:txBody>
-          <a:bodyPr/>
-          <a:p/>
-        </p:txBody>
       </p:sp>
       <p:sp>
         <p:nvSpPr>
@@ -10926,10 +10835,6 @@
             <a:prstDash val="solid"/>
           </a:ln>
         </p:spPr>
-        <p:txBody>
-          <a:bodyPr/>
-          <a:p/>
-        </p:txBody>
       </p:sp>
       <p:sp>
         <p:nvSpPr>
@@ -10953,10 +10858,6 @@
             <a:prstDash val="solid"/>
           </a:ln>
         </p:spPr>
-        <p:txBody>
-          <a:bodyPr/>
-          <a:p/>
-        </p:txBody>
       </p:sp>
       <p:sp>
         <p:nvSpPr>
@@ -10980,10 +10881,6 @@
             <a:prstDash val="solid"/>
           </a:ln>
         </p:spPr>
-        <p:txBody>
-          <a:bodyPr/>
-          <a:p/>
-        </p:txBody>
       </p:sp>
       <p:sp>
         <p:nvSpPr>
@@ -11007,10 +10904,6 @@
             <a:prstDash val="solid"/>
           </a:ln>
         </p:spPr>
-        <p:txBody>
-          <a:bodyPr/>
-          <a:p/>
-        </p:txBody>
       </p:sp>
       <p:sp>
         <p:nvSpPr>
@@ -11034,10 +10927,6 @@
             <a:prstDash val="solid"/>
           </a:ln>
         </p:spPr>
-        <p:txBody>
-          <a:bodyPr/>
-          <a:p/>
-        </p:txBody>
       </p:sp>
       <p:sp>
         <p:nvSpPr>
@@ -11061,10 +10950,6 @@
             <a:prstDash val="solid"/>
           </a:ln>
         </p:spPr>
-        <p:txBody>
-          <a:bodyPr/>
-          <a:p/>
-        </p:txBody>
       </p:sp>
       <p:sp>
         <p:nvSpPr>
@@ -11088,10 +10973,6 @@
             <a:prstDash val="solid"/>
           </a:ln>
         </p:spPr>
-        <p:txBody>
-          <a:bodyPr/>
-          <a:p/>
-        </p:txBody>
       </p:sp>
       <p:sp>
         <p:nvSpPr>
@@ -11115,10 +10996,6 @@
             <a:prstDash val="solid"/>
           </a:ln>
         </p:spPr>
-        <p:txBody>
-          <a:bodyPr/>
-          <a:p/>
-        </p:txBody>
       </p:sp>
       <p:sp>
         <p:nvSpPr>
@@ -11144,10 +11021,6 @@
             <a:prstDash val="solid"/>
           </a:ln>
         </p:spPr>
-        <p:txBody>
-          <a:bodyPr/>
-          <a:p/>
-        </p:txBody>
       </p:sp>
       <p:sp>
         <p:nvSpPr>
@@ -11371,10 +11244,6 @@
             <a:prstDash val="solid"/>
           </a:ln>
         </p:spPr>
-        <p:txBody>
-          <a:bodyPr/>
-          <a:p/>
-        </p:txBody>
       </p:sp>
       <p:sp>
         <p:nvSpPr>
@@ -11400,10 +11269,6 @@
             <a:prstDash val="solid"/>
           </a:ln>
         </p:spPr>
-        <p:txBody>
-          <a:bodyPr/>
-          <a:p/>
-        </p:txBody>
       </p:sp>
       <p:sp>
         <p:nvSpPr>
@@ -11511,10 +11376,6 @@
             <a:prstDash val="solid"/>
           </a:ln>
         </p:spPr>
-        <p:txBody>
-          <a:bodyPr/>
-          <a:p/>
-        </p:txBody>
       </p:sp>
       <p:sp>
         <p:nvSpPr>
@@ -11540,10 +11401,6 @@
             <a:prstDash val="solid"/>
           </a:ln>
         </p:spPr>
-        <p:txBody>
-          <a:bodyPr/>
-          <a:p/>
-        </p:txBody>
       </p:sp>
       <p:sp>
         <p:nvSpPr>
@@ -11569,10 +11426,6 @@
             <a:prstDash val="solid"/>
           </a:ln>
         </p:spPr>
-        <p:txBody>
-          <a:bodyPr/>
-          <a:p/>
-        </p:txBody>
       </p:sp>
       <p:sp>
         <p:nvSpPr>
@@ -11598,10 +11451,6 @@
             <a:prstDash val="solid"/>
           </a:ln>
         </p:spPr>
-        <p:txBody>
-          <a:bodyPr/>
-          <a:p/>
-        </p:txBody>
       </p:sp>
       <p:sp>
         <p:nvSpPr>
@@ -11668,10 +11517,6 @@
             <a:prstDash val="solid"/>
           </a:ln>
         </p:spPr>
-        <p:txBody>
-          <a:bodyPr/>
-          <a:p/>
-        </p:txBody>
       </p:sp>
       <p:sp>
         <p:nvSpPr>
@@ -11697,10 +11542,6 @@
             <a:prstDash val="solid"/>
           </a:ln>
         </p:spPr>
-        <p:txBody>
-          <a:bodyPr/>
-          <a:p/>
-        </p:txBody>
       </p:sp>
       <p:sp>
         <p:nvSpPr>
@@ -11726,10 +11567,6 @@
             <a:prstDash val="solid"/>
           </a:ln>
         </p:spPr>
-        <p:txBody>
-          <a:bodyPr/>
-          <a:p/>
-        </p:txBody>
       </p:sp>
       <p:sp>
         <p:nvSpPr>
@@ -11755,10 +11592,6 @@
             <a:prstDash val="solid"/>
           </a:ln>
         </p:spPr>
-        <p:txBody>
-          <a:bodyPr/>
-          <a:p/>
-        </p:txBody>
       </p:sp>
       <p:sp>
         <p:nvSpPr>
@@ -11784,10 +11617,6 @@
             <a:prstDash val="solid"/>
           </a:ln>
         </p:spPr>
-        <p:txBody>
-          <a:bodyPr/>
-          <a:p/>
-        </p:txBody>
       </p:sp>
       <p:sp>
         <p:nvSpPr>
@@ -11824,7 +11653,7 @@
                 <a:ea typeface="Aptos" pitchFamily="34" charset="-122"/>
                 <a:cs typeface="Aptos" pitchFamily="34" charset="-120"/>
               </a:rPr>
-              <a:t>7.25% MODELED COST CUT</a:t>
+              <a:t>8–13% MODELED COST CUT</a:t>
             </a:r>
             <a:endParaRPr lang="en-US" sz="720" dirty="0"/>
           </a:p>
@@ -11865,7 +11694,7 @@
                 <a:ea typeface="Aptos" pitchFamily="34" charset="-122"/>
                 <a:cs typeface="Aptos" pitchFamily="34" charset="-120"/>
               </a:rPr>
-              <a:t>960 t conserved  |  zero violations  |  −7.89% peak  |  −3.29% CO₂</a:t>
+              <a:t>Equal tonnage  |  zero hard-constraint violations  |  3–7% lower peak</a:t>
             </a:r>
             <a:endParaRPr lang="en-US" sz="770" dirty="0"/>
           </a:p>
@@ -11895,10 +11724,6 @@
             <a:prstDash val="solid"/>
           </a:ln>
         </p:spPr>
-        <p:txBody>
-          <a:bodyPr/>
-          <a:p/>
-        </p:txBody>
       </p:sp>
       <p:sp>
         <p:nvSpPr>
@@ -12036,10 +11861,6 @@
             <a:prstDash val="solid"/>
           </a:ln>
         </p:spPr>
-        <p:txBody>
-          <a:bodyPr/>
-          <a:p/>
-        </p:txBody>
       </p:sp>
       <p:sp>
         <p:nvSpPr>
@@ -12177,10 +11998,6 @@
             <a:prstDash val="solid"/>
           </a:ln>
         </p:spPr>
-        <p:txBody>
-          <a:bodyPr/>
-          <a:p/>
-        </p:txBody>
       </p:sp>
       <p:sp>
         <p:nvSpPr>
@@ -12359,10 +12176,6 @@
             <a:prstDash val="solid"/>
           </a:ln>
         </p:spPr>
-        <p:txBody>
-          <a:bodyPr/>
-          <a:p/>
-        </p:txBody>
       </p:sp>
       <p:sp>
         <p:nvSpPr>
@@ -12388,10 +12201,6 @@
             <a:prstDash val="solid"/>
           </a:ln>
         </p:spPr>
-        <p:txBody>
-          <a:bodyPr/>
-          <a:p/>
-        </p:txBody>
       </p:sp>
       <p:sp>
         <p:nvSpPr>
@@ -27864,7 +27673,7 @@
                 <a:ea typeface="Aptos" pitchFamily="34" charset="-122"/>
                 <a:cs typeface="Aptos" pitchFamily="34" charset="-120"/>
               </a:rPr>
-              <a:t>FAQ &amp; VALIDATION BACKUP  •  01 / 06</a:t>
+              <a:t>FAQ &amp; VALIDATION BACKUP  •  01 / 07</a:t>
             </a:r>
             <a:endParaRPr lang="en-US" sz="650" dirty="0"/>
           </a:p>
@@ -28820,7 +28629,7 @@
                 <a:ea typeface="Aptos" pitchFamily="34" charset="-122"/>
                 <a:cs typeface="Aptos" pitchFamily="34" charset="-120"/>
               </a:rPr>
-              <a:t>FAQ &amp; VALIDATION BACKUP  •  02 / 06</a:t>
+              <a:t>FAQ &amp; VALIDATION BACKUP  •  02 / 07</a:t>
             </a:r>
             <a:endParaRPr lang="en-US" sz="650" dirty="0"/>
           </a:p>
@@ -30219,7 +30028,7 @@
                 <a:ea typeface="Aptos" pitchFamily="34" charset="-122"/>
                 <a:cs typeface="Aptos" pitchFamily="34" charset="-120"/>
               </a:rPr>
-              <a:t>FAQ &amp; VALIDATION BACKUP  •  03 / 06</a:t>
+              <a:t>FAQ &amp; VALIDATION BACKUP  •  03 / 07</a:t>
             </a:r>
             <a:endParaRPr lang="en-US" sz="650" dirty="0"/>
           </a:p>
@@ -31456,7 +31265,7 @@
                 <a:ea typeface="Aptos" pitchFamily="34" charset="-122"/>
                 <a:cs typeface="Aptos" pitchFamily="34" charset="-120"/>
               </a:rPr>
-              <a:t>FAQ &amp; VALIDATION BACKUP  •  04 / 06</a:t>
+              <a:t>FAQ &amp; VALIDATION BACKUP  •  04 / 07</a:t>
             </a:r>
             <a:endParaRPr lang="en-US" sz="650" dirty="0"/>
           </a:p>
@@ -32523,7 +32332,7 @@
                 <a:ea typeface="Aptos" pitchFamily="34" charset="-122"/>
                 <a:cs typeface="Aptos" pitchFamily="34" charset="-120"/>
               </a:rPr>
-              <a:t>FAQ &amp; VALIDATION BACKUP  •  05 / 06</a:t>
+              <a:t>FAQ &amp; VALIDATION BACKUP  •  05 / 07</a:t>
             </a:r>
             <a:endParaRPr lang="en-US" sz="650" dirty="0"/>
           </a:p>
@@ -33933,7 +33742,3177 @@
                 <a:ea typeface="Aptos" pitchFamily="34" charset="-122"/>
                 <a:cs typeface="Aptos" pitchFamily="34" charset="-120"/>
               </a:rPr>
-              <a:t>FAQ &amp; VALIDATION BACKUP  •  06 / 06</a:t>
+              <a:t>FAQ &amp; VALIDATION BACKUP  •  06 / 07</a:t>
+            </a:r>
+            <a:endParaRPr lang="en-US" sz="650" dirty="0"/>
+          </a:p>
+        </p:txBody>
+      </p:sp>
+    </p:spTree>
+  </p:cSld>
+  <p:clrMapOvr>
+    <a:masterClrMapping/>
+  </p:clrMapOvr>
+</p:sld>
+</file>
+
+<file path=ppt/slides/slide27.xml><?xml version="1.0" encoding="utf-8"?>
+<p:sld xmlns:a="http://schemas.openxmlformats.org/drawingml/2006/main" xmlns:r="http://schemas.openxmlformats.org/officeDocument/2006/relationships" xmlns:p="http://schemas.openxmlformats.org/presentationml/2006/main">
+  <p:cSld name="Slide 27">
+    <p:bg>
+      <p:bgPr>
+        <a:solidFill>
+          <a:srgbClr val="F4F0E9"/>
+        </a:solidFill>
+      </p:bgPr>
+    </p:bg>
+    <p:spTree>
+      <p:nvGrpSpPr>
+        <p:cNvPr id="1" name=""/>
+        <p:cNvGrpSpPr/>
+        <p:nvPr/>
+      </p:nvGrpSpPr>
+      <p:grpSpPr>
+        <a:xfrm>
+          <a:off x="0" y="0"/>
+          <a:ext cx="0" cy="0"/>
+          <a:chOff x="0" y="0"/>
+          <a:chExt cx="0" cy="0"/>
+        </a:xfrm>
+      </p:grpSpPr>
+      <p:sp>
+        <p:nvSpPr>
+          <p:cNvPr id="2" name="Shape 0"/>
+          <p:cNvSpPr/>
+          <p:nvPr/>
+        </p:nvSpPr>
+        <p:spPr>
+          <a:xfrm>
+            <a:off x="10195560" y="73152"/>
+            <a:ext cx="1664208" cy="1664208"/>
+          </a:xfrm>
+          <a:prstGeom prst="ellipse">
+            <a:avLst/>
+          </a:prstGeom>
+          <a:solidFill>
+            <a:srgbClr val="F3E9CB">
+              <a:alpha val="75000"/>
+            </a:srgbClr>
+          </a:solidFill>
+          <a:ln w="6350">
+            <a:solidFill>
+              <a:srgbClr val="F3E9CB"/>
+            </a:solidFill>
+            <a:prstDash val="solid"/>
+          </a:ln>
+        </p:spPr>
+      </p:sp>
+      <p:sp>
+        <p:nvSpPr>
+          <p:cNvPr id="3" name="Shape 1"/>
+          <p:cNvSpPr/>
+          <p:nvPr/>
+        </p:nvSpPr>
+        <p:spPr>
+          <a:xfrm>
+            <a:off x="73152" y="4983480"/>
+            <a:ext cx="1444752" cy="1444752"/>
+          </a:xfrm>
+          <a:prstGeom prst="ellipse">
+            <a:avLst/>
+          </a:prstGeom>
+          <a:solidFill>
+            <a:srgbClr val="D8ECE7">
+              <a:alpha val="65000"/>
+            </a:srgbClr>
+          </a:solidFill>
+          <a:ln w="6350">
+            <a:solidFill>
+              <a:srgbClr val="D8ECE7"/>
+            </a:solidFill>
+            <a:prstDash val="solid"/>
+          </a:ln>
+        </p:spPr>
+      </p:sp>
+      <p:sp>
+        <p:nvSpPr>
+          <p:cNvPr id="4" name="Shape 2"/>
+          <p:cNvSpPr/>
+          <p:nvPr/>
+        </p:nvSpPr>
+        <p:spPr>
+          <a:xfrm>
+            <a:off x="457200" y="274320"/>
+            <a:ext cx="822960" cy="246888"/>
+          </a:xfrm>
+          <a:prstGeom prst="roundRect">
+            <a:avLst/>
+          </a:prstGeom>
+          <a:solidFill>
+            <a:srgbClr val="7A261C"/>
+          </a:solidFill>
+          <a:ln w="5080">
+            <a:solidFill>
+              <a:srgbClr val="7A261C"/>
+            </a:solidFill>
+            <a:prstDash val="solid"/>
+          </a:ln>
+        </p:spPr>
+      </p:sp>
+      <p:sp>
+        <p:nvSpPr>
+          <p:cNvPr id="5" name="Text 3"/>
+          <p:cNvSpPr/>
+          <p:nvPr/>
+        </p:nvSpPr>
+        <p:spPr>
+          <a:xfrm>
+            <a:off x="576072" y="324612"/>
+            <a:ext cx="585216" cy="118872"/>
+          </a:xfrm>
+          <a:prstGeom prst="rect">
+            <a:avLst/>
+          </a:prstGeom>
+          <a:noFill/>
+          <a:ln/>
+        </p:spPr>
+        <p:txBody>
+          <a:bodyPr wrap="square" lIns="0" tIns="0" rIns="0" bIns="0" rtlCol="0" anchor="ctr">
+            <a:normAutofit/>
+          </a:bodyPr>
+          <a:lstStyle/>
+          <a:p>
+            <a:pPr algn="l" indent="0" marL="0">
+              <a:buNone/>
+            </a:pPr>
+            <a:r>
+              <a:rPr lang="en-US" sz="720" b="1" spc="110" kern="0" dirty="0">
+                <a:solidFill>
+                  <a:srgbClr val="FFFFFF"/>
+                </a:solidFill>
+                <a:latin typeface="Aptos" pitchFamily="34" charset="0"/>
+                <a:ea typeface="Aptos" pitchFamily="34" charset="-122"/>
+                <a:cs typeface="Aptos" pitchFamily="34" charset="-120"/>
+              </a:rPr>
+              <a:t>BACKUP 7</a:t>
+            </a:r>
+            <a:endParaRPr lang="en-US" sz="720" dirty="0"/>
+          </a:p>
+        </p:txBody>
+      </p:sp>
+      <p:sp>
+        <p:nvSpPr>
+          <p:cNvPr id="6" name="Text 4"/>
+          <p:cNvSpPr/>
+          <p:nvPr/>
+        </p:nvSpPr>
+        <p:spPr>
+          <a:xfrm>
+            <a:off x="1508760" y="310896"/>
+            <a:ext cx="6309360" cy="164592"/>
+          </a:xfrm>
+          <a:prstGeom prst="rect">
+            <a:avLst/>
+          </a:prstGeom>
+          <a:noFill/>
+          <a:ln/>
+        </p:spPr>
+        <p:txBody>
+          <a:bodyPr wrap="square" lIns="0" tIns="0" rIns="0" bIns="0" rtlCol="0" anchor="ctr">
+            <a:normAutofit/>
+          </a:bodyPr>
+          <a:lstStyle/>
+          <a:p>
+            <a:pPr algn="l" indent="0" marL="0">
+              <a:buNone/>
+            </a:pPr>
+            <a:r>
+              <a:rPr lang="en-US" sz="810" b="1" spc="130" kern="0" dirty="0">
+                <a:solidFill>
+                  <a:srgbClr val="687373"/>
+                </a:solidFill>
+                <a:latin typeface="Aptos" pitchFamily="34" charset="0"/>
+                <a:ea typeface="Aptos" pitchFamily="34" charset="-122"/>
+                <a:cs typeface="Aptos" pitchFamily="34" charset="-120"/>
+              </a:rPr>
+              <a:t>FAQ BACKUP</a:t>
+            </a:r>
+            <a:endParaRPr lang="en-US" sz="810" dirty="0"/>
+          </a:p>
+        </p:txBody>
+      </p:sp>
+      <p:sp>
+        <p:nvSpPr>
+          <p:cNvPr id="7" name="Text 5"/>
+          <p:cNvSpPr/>
+          <p:nvPr/>
+        </p:nvSpPr>
+        <p:spPr>
+          <a:xfrm>
+            <a:off x="457200" y="630936"/>
+            <a:ext cx="11109960" cy="429768"/>
+          </a:xfrm>
+          <a:prstGeom prst="rect">
+            <a:avLst/>
+          </a:prstGeom>
+          <a:noFill/>
+          <a:ln/>
+        </p:spPr>
+        <p:txBody>
+          <a:bodyPr wrap="square" lIns="0" tIns="0" rIns="0" bIns="0" rtlCol="0" anchor="ctr">
+            <a:normAutofit/>
+          </a:bodyPr>
+          <a:lstStyle/>
+          <a:p>
+            <a:pPr algn="l" indent="0" marL="0">
+              <a:buNone/>
+            </a:pPr>
+            <a:r>
+              <a:rPr lang="en-US" sz="2550" b="1" dirty="0">
+                <a:solidFill>
+                  <a:srgbClr val="202729"/>
+                </a:solidFill>
+                <a:latin typeface="Bahnschrift SemiBold" pitchFamily="34" charset="0"/>
+                <a:ea typeface="Bahnschrift SemiBold" pitchFamily="34" charset="-122"/>
+                <a:cs typeface="Bahnschrift SemiBold" pitchFamily="34" charset="-120"/>
+              </a:rPr>
+              <a:t>Why we do not write to the furnace</a:t>
+            </a:r>
+            <a:endParaRPr lang="en-US" sz="2550" dirty="0"/>
+          </a:p>
+        </p:txBody>
+      </p:sp>
+      <p:sp>
+        <p:nvSpPr>
+          <p:cNvPr id="8" name="Shape 6"/>
+          <p:cNvSpPr/>
+          <p:nvPr/>
+        </p:nvSpPr>
+        <p:spPr>
+          <a:xfrm>
+            <a:off x="457200" y="1188720"/>
+            <a:ext cx="1325880" cy="246888"/>
+          </a:xfrm>
+          <a:prstGeom prst="roundRect">
+            <a:avLst/>
+          </a:prstGeom>
+          <a:solidFill>
+            <a:srgbClr val="B64A2D"/>
+          </a:solidFill>
+          <a:ln w="5080">
+            <a:solidFill>
+              <a:srgbClr val="B64A2D"/>
+            </a:solidFill>
+            <a:prstDash val="solid"/>
+          </a:ln>
+        </p:spPr>
+      </p:sp>
+      <p:sp>
+        <p:nvSpPr>
+          <p:cNvPr id="9" name="Text 7"/>
+          <p:cNvSpPr/>
+          <p:nvPr/>
+        </p:nvSpPr>
+        <p:spPr>
+          <a:xfrm>
+            <a:off x="576072" y="1239012"/>
+            <a:ext cx="1088136" cy="118872"/>
+          </a:xfrm>
+          <a:prstGeom prst="rect">
+            <a:avLst/>
+          </a:prstGeom>
+          <a:noFill/>
+          <a:ln/>
+        </p:spPr>
+        <p:txBody>
+          <a:bodyPr wrap="square" lIns="0" tIns="0" rIns="0" bIns="0" rtlCol="0" anchor="ctr">
+            <a:normAutofit/>
+          </a:bodyPr>
+          <a:lstStyle/>
+          <a:p>
+            <a:pPr algn="l" indent="0" marL="0">
+              <a:buNone/>
+            </a:pPr>
+            <a:r>
+              <a:rPr lang="en-US" sz="720" b="1" spc="110" kern="0" dirty="0">
+                <a:solidFill>
+                  <a:srgbClr val="FFFFFF"/>
+                </a:solidFill>
+                <a:latin typeface="Aptos" pitchFamily="34" charset="0"/>
+                <a:ea typeface="Aptos" pitchFamily="34" charset="-122"/>
+                <a:cs typeface="Aptos" pitchFamily="34" charset="-120"/>
+              </a:rPr>
+              <a:t>SCOPE DEFENSE</a:t>
+            </a:r>
+            <a:endParaRPr lang="en-US" sz="720" dirty="0"/>
+          </a:p>
+        </p:txBody>
+      </p:sp>
+      <p:sp>
+        <p:nvSpPr>
+          <p:cNvPr id="10" name="Text 8"/>
+          <p:cNvSpPr/>
+          <p:nvPr/>
+        </p:nvSpPr>
+        <p:spPr>
+          <a:xfrm>
+            <a:off x="1901952" y="1220724"/>
+            <a:ext cx="6766560" cy="164592"/>
+          </a:xfrm>
+          <a:prstGeom prst="rect">
+            <a:avLst/>
+          </a:prstGeom>
+          <a:noFill/>
+          <a:ln/>
+        </p:spPr>
+        <p:txBody>
+          <a:bodyPr wrap="square" lIns="0" tIns="0" rIns="0" bIns="0" rtlCol="0" anchor="ctr">
+            <a:normAutofit/>
+          </a:bodyPr>
+          <a:lstStyle/>
+          <a:p>
+            <a:pPr algn="l" indent="0" marL="0">
+              <a:buNone/>
+            </a:pPr>
+            <a:r>
+              <a:rPr lang="en-US" sz="840" b="1" dirty="0">
+                <a:solidFill>
+                  <a:srgbClr val="687373"/>
+                </a:solidFill>
+                <a:latin typeface="Aptos" pitchFamily="34" charset="0"/>
+                <a:ea typeface="Aptos" pitchFamily="34" charset="-122"/>
+                <a:cs typeface="Aptos" pitchFamily="34" charset="-120"/>
+              </a:rPr>
+              <a:t>The advisory boundary is a designed acceptance criterion (O1, C-04, AI-05) — not a missing feature.</a:t>
+            </a:r>
+            <a:endParaRPr lang="en-US" sz="840" dirty="0"/>
+          </a:p>
+        </p:txBody>
+      </p:sp>
+      <p:sp>
+        <p:nvSpPr>
+          <p:cNvPr id="11" name="Text 9"/>
+          <p:cNvSpPr/>
+          <p:nvPr/>
+        </p:nvSpPr>
+        <p:spPr>
+          <a:xfrm>
+            <a:off x="457200" y="1627632"/>
+            <a:ext cx="3108960" cy="146304"/>
+          </a:xfrm>
+          <a:prstGeom prst="rect">
+            <a:avLst/>
+          </a:prstGeom>
+          <a:noFill/>
+          <a:ln/>
+        </p:spPr>
+        <p:txBody>
+          <a:bodyPr wrap="square" lIns="0" tIns="0" rIns="0" bIns="0" rtlCol="0" anchor="ctr">
+            <a:normAutofit/>
+          </a:bodyPr>
+          <a:lstStyle/>
+          <a:p>
+            <a:pPr algn="l" indent="0" marL="0">
+              <a:buNone/>
+            </a:pPr>
+            <a:r>
+              <a:rPr lang="en-US" sz="720" b="1" spc="120" kern="0" dirty="0">
+                <a:solidFill>
+                  <a:srgbClr val="687373"/>
+                </a:solidFill>
+                <a:latin typeface="Aptos" pitchFamily="34" charset="0"/>
+                <a:ea typeface="Aptos" pitchFamily="34" charset="-122"/>
+                <a:cs typeface="Aptos" pitchFamily="34" charset="-120"/>
+              </a:rPr>
+              <a:t>ISA-95 / PURDUE PLACEMENT</a:t>
+            </a:r>
+            <a:endParaRPr lang="en-US" sz="720" dirty="0"/>
+          </a:p>
+        </p:txBody>
+      </p:sp>
+      <p:sp>
+        <p:nvSpPr>
+          <p:cNvPr id="12" name="Shape 10"/>
+          <p:cNvSpPr/>
+          <p:nvPr/>
+        </p:nvSpPr>
+        <p:spPr>
+          <a:xfrm>
+            <a:off x="457200" y="1819656"/>
+            <a:ext cx="5623560" cy="786384"/>
+          </a:xfrm>
+          <a:prstGeom prst="roundRect">
+            <a:avLst/>
+          </a:prstGeom>
+          <a:solidFill>
+            <a:srgbClr val="FFFFFF"/>
+          </a:solidFill>
+          <a:ln w="8890">
+            <a:solidFill>
+              <a:srgbClr val="147D74"/>
+            </a:solidFill>
+            <a:prstDash val="solid"/>
+          </a:ln>
+        </p:spPr>
+      </p:sp>
+      <p:sp>
+        <p:nvSpPr>
+          <p:cNvPr id="13" name="Shape 11"/>
+          <p:cNvSpPr/>
+          <p:nvPr/>
+        </p:nvSpPr>
+        <p:spPr>
+          <a:xfrm>
+            <a:off x="457200" y="1819656"/>
+            <a:ext cx="77724" cy="786384"/>
+          </a:xfrm>
+          <a:prstGeom prst="rect">
+            <a:avLst/>
+          </a:prstGeom>
+          <a:solidFill>
+            <a:srgbClr val="147D74"/>
+          </a:solidFill>
+          <a:ln w="6350">
+            <a:solidFill>
+              <a:srgbClr val="147D74"/>
+            </a:solidFill>
+            <a:prstDash val="solid"/>
+          </a:ln>
+        </p:spPr>
+      </p:sp>
+      <p:sp>
+        <p:nvSpPr>
+          <p:cNvPr id="14" name="Text 12"/>
+          <p:cNvSpPr/>
+          <p:nvPr/>
+        </p:nvSpPr>
+        <p:spPr>
+          <a:xfrm>
+            <a:off x="658368" y="1956816"/>
+            <a:ext cx="3931920" cy="109728"/>
+          </a:xfrm>
+          <a:prstGeom prst="rect">
+            <a:avLst/>
+          </a:prstGeom>
+          <a:noFill/>
+          <a:ln/>
+        </p:spPr>
+        <p:txBody>
+          <a:bodyPr wrap="square" lIns="0" tIns="0" rIns="0" bIns="0" rtlCol="0" anchor="ctr">
+            <a:normAutofit/>
+          </a:bodyPr>
+          <a:lstStyle/>
+          <a:p>
+            <a:pPr algn="l" indent="0" marL="0">
+              <a:buNone/>
+            </a:pPr>
+            <a:r>
+              <a:rPr lang="en-US" sz="740" b="1" spc="90" kern="0" dirty="0">
+                <a:solidFill>
+                  <a:srgbClr val="147D74"/>
+                </a:solidFill>
+                <a:latin typeface="Aptos" pitchFamily="34" charset="0"/>
+                <a:ea typeface="Aptos" pitchFamily="34" charset="-122"/>
+                <a:cs typeface="Aptos" pitchFamily="34" charset="-120"/>
+              </a:rPr>
+              <a:t>L4 / L3 — BUSINESS, MES, HISTORIAN</a:t>
+            </a:r>
+            <a:endParaRPr lang="en-US" sz="740" dirty="0"/>
+          </a:p>
+        </p:txBody>
+      </p:sp>
+      <p:sp>
+        <p:nvSpPr>
+          <p:cNvPr id="15" name="Shape 13"/>
+          <p:cNvSpPr/>
+          <p:nvPr/>
+        </p:nvSpPr>
+        <p:spPr>
+          <a:xfrm>
+            <a:off x="4956048" y="1911096"/>
+            <a:ext cx="932688" cy="219456"/>
+          </a:xfrm>
+          <a:prstGeom prst="roundRect">
+            <a:avLst/>
+          </a:prstGeom>
+          <a:solidFill>
+            <a:srgbClr val="D8ECE7"/>
+          </a:solidFill>
+          <a:ln w="6350">
+            <a:solidFill>
+              <a:srgbClr val="147D74"/>
+            </a:solidFill>
+            <a:prstDash val="solid"/>
+          </a:ln>
+        </p:spPr>
+      </p:sp>
+      <p:sp>
+        <p:nvSpPr>
+          <p:cNvPr id="16" name="Text 14"/>
+          <p:cNvSpPr/>
+          <p:nvPr/>
+        </p:nvSpPr>
+        <p:spPr>
+          <a:xfrm>
+            <a:off x="5001768" y="1988820"/>
+            <a:ext cx="841248" cy="82296"/>
+          </a:xfrm>
+          <a:prstGeom prst="rect">
+            <a:avLst/>
+          </a:prstGeom>
+          <a:noFill/>
+          <a:ln/>
+        </p:spPr>
+        <p:txBody>
+          <a:bodyPr wrap="square" lIns="0" tIns="0" rIns="0" bIns="0" rtlCol="0" anchor="ctr">
+            <a:normAutofit/>
+          </a:bodyPr>
+          <a:lstStyle/>
+          <a:p>
+            <a:pPr algn="ctr" indent="0" marL="0">
+              <a:buNone/>
+            </a:pPr>
+            <a:r>
+              <a:rPr lang="en-US" sz="620" b="1" dirty="0">
+                <a:solidFill>
+                  <a:srgbClr val="147D74"/>
+                </a:solidFill>
+                <a:latin typeface="Aptos" pitchFamily="34" charset="0"/>
+                <a:ea typeface="Aptos" pitchFamily="34" charset="-122"/>
+                <a:cs typeface="Aptos" pitchFamily="34" charset="-120"/>
+              </a:rPr>
+              <a:t>WE LIVE HERE</a:t>
+            </a:r>
+            <a:endParaRPr lang="en-US" sz="620" dirty="0"/>
+          </a:p>
+        </p:txBody>
+      </p:sp>
+      <p:sp>
+        <p:nvSpPr>
+          <p:cNvPr id="17" name="Text 15"/>
+          <p:cNvSpPr/>
+          <p:nvPr/>
+        </p:nvSpPr>
+        <p:spPr>
+          <a:xfrm>
+            <a:off x="658368" y="2249424"/>
+            <a:ext cx="5074920" cy="256032"/>
+          </a:xfrm>
+          <a:prstGeom prst="rect">
+            <a:avLst/>
+          </a:prstGeom>
+          <a:noFill/>
+          <a:ln/>
+        </p:spPr>
+        <p:txBody>
+          <a:bodyPr wrap="square" lIns="0" tIns="0" rIns="0" bIns="0" rtlCol="0" anchor="t">
+            <a:normAutofit/>
+          </a:bodyPr>
+          <a:lstStyle/>
+          <a:p>
+            <a:pPr algn="l" indent="0" marL="0">
+              <a:buNone/>
+            </a:pPr>
+            <a:r>
+              <a:rPr lang="en-US" sz="940" b="1" dirty="0">
+                <a:solidFill>
+                  <a:srgbClr val="202729"/>
+                </a:solidFill>
+                <a:latin typeface="Aptos" pitchFamily="34" charset="0"/>
+                <a:ea typeface="Aptos" pitchFamily="34" charset="-122"/>
+                <a:cs typeface="Aptos" pitchFamily="34" charset="-120"/>
+              </a:rPr>
+              <a:t>NovaSteel: Fabric core, four AI capabilities, persona apps, human approval</a:t>
+            </a:r>
+            <a:endParaRPr lang="en-US" sz="940" dirty="0"/>
+          </a:p>
+        </p:txBody>
+      </p:sp>
+      <p:sp>
+        <p:nvSpPr>
+          <p:cNvPr id="18" name="Shape 16"/>
+          <p:cNvSpPr/>
+          <p:nvPr/>
+        </p:nvSpPr>
+        <p:spPr>
+          <a:xfrm>
+            <a:off x="457200" y="2724912"/>
+            <a:ext cx="5623560" cy="658368"/>
+          </a:xfrm>
+          <a:prstGeom prst="roundRect">
+            <a:avLst/>
+          </a:prstGeom>
+          <a:solidFill>
+            <a:srgbClr val="1F2426"/>
+          </a:solidFill>
+          <a:ln w="16510">
+            <a:solidFill>
+              <a:srgbClr val="B64A2D"/>
+            </a:solidFill>
+            <a:prstDash val="solid"/>
+          </a:ln>
+        </p:spPr>
+      </p:sp>
+      <p:sp>
+        <p:nvSpPr>
+          <p:cNvPr id="19" name="Text 17"/>
+          <p:cNvSpPr/>
+          <p:nvPr/>
+        </p:nvSpPr>
+        <p:spPr>
+          <a:xfrm>
+            <a:off x="658368" y="2834640"/>
+            <a:ext cx="5212080" cy="91440"/>
+          </a:xfrm>
+          <a:prstGeom prst="rect">
+            <a:avLst/>
+          </a:prstGeom>
+          <a:noFill/>
+          <a:ln/>
+        </p:spPr>
+        <p:txBody>
+          <a:bodyPr wrap="square" lIns="0" tIns="0" rIns="0" bIns="0" rtlCol="0" anchor="ctr">
+            <a:normAutofit/>
+          </a:bodyPr>
+          <a:lstStyle/>
+          <a:p>
+            <a:pPr algn="l" indent="0" marL="0">
+              <a:buNone/>
+            </a:pPr>
+            <a:r>
+              <a:rPr lang="en-US" sz="700" b="1" spc="110" kern="0" dirty="0">
+                <a:solidFill>
+                  <a:srgbClr val="E3A72F"/>
+                </a:solidFill>
+                <a:latin typeface="Aptos" pitchFamily="34" charset="0"/>
+                <a:ea typeface="Aptos" pitchFamily="34" charset="-122"/>
+                <a:cs typeface="Aptos" pitchFamily="34" charset="-120"/>
+              </a:rPr>
+              <a:t>OT / IT BOUNDARY  —  IEC 62443 ZONE CONDUIT</a:t>
+            </a:r>
+            <a:endParaRPr lang="en-US" sz="700" dirty="0"/>
+          </a:p>
+        </p:txBody>
+      </p:sp>
+      <p:sp>
+        <p:nvSpPr>
+          <p:cNvPr id="20" name="Shape 18"/>
+          <p:cNvSpPr/>
+          <p:nvPr/>
+        </p:nvSpPr>
+        <p:spPr>
+          <a:xfrm>
+            <a:off x="676656" y="3035808"/>
+            <a:ext cx="173736" cy="256032"/>
+          </a:xfrm>
+          <a:prstGeom prst="upArrow">
+            <a:avLst/>
+          </a:prstGeom>
+          <a:solidFill>
+            <a:srgbClr val="147D74"/>
+          </a:solidFill>
+          <a:ln w="6350">
+            <a:solidFill>
+              <a:srgbClr val="147D74"/>
+            </a:solidFill>
+            <a:prstDash val="solid"/>
+          </a:ln>
+        </p:spPr>
+      </p:sp>
+      <p:sp>
+        <p:nvSpPr>
+          <p:cNvPr id="21" name="Text 19"/>
+          <p:cNvSpPr/>
+          <p:nvPr/>
+        </p:nvSpPr>
+        <p:spPr>
+          <a:xfrm>
+            <a:off x="941832" y="3104388"/>
+            <a:ext cx="2286000" cy="91440"/>
+          </a:xfrm>
+          <a:prstGeom prst="rect">
+            <a:avLst/>
+          </a:prstGeom>
+          <a:noFill/>
+          <a:ln/>
+        </p:spPr>
+        <p:txBody>
+          <a:bodyPr wrap="square" lIns="0" tIns="0" rIns="0" bIns="0" rtlCol="0" anchor="ctr">
+            <a:normAutofit/>
+          </a:bodyPr>
+          <a:lstStyle/>
+          <a:p>
+            <a:pPr algn="l" indent="0" marL="0">
+              <a:buNone/>
+            </a:pPr>
+            <a:r>
+              <a:rPr lang="en-US" sz="720" b="1" dirty="0">
+                <a:solidFill>
+                  <a:srgbClr val="DDE4E1"/>
+                </a:solidFill>
+                <a:latin typeface="Aptos" pitchFamily="34" charset="0"/>
+                <a:ea typeface="Aptos" pitchFamily="34" charset="-122"/>
+                <a:cs typeface="Aptos" pitchFamily="34" charset="-120"/>
+              </a:rPr>
+              <a:t>TELEMETRY UP  ·  read-only historian / OPC UA tags</a:t>
+            </a:r>
+            <a:endParaRPr lang="en-US" sz="720" dirty="0"/>
+          </a:p>
+        </p:txBody>
+      </p:sp>
+      <p:sp>
+        <p:nvSpPr>
+          <p:cNvPr id="22" name="Shape 20"/>
+          <p:cNvSpPr/>
+          <p:nvPr/>
+        </p:nvSpPr>
+        <p:spPr>
+          <a:xfrm>
+            <a:off x="3346704" y="3035808"/>
+            <a:ext cx="173736" cy="256032"/>
+          </a:xfrm>
+          <a:prstGeom prst="downArrow">
+            <a:avLst/>
+          </a:prstGeom>
+          <a:solidFill>
+            <a:srgbClr val="B64A2D"/>
+          </a:solidFill>
+          <a:ln w="6350">
+            <a:solidFill>
+              <a:srgbClr val="B64A2D"/>
+            </a:solidFill>
+            <a:prstDash val="solid"/>
+          </a:ln>
+        </p:spPr>
+      </p:sp>
+      <p:sp>
+        <p:nvSpPr>
+          <p:cNvPr id="23" name="Text 21"/>
+          <p:cNvSpPr/>
+          <p:nvPr/>
+        </p:nvSpPr>
+        <p:spPr>
+          <a:xfrm>
+            <a:off x="3611880" y="3104388"/>
+            <a:ext cx="2286000" cy="91440"/>
+          </a:xfrm>
+          <a:prstGeom prst="rect">
+            <a:avLst/>
+          </a:prstGeom>
+          <a:noFill/>
+          <a:ln/>
+        </p:spPr>
+        <p:txBody>
+          <a:bodyPr wrap="square" lIns="0" tIns="0" rIns="0" bIns="0" rtlCol="0" anchor="ctr">
+            <a:normAutofit/>
+          </a:bodyPr>
+          <a:lstStyle/>
+          <a:p>
+            <a:pPr algn="l" indent="0" marL="0">
+              <a:buNone/>
+            </a:pPr>
+            <a:r>
+              <a:rPr lang="en-US" sz="720" b="1" dirty="0">
+                <a:solidFill>
+                  <a:srgbClr val="F1DDD4"/>
+                </a:solidFill>
+                <a:latin typeface="Aptos" pitchFamily="34" charset="0"/>
+                <a:ea typeface="Aptos" pitchFamily="34" charset="-122"/>
+                <a:cs typeface="Aptos" pitchFamily="34" charset="-120"/>
+              </a:rPr>
+              <a:t>NO COMMAND DOWN  ·  no setpoint, no PLC write</a:t>
+            </a:r>
+            <a:endParaRPr lang="en-US" sz="720" dirty="0"/>
+          </a:p>
+        </p:txBody>
+      </p:sp>
+      <p:sp>
+        <p:nvSpPr>
+          <p:cNvPr id="24" name="Shape 22"/>
+          <p:cNvSpPr/>
+          <p:nvPr/>
+        </p:nvSpPr>
+        <p:spPr>
+          <a:xfrm>
+            <a:off x="457200" y="3474720"/>
+            <a:ext cx="5623560" cy="1719072"/>
+          </a:xfrm>
+          <a:prstGeom prst="roundRect">
+            <a:avLst/>
+          </a:prstGeom>
+          <a:solidFill>
+            <a:srgbClr val="E5E9E6"/>
+          </a:solidFill>
+          <a:ln w="8890">
+            <a:solidFill>
+              <a:srgbClr val="AEB9BA"/>
+            </a:solidFill>
+            <a:prstDash val="solid"/>
+          </a:ln>
+        </p:spPr>
+      </p:sp>
+      <p:sp>
+        <p:nvSpPr>
+          <p:cNvPr id="25" name="Shape 23"/>
+          <p:cNvSpPr/>
+          <p:nvPr/>
+        </p:nvSpPr>
+        <p:spPr>
+          <a:xfrm>
+            <a:off x="457200" y="3474720"/>
+            <a:ext cx="77724" cy="1719072"/>
+          </a:xfrm>
+          <a:prstGeom prst="rect">
+            <a:avLst/>
+          </a:prstGeom>
+          <a:solidFill>
+            <a:srgbClr val="465057"/>
+          </a:solidFill>
+          <a:ln w="6350">
+            <a:solidFill>
+              <a:srgbClr val="465057"/>
+            </a:solidFill>
+            <a:prstDash val="solid"/>
+          </a:ln>
+        </p:spPr>
+      </p:sp>
+      <p:sp>
+        <p:nvSpPr>
+          <p:cNvPr id="26" name="Shape 24"/>
+          <p:cNvSpPr/>
+          <p:nvPr/>
+        </p:nvSpPr>
+        <p:spPr>
+          <a:xfrm>
+            <a:off x="658368" y="3584448"/>
+            <a:ext cx="5221224" cy="457200"/>
+          </a:xfrm>
+          <a:prstGeom prst="roundRect">
+            <a:avLst/>
+          </a:prstGeom>
+          <a:solidFill>
+            <a:srgbClr val="FFFFFF"/>
+          </a:solidFill>
+          <a:ln w="6350">
+            <a:solidFill>
+              <a:srgbClr val="DDE4E1"/>
+            </a:solidFill>
+            <a:prstDash val="solid"/>
+          </a:ln>
+        </p:spPr>
+      </p:sp>
+      <p:sp>
+        <p:nvSpPr>
+          <p:cNvPr id="27" name="Shape 25"/>
+          <p:cNvSpPr/>
+          <p:nvPr/>
+        </p:nvSpPr>
+        <p:spPr>
+          <a:xfrm>
+            <a:off x="777240" y="3703320"/>
+            <a:ext cx="384048" cy="219456"/>
+          </a:xfrm>
+          <a:prstGeom prst="roundRect">
+            <a:avLst/>
+          </a:prstGeom>
+          <a:solidFill>
+            <a:srgbClr val="465057"/>
+          </a:solidFill>
+          <a:ln w="5080">
+            <a:solidFill>
+              <a:srgbClr val="465057"/>
+            </a:solidFill>
+            <a:prstDash val="solid"/>
+          </a:ln>
+        </p:spPr>
+      </p:sp>
+      <p:sp>
+        <p:nvSpPr>
+          <p:cNvPr id="28" name="Text 26"/>
+          <p:cNvSpPr/>
+          <p:nvPr/>
+        </p:nvSpPr>
+        <p:spPr>
+          <a:xfrm>
+            <a:off x="822960" y="3781044"/>
+            <a:ext cx="292608" cy="82296"/>
+          </a:xfrm>
+          <a:prstGeom prst="rect">
+            <a:avLst/>
+          </a:prstGeom>
+          <a:noFill/>
+          <a:ln/>
+        </p:spPr>
+        <p:txBody>
+          <a:bodyPr wrap="square" lIns="0" tIns="0" rIns="0" bIns="0" rtlCol="0" anchor="ctr">
+            <a:normAutofit/>
+          </a:bodyPr>
+          <a:lstStyle/>
+          <a:p>
+            <a:pPr algn="ctr" indent="0" marL="0">
+              <a:buNone/>
+            </a:pPr>
+            <a:r>
+              <a:rPr lang="en-US" sz="700" b="1" dirty="0">
+                <a:solidFill>
+                  <a:srgbClr val="FFFFFF"/>
+                </a:solidFill>
+                <a:latin typeface="Aptos" pitchFamily="34" charset="0"/>
+                <a:ea typeface="Aptos" pitchFamily="34" charset="-122"/>
+                <a:cs typeface="Aptos" pitchFamily="34" charset="-120"/>
+              </a:rPr>
+              <a:t>L2</a:t>
+            </a:r>
+            <a:endParaRPr lang="en-US" sz="700" dirty="0"/>
+          </a:p>
+        </p:txBody>
+      </p:sp>
+      <p:sp>
+        <p:nvSpPr>
+          <p:cNvPr id="29" name="Text 27"/>
+          <p:cNvSpPr/>
+          <p:nvPr/>
+        </p:nvSpPr>
+        <p:spPr>
+          <a:xfrm>
+            <a:off x="1280160" y="3689604"/>
+            <a:ext cx="3337560" cy="109728"/>
+          </a:xfrm>
+          <a:prstGeom prst="rect">
+            <a:avLst/>
+          </a:prstGeom>
+          <a:noFill/>
+          <a:ln/>
+        </p:spPr>
+        <p:txBody>
+          <a:bodyPr wrap="square" lIns="0" tIns="0" rIns="0" bIns="0" rtlCol="0" anchor="ctr">
+            <a:normAutofit/>
+          </a:bodyPr>
+          <a:lstStyle/>
+          <a:p>
+            <a:pPr algn="l" indent="0" marL="0">
+              <a:buNone/>
+            </a:pPr>
+            <a:r>
+              <a:rPr lang="en-US" sz="870" b="1" dirty="0">
+                <a:solidFill>
+                  <a:srgbClr val="202729"/>
+                </a:solidFill>
+                <a:latin typeface="Aptos" pitchFamily="34" charset="0"/>
+                <a:ea typeface="Aptos" pitchFamily="34" charset="-122"/>
+                <a:cs typeface="Aptos" pitchFamily="34" charset="-120"/>
+              </a:rPr>
+              <a:t>Supervisory control — SCADA / HMI</a:t>
+            </a:r>
+            <a:endParaRPr lang="en-US" sz="870" dirty="0"/>
+          </a:p>
+        </p:txBody>
+      </p:sp>
+      <p:sp>
+        <p:nvSpPr>
+          <p:cNvPr id="30" name="Text 28"/>
+          <p:cNvSpPr/>
+          <p:nvPr/>
+        </p:nvSpPr>
+        <p:spPr>
+          <a:xfrm>
+            <a:off x="1280160" y="3867912"/>
+            <a:ext cx="3337560" cy="91440"/>
+          </a:xfrm>
+          <a:prstGeom prst="rect">
+            <a:avLst/>
+          </a:prstGeom>
+          <a:noFill/>
+          <a:ln/>
+        </p:spPr>
+        <p:txBody>
+          <a:bodyPr wrap="square" lIns="0" tIns="0" rIns="0" bIns="0" rtlCol="0" anchor="ctr">
+            <a:normAutofit/>
+          </a:bodyPr>
+          <a:lstStyle/>
+          <a:p>
+            <a:pPr algn="l" indent="0" marL="0">
+              <a:buNone/>
+            </a:pPr>
+            <a:r>
+              <a:rPr lang="en-US" sz="680" dirty="0">
+                <a:solidFill>
+                  <a:srgbClr val="687373"/>
+                </a:solidFill>
+                <a:latin typeface="Aptos" pitchFamily="34" charset="0"/>
+                <a:ea typeface="Aptos" pitchFamily="34" charset="-122"/>
+                <a:cs typeface="Aptos" pitchFamily="34" charset="-120"/>
+              </a:rPr>
+              <a:t>operator authority stays on the floor</a:t>
+            </a:r>
+            <a:endParaRPr lang="en-US" sz="680" dirty="0"/>
+          </a:p>
+        </p:txBody>
+      </p:sp>
+      <p:sp>
+        <p:nvSpPr>
+          <p:cNvPr id="31" name="Shape 29"/>
+          <p:cNvSpPr/>
+          <p:nvPr/>
+        </p:nvSpPr>
+        <p:spPr>
+          <a:xfrm>
+            <a:off x="4773168" y="3712464"/>
+            <a:ext cx="969264" cy="201168"/>
+          </a:xfrm>
+          <a:prstGeom prst="roundRect">
+            <a:avLst/>
+          </a:prstGeom>
+          <a:solidFill>
+            <a:srgbClr val="F1DDD4"/>
+          </a:solidFill>
+          <a:ln w="6350">
+            <a:solidFill>
+              <a:srgbClr val="B64A2D"/>
+            </a:solidFill>
+            <a:prstDash val="solid"/>
+          </a:ln>
+        </p:spPr>
+      </p:sp>
+      <p:sp>
+        <p:nvSpPr>
+          <p:cNvPr id="32" name="Text 30"/>
+          <p:cNvSpPr/>
+          <p:nvPr/>
+        </p:nvSpPr>
+        <p:spPr>
+          <a:xfrm>
+            <a:off x="4818888" y="3787445"/>
+            <a:ext cx="877824" cy="73152"/>
+          </a:xfrm>
+          <a:prstGeom prst="rect">
+            <a:avLst/>
+          </a:prstGeom>
+          <a:noFill/>
+          <a:ln/>
+        </p:spPr>
+        <p:txBody>
+          <a:bodyPr wrap="square" lIns="0" tIns="0" rIns="0" bIns="0" rtlCol="0" anchor="ctr">
+            <a:normAutofit/>
+          </a:bodyPr>
+          <a:lstStyle/>
+          <a:p>
+            <a:pPr algn="ctr" indent="0" marL="0">
+              <a:buNone/>
+            </a:pPr>
+            <a:r>
+              <a:rPr lang="en-US" sz="630" b="1" dirty="0">
+                <a:solidFill>
+                  <a:srgbClr val="7A261C"/>
+                </a:solidFill>
+                <a:latin typeface="Aptos" pitchFamily="34" charset="0"/>
+                <a:ea typeface="Aptos" pitchFamily="34" charset="-122"/>
+                <a:cs typeface="Aptos" pitchFamily="34" charset="-120"/>
+              </a:rPr>
+              <a:t>NO WRITE</a:t>
+            </a:r>
+            <a:endParaRPr lang="en-US" sz="630" dirty="0"/>
+          </a:p>
+        </p:txBody>
+      </p:sp>
+      <p:sp>
+        <p:nvSpPr>
+          <p:cNvPr id="33" name="Shape 31"/>
+          <p:cNvSpPr/>
+          <p:nvPr/>
+        </p:nvSpPr>
+        <p:spPr>
+          <a:xfrm>
+            <a:off x="658368" y="4096512"/>
+            <a:ext cx="5221224" cy="457200"/>
+          </a:xfrm>
+          <a:prstGeom prst="roundRect">
+            <a:avLst/>
+          </a:prstGeom>
+          <a:solidFill>
+            <a:srgbClr val="FFFFFF"/>
+          </a:solidFill>
+          <a:ln w="6350">
+            <a:solidFill>
+              <a:srgbClr val="DDE4E1"/>
+            </a:solidFill>
+            <a:prstDash val="solid"/>
+          </a:ln>
+        </p:spPr>
+      </p:sp>
+      <p:sp>
+        <p:nvSpPr>
+          <p:cNvPr id="34" name="Shape 32"/>
+          <p:cNvSpPr/>
+          <p:nvPr/>
+        </p:nvSpPr>
+        <p:spPr>
+          <a:xfrm>
+            <a:off x="777240" y="4215384"/>
+            <a:ext cx="384048" cy="219456"/>
+          </a:xfrm>
+          <a:prstGeom prst="roundRect">
+            <a:avLst/>
+          </a:prstGeom>
+          <a:solidFill>
+            <a:srgbClr val="465057"/>
+          </a:solidFill>
+          <a:ln w="5080">
+            <a:solidFill>
+              <a:srgbClr val="465057"/>
+            </a:solidFill>
+            <a:prstDash val="solid"/>
+          </a:ln>
+        </p:spPr>
+      </p:sp>
+      <p:sp>
+        <p:nvSpPr>
+          <p:cNvPr id="35" name="Text 33"/>
+          <p:cNvSpPr/>
+          <p:nvPr/>
+        </p:nvSpPr>
+        <p:spPr>
+          <a:xfrm>
+            <a:off x="822960" y="4293108"/>
+            <a:ext cx="292608" cy="82296"/>
+          </a:xfrm>
+          <a:prstGeom prst="rect">
+            <a:avLst/>
+          </a:prstGeom>
+          <a:noFill/>
+          <a:ln/>
+        </p:spPr>
+        <p:txBody>
+          <a:bodyPr wrap="square" lIns="0" tIns="0" rIns="0" bIns="0" rtlCol="0" anchor="ctr">
+            <a:normAutofit/>
+          </a:bodyPr>
+          <a:lstStyle/>
+          <a:p>
+            <a:pPr algn="ctr" indent="0" marL="0">
+              <a:buNone/>
+            </a:pPr>
+            <a:r>
+              <a:rPr lang="en-US" sz="700" b="1" dirty="0">
+                <a:solidFill>
+                  <a:srgbClr val="FFFFFF"/>
+                </a:solidFill>
+                <a:latin typeface="Aptos" pitchFamily="34" charset="0"/>
+                <a:ea typeface="Aptos" pitchFamily="34" charset="-122"/>
+                <a:cs typeface="Aptos" pitchFamily="34" charset="-120"/>
+              </a:rPr>
+              <a:t>L1</a:t>
+            </a:r>
+            <a:endParaRPr lang="en-US" sz="700" dirty="0"/>
+          </a:p>
+        </p:txBody>
+      </p:sp>
+      <p:sp>
+        <p:nvSpPr>
+          <p:cNvPr id="36" name="Text 34"/>
+          <p:cNvSpPr/>
+          <p:nvPr/>
+        </p:nvSpPr>
+        <p:spPr>
+          <a:xfrm>
+            <a:off x="1280160" y="4201668"/>
+            <a:ext cx="3337560" cy="109728"/>
+          </a:xfrm>
+          <a:prstGeom prst="rect">
+            <a:avLst/>
+          </a:prstGeom>
+          <a:noFill/>
+          <a:ln/>
+        </p:spPr>
+        <p:txBody>
+          <a:bodyPr wrap="square" lIns="0" tIns="0" rIns="0" bIns="0" rtlCol="0" anchor="ctr">
+            <a:normAutofit/>
+          </a:bodyPr>
+          <a:lstStyle/>
+          <a:p>
+            <a:pPr algn="l" indent="0" marL="0">
+              <a:buNone/>
+            </a:pPr>
+            <a:r>
+              <a:rPr lang="en-US" sz="870" b="1" dirty="0">
+                <a:solidFill>
+                  <a:srgbClr val="202729"/>
+                </a:solidFill>
+                <a:latin typeface="Aptos" pitchFamily="34" charset="0"/>
+                <a:ea typeface="Aptos" pitchFamily="34" charset="-122"/>
+                <a:cs typeface="Aptos" pitchFamily="34" charset="-120"/>
+              </a:rPr>
+              <a:t>Regulatory control — PLC / DCS setpoints</a:t>
+            </a:r>
+            <a:endParaRPr lang="en-US" sz="870" dirty="0"/>
+          </a:p>
+        </p:txBody>
+      </p:sp>
+      <p:sp>
+        <p:nvSpPr>
+          <p:cNvPr id="37" name="Text 35"/>
+          <p:cNvSpPr/>
+          <p:nvPr/>
+        </p:nvSpPr>
+        <p:spPr>
+          <a:xfrm>
+            <a:off x="1280160" y="4379976"/>
+            <a:ext cx="3337560" cy="91440"/>
+          </a:xfrm>
+          <a:prstGeom prst="rect">
+            <a:avLst/>
+          </a:prstGeom>
+          <a:noFill/>
+          <a:ln/>
+        </p:spPr>
+        <p:txBody>
+          <a:bodyPr wrap="square" lIns="0" tIns="0" rIns="0" bIns="0" rtlCol="0" anchor="ctr">
+            <a:normAutofit/>
+          </a:bodyPr>
+          <a:lstStyle/>
+          <a:p>
+            <a:pPr algn="l" indent="0" marL="0">
+              <a:buNone/>
+            </a:pPr>
+            <a:r>
+              <a:rPr lang="en-US" sz="680" dirty="0">
+                <a:solidFill>
+                  <a:srgbClr val="687373"/>
+                </a:solidFill>
+                <a:latin typeface="Aptos" pitchFamily="34" charset="0"/>
+                <a:ea typeface="Aptos" pitchFamily="34" charset="-122"/>
+                <a:cs typeface="Aptos" pitchFamily="34" charset="-120"/>
+              </a:rPr>
+              <a:t>vendor-certified control logic</a:t>
+            </a:r>
+            <a:endParaRPr lang="en-US" sz="680" dirty="0"/>
+          </a:p>
+        </p:txBody>
+      </p:sp>
+      <p:sp>
+        <p:nvSpPr>
+          <p:cNvPr id="38" name="Shape 36"/>
+          <p:cNvSpPr/>
+          <p:nvPr/>
+        </p:nvSpPr>
+        <p:spPr>
+          <a:xfrm>
+            <a:off x="4773168" y="4224528"/>
+            <a:ext cx="969264" cy="201168"/>
+          </a:xfrm>
+          <a:prstGeom prst="roundRect">
+            <a:avLst/>
+          </a:prstGeom>
+          <a:solidFill>
+            <a:srgbClr val="F1DDD4"/>
+          </a:solidFill>
+          <a:ln w="6350">
+            <a:solidFill>
+              <a:srgbClr val="B64A2D"/>
+            </a:solidFill>
+            <a:prstDash val="solid"/>
+          </a:ln>
+        </p:spPr>
+      </p:sp>
+      <p:sp>
+        <p:nvSpPr>
+          <p:cNvPr id="39" name="Text 37"/>
+          <p:cNvSpPr/>
+          <p:nvPr/>
+        </p:nvSpPr>
+        <p:spPr>
+          <a:xfrm>
+            <a:off x="4818888" y="4299509"/>
+            <a:ext cx="877824" cy="73152"/>
+          </a:xfrm>
+          <a:prstGeom prst="rect">
+            <a:avLst/>
+          </a:prstGeom>
+          <a:noFill/>
+          <a:ln/>
+        </p:spPr>
+        <p:txBody>
+          <a:bodyPr wrap="square" lIns="0" tIns="0" rIns="0" bIns="0" rtlCol="0" anchor="ctr">
+            <a:normAutofit/>
+          </a:bodyPr>
+          <a:lstStyle/>
+          <a:p>
+            <a:pPr algn="ctr" indent="0" marL="0">
+              <a:buNone/>
+            </a:pPr>
+            <a:r>
+              <a:rPr lang="en-US" sz="630" b="1" dirty="0">
+                <a:solidFill>
+                  <a:srgbClr val="7A261C"/>
+                </a:solidFill>
+                <a:latin typeface="Aptos" pitchFamily="34" charset="0"/>
+                <a:ea typeface="Aptos" pitchFamily="34" charset="-122"/>
+                <a:cs typeface="Aptos" pitchFamily="34" charset="-120"/>
+              </a:rPr>
+              <a:t>NO WRITE</a:t>
+            </a:r>
+            <a:endParaRPr lang="en-US" sz="630" dirty="0"/>
+          </a:p>
+        </p:txBody>
+      </p:sp>
+      <p:sp>
+        <p:nvSpPr>
+          <p:cNvPr id="40" name="Shape 38"/>
+          <p:cNvSpPr/>
+          <p:nvPr/>
+        </p:nvSpPr>
+        <p:spPr>
+          <a:xfrm>
+            <a:off x="658368" y="4608576"/>
+            <a:ext cx="5221224" cy="457200"/>
+          </a:xfrm>
+          <a:prstGeom prst="roundRect">
+            <a:avLst/>
+          </a:prstGeom>
+          <a:solidFill>
+            <a:srgbClr val="FFFFFF"/>
+          </a:solidFill>
+          <a:ln w="6350">
+            <a:solidFill>
+              <a:srgbClr val="DDE4E1"/>
+            </a:solidFill>
+            <a:prstDash val="solid"/>
+          </a:ln>
+        </p:spPr>
+      </p:sp>
+      <p:sp>
+        <p:nvSpPr>
+          <p:cNvPr id="41" name="Shape 39"/>
+          <p:cNvSpPr/>
+          <p:nvPr/>
+        </p:nvSpPr>
+        <p:spPr>
+          <a:xfrm>
+            <a:off x="777240" y="4727448"/>
+            <a:ext cx="384048" cy="219456"/>
+          </a:xfrm>
+          <a:prstGeom prst="roundRect">
+            <a:avLst/>
+          </a:prstGeom>
+          <a:solidFill>
+            <a:srgbClr val="465057"/>
+          </a:solidFill>
+          <a:ln w="5080">
+            <a:solidFill>
+              <a:srgbClr val="465057"/>
+            </a:solidFill>
+            <a:prstDash val="solid"/>
+          </a:ln>
+        </p:spPr>
+      </p:sp>
+      <p:sp>
+        <p:nvSpPr>
+          <p:cNvPr id="42" name="Text 40"/>
+          <p:cNvSpPr/>
+          <p:nvPr/>
+        </p:nvSpPr>
+        <p:spPr>
+          <a:xfrm>
+            <a:off x="822960" y="4805172"/>
+            <a:ext cx="292608" cy="82296"/>
+          </a:xfrm>
+          <a:prstGeom prst="rect">
+            <a:avLst/>
+          </a:prstGeom>
+          <a:noFill/>
+          <a:ln/>
+        </p:spPr>
+        <p:txBody>
+          <a:bodyPr wrap="square" lIns="0" tIns="0" rIns="0" bIns="0" rtlCol="0" anchor="ctr">
+            <a:normAutofit/>
+          </a:bodyPr>
+          <a:lstStyle/>
+          <a:p>
+            <a:pPr algn="ctr" indent="0" marL="0">
+              <a:buNone/>
+            </a:pPr>
+            <a:r>
+              <a:rPr lang="en-US" sz="700" b="1" dirty="0">
+                <a:solidFill>
+                  <a:srgbClr val="FFFFFF"/>
+                </a:solidFill>
+                <a:latin typeface="Aptos" pitchFamily="34" charset="0"/>
+                <a:ea typeface="Aptos" pitchFamily="34" charset="-122"/>
+                <a:cs typeface="Aptos" pitchFamily="34" charset="-120"/>
+              </a:rPr>
+              <a:t>L0</a:t>
+            </a:r>
+            <a:endParaRPr lang="en-US" sz="700" dirty="0"/>
+          </a:p>
+        </p:txBody>
+      </p:sp>
+      <p:sp>
+        <p:nvSpPr>
+          <p:cNvPr id="43" name="Text 41"/>
+          <p:cNvSpPr/>
+          <p:nvPr/>
+        </p:nvSpPr>
+        <p:spPr>
+          <a:xfrm>
+            <a:off x="1280160" y="4713732"/>
+            <a:ext cx="3337560" cy="109728"/>
+          </a:xfrm>
+          <a:prstGeom prst="rect">
+            <a:avLst/>
+          </a:prstGeom>
+          <a:noFill/>
+          <a:ln/>
+        </p:spPr>
+        <p:txBody>
+          <a:bodyPr wrap="square" lIns="0" tIns="0" rIns="0" bIns="0" rtlCol="0" anchor="ctr">
+            <a:normAutofit/>
+          </a:bodyPr>
+          <a:lstStyle/>
+          <a:p>
+            <a:pPr algn="l" indent="0" marL="0">
+              <a:buNone/>
+            </a:pPr>
+            <a:r>
+              <a:rPr lang="en-US" sz="870" b="1" dirty="0">
+                <a:solidFill>
+                  <a:srgbClr val="202729"/>
+                </a:solidFill>
+                <a:latin typeface="Aptos" pitchFamily="34" charset="0"/>
+                <a:ea typeface="Aptos" pitchFamily="34" charset="-122"/>
+                <a:cs typeface="Aptos" pitchFamily="34" charset="-120"/>
+              </a:rPr>
+              <a:t>Sensors, actuators, SIS interlocks</a:t>
+            </a:r>
+            <a:endParaRPr lang="en-US" sz="870" dirty="0"/>
+          </a:p>
+        </p:txBody>
+      </p:sp>
+      <p:sp>
+        <p:nvSpPr>
+          <p:cNvPr id="44" name="Text 42"/>
+          <p:cNvSpPr/>
+          <p:nvPr/>
+        </p:nvSpPr>
+        <p:spPr>
+          <a:xfrm>
+            <a:off x="1280160" y="4892040"/>
+            <a:ext cx="3337560" cy="91440"/>
+          </a:xfrm>
+          <a:prstGeom prst="rect">
+            <a:avLst/>
+          </a:prstGeom>
+          <a:noFill/>
+          <a:ln/>
+        </p:spPr>
+        <p:txBody>
+          <a:bodyPr wrap="square" lIns="0" tIns="0" rIns="0" bIns="0" rtlCol="0" anchor="ctr">
+            <a:normAutofit/>
+          </a:bodyPr>
+          <a:lstStyle/>
+          <a:p>
+            <a:pPr algn="l" indent="0" marL="0">
+              <a:buNone/>
+            </a:pPr>
+            <a:r>
+              <a:rPr lang="en-US" sz="680" dirty="0">
+                <a:solidFill>
+                  <a:srgbClr val="687373"/>
+                </a:solidFill>
+                <a:latin typeface="Aptos" pitchFamily="34" charset="0"/>
+                <a:ea typeface="Aptos" pitchFamily="34" charset="-122"/>
+                <a:cs typeface="Aptos" pitchFamily="34" charset="-120"/>
+              </a:rPr>
+              <a:t>IEC 61511 safety-instrumented functions</a:t>
+            </a:r>
+            <a:endParaRPr lang="en-US" sz="680" dirty="0"/>
+          </a:p>
+        </p:txBody>
+      </p:sp>
+      <p:sp>
+        <p:nvSpPr>
+          <p:cNvPr id="45" name="Shape 43"/>
+          <p:cNvSpPr/>
+          <p:nvPr/>
+        </p:nvSpPr>
+        <p:spPr>
+          <a:xfrm>
+            <a:off x="4773168" y="4736592"/>
+            <a:ext cx="969264" cy="201168"/>
+          </a:xfrm>
+          <a:prstGeom prst="roundRect">
+            <a:avLst/>
+          </a:prstGeom>
+          <a:solidFill>
+            <a:srgbClr val="F1DDD4"/>
+          </a:solidFill>
+          <a:ln w="6350">
+            <a:solidFill>
+              <a:srgbClr val="B64A2D"/>
+            </a:solidFill>
+            <a:prstDash val="solid"/>
+          </a:ln>
+        </p:spPr>
+      </p:sp>
+      <p:sp>
+        <p:nvSpPr>
+          <p:cNvPr id="46" name="Text 44"/>
+          <p:cNvSpPr/>
+          <p:nvPr/>
+        </p:nvSpPr>
+        <p:spPr>
+          <a:xfrm>
+            <a:off x="4818888" y="4811573"/>
+            <a:ext cx="877824" cy="73152"/>
+          </a:xfrm>
+          <a:prstGeom prst="rect">
+            <a:avLst/>
+          </a:prstGeom>
+          <a:noFill/>
+          <a:ln/>
+        </p:spPr>
+        <p:txBody>
+          <a:bodyPr wrap="square" lIns="0" tIns="0" rIns="0" bIns="0" rtlCol="0" anchor="ctr">
+            <a:normAutofit/>
+          </a:bodyPr>
+          <a:lstStyle/>
+          <a:p>
+            <a:pPr algn="ctr" indent="0" marL="0">
+              <a:buNone/>
+            </a:pPr>
+            <a:r>
+              <a:rPr lang="en-US" sz="630" b="1" dirty="0">
+                <a:solidFill>
+                  <a:srgbClr val="7A261C"/>
+                </a:solidFill>
+                <a:latin typeface="Aptos" pitchFamily="34" charset="0"/>
+                <a:ea typeface="Aptos" pitchFamily="34" charset="-122"/>
+                <a:cs typeface="Aptos" pitchFamily="34" charset="-120"/>
+              </a:rPr>
+              <a:t>NO WRITE</a:t>
+            </a:r>
+            <a:endParaRPr lang="en-US" sz="630" dirty="0"/>
+          </a:p>
+        </p:txBody>
+      </p:sp>
+      <p:sp>
+        <p:nvSpPr>
+          <p:cNvPr id="47" name="Text 45"/>
+          <p:cNvSpPr/>
+          <p:nvPr/>
+        </p:nvSpPr>
+        <p:spPr>
+          <a:xfrm>
+            <a:off x="6446520" y="1627632"/>
+            <a:ext cx="4937760" cy="146304"/>
+          </a:xfrm>
+          <a:prstGeom prst="rect">
+            <a:avLst/>
+          </a:prstGeom>
+          <a:noFill/>
+          <a:ln/>
+        </p:spPr>
+        <p:txBody>
+          <a:bodyPr wrap="square" lIns="0" tIns="0" rIns="0" bIns="0" rtlCol="0" anchor="ctr">
+            <a:normAutofit/>
+          </a:bodyPr>
+          <a:lstStyle/>
+          <a:p>
+            <a:pPr algn="l" indent="0" marL="0">
+              <a:buNone/>
+            </a:pPr>
+            <a:r>
+              <a:rPr lang="en-US" sz="720" b="1" spc="120" kern="0" dirty="0">
+                <a:solidFill>
+                  <a:srgbClr val="687373"/>
+                </a:solidFill>
+                <a:latin typeface="Aptos" pitchFamily="34" charset="0"/>
+                <a:ea typeface="Aptos" pitchFamily="34" charset="-122"/>
+                <a:cs typeface="Aptos" pitchFamily="34" charset="-120"/>
+              </a:rPr>
+              <a:t>NOT READ-ONLY — THE PLATFORM WRITES DECISIONS</a:t>
+            </a:r>
+            <a:endParaRPr lang="en-US" sz="720" dirty="0"/>
+          </a:p>
+        </p:txBody>
+      </p:sp>
+      <p:sp>
+        <p:nvSpPr>
+          <p:cNvPr id="48" name="Shape 46"/>
+          <p:cNvSpPr/>
+          <p:nvPr/>
+        </p:nvSpPr>
+        <p:spPr>
+          <a:xfrm>
+            <a:off x="6446520" y="1819656"/>
+            <a:ext cx="5285232" cy="621792"/>
+          </a:xfrm>
+          <a:prstGeom prst="roundRect">
+            <a:avLst/>
+          </a:prstGeom>
+          <a:solidFill>
+            <a:srgbClr val="FFFFFF"/>
+          </a:solidFill>
+          <a:ln w="8890">
+            <a:solidFill>
+              <a:srgbClr val="DDE4E1"/>
+            </a:solidFill>
+            <a:prstDash val="solid"/>
+          </a:ln>
+        </p:spPr>
+      </p:sp>
+      <p:sp>
+        <p:nvSpPr>
+          <p:cNvPr id="49" name="Shape 47"/>
+          <p:cNvSpPr/>
+          <p:nvPr/>
+        </p:nvSpPr>
+        <p:spPr>
+          <a:xfrm>
+            <a:off x="6446520" y="1819656"/>
+            <a:ext cx="77724" cy="621792"/>
+          </a:xfrm>
+          <a:prstGeom prst="rect">
+            <a:avLst/>
+          </a:prstGeom>
+          <a:solidFill>
+            <a:srgbClr val="147D74"/>
+          </a:solidFill>
+          <a:ln w="6350">
+            <a:solidFill>
+              <a:srgbClr val="147D74"/>
+            </a:solidFill>
+            <a:prstDash val="solid"/>
+          </a:ln>
+        </p:spPr>
+      </p:sp>
+      <p:sp>
+        <p:nvSpPr>
+          <p:cNvPr id="50" name="Shape 48"/>
+          <p:cNvSpPr/>
+          <p:nvPr/>
+        </p:nvSpPr>
+        <p:spPr>
+          <a:xfrm>
+            <a:off x="6656832" y="2011680"/>
+            <a:ext cx="237744" cy="237744"/>
+          </a:xfrm>
+          <a:prstGeom prst="ellipse">
+            <a:avLst/>
+          </a:prstGeom>
+          <a:solidFill>
+            <a:srgbClr val="147D74"/>
+          </a:solidFill>
+          <a:ln w="6350">
+            <a:solidFill>
+              <a:srgbClr val="147D74"/>
+            </a:solidFill>
+            <a:prstDash val="solid"/>
+          </a:ln>
+        </p:spPr>
+      </p:sp>
+      <p:sp>
+        <p:nvSpPr>
+          <p:cNvPr id="51" name="Text 49"/>
+          <p:cNvSpPr/>
+          <p:nvPr/>
+        </p:nvSpPr>
+        <p:spPr>
+          <a:xfrm>
+            <a:off x="6656832" y="2098548"/>
+            <a:ext cx="237744" cy="73152"/>
+          </a:xfrm>
+          <a:prstGeom prst="rect">
+            <a:avLst/>
+          </a:prstGeom>
+          <a:noFill/>
+          <a:ln/>
+        </p:spPr>
+        <p:txBody>
+          <a:bodyPr wrap="square" lIns="0" tIns="0" rIns="0" bIns="0" rtlCol="0" anchor="ctr">
+            <a:normAutofit/>
+          </a:bodyPr>
+          <a:lstStyle/>
+          <a:p>
+            <a:pPr algn="ctr" indent="0" marL="0">
+              <a:buNone/>
+            </a:pPr>
+            <a:r>
+              <a:rPr lang="en-US" sz="740" b="1" dirty="0">
+                <a:solidFill>
+                  <a:srgbClr val="FFFFFF"/>
+                </a:solidFill>
+                <a:latin typeface="Aptos" pitchFamily="34" charset="0"/>
+                <a:ea typeface="Aptos" pitchFamily="34" charset="-122"/>
+                <a:cs typeface="Aptos" pitchFamily="34" charset="-120"/>
+              </a:rPr>
+              <a:t>✓</a:t>
+            </a:r>
+            <a:endParaRPr lang="en-US" sz="740" dirty="0"/>
+          </a:p>
+        </p:txBody>
+      </p:sp>
+      <p:sp>
+        <p:nvSpPr>
+          <p:cNvPr id="52" name="Text 50"/>
+          <p:cNvSpPr/>
+          <p:nvPr/>
+        </p:nvSpPr>
+        <p:spPr>
+          <a:xfrm>
+            <a:off x="7022592" y="1938528"/>
+            <a:ext cx="4480560" cy="118872"/>
+          </a:xfrm>
+          <a:prstGeom prst="rect">
+            <a:avLst/>
+          </a:prstGeom>
+          <a:noFill/>
+          <a:ln/>
+        </p:spPr>
+        <p:txBody>
+          <a:bodyPr wrap="square" lIns="0" tIns="0" rIns="0" bIns="0" rtlCol="0" anchor="ctr">
+            <a:normAutofit/>
+          </a:bodyPr>
+          <a:lstStyle/>
+          <a:p>
+            <a:pPr algn="l" indent="0" marL="0">
+              <a:buNone/>
+            </a:pPr>
+            <a:r>
+              <a:rPr lang="en-US" sz="920" b="1" dirty="0">
+                <a:solidFill>
+                  <a:srgbClr val="202729"/>
+                </a:solidFill>
+                <a:latin typeface="Aptos" pitchFamily="34" charset="0"/>
+                <a:ea typeface="Aptos" pitchFamily="34" charset="-122"/>
+                <a:cs typeface="Aptos" pitchFamily="34" charset="-120"/>
+              </a:rPr>
+              <a:t>Energy dispatch decision</a:t>
+            </a:r>
+            <a:endParaRPr lang="en-US" sz="920" dirty="0"/>
+          </a:p>
+        </p:txBody>
+      </p:sp>
+      <p:sp>
+        <p:nvSpPr>
+          <p:cNvPr id="53" name="Text 51"/>
+          <p:cNvSpPr/>
+          <p:nvPr/>
+        </p:nvSpPr>
+        <p:spPr>
+          <a:xfrm>
+            <a:off x="7022592" y="2185416"/>
+            <a:ext cx="4480560" cy="100584"/>
+          </a:xfrm>
+          <a:prstGeom prst="rect">
+            <a:avLst/>
+          </a:prstGeom>
+          <a:noFill/>
+          <a:ln/>
+        </p:spPr>
+        <p:txBody>
+          <a:bodyPr wrap="square" lIns="0" tIns="0" rIns="0" bIns="0" rtlCol="0" anchor="ctr">
+            <a:normAutofit/>
+          </a:bodyPr>
+          <a:lstStyle/>
+          <a:p>
+            <a:pPr algn="l" indent="0" marL="0">
+              <a:buNone/>
+            </a:pPr>
+            <a:r>
+              <a:rPr lang="en-US" sz="710" dirty="0">
+                <a:solidFill>
+                  <a:srgbClr val="687373"/>
+                </a:solidFill>
+                <a:latin typeface="Consolas" pitchFamily="34" charset="0"/>
+                <a:ea typeface="Consolas" pitchFamily="34" charset="-122"/>
+                <a:cs typeface="Consolas" pitchFamily="34" charset="-120"/>
+              </a:rPr>
+              <a:t>POST /v1/energy/recommendations/{id}:approve</a:t>
+            </a:r>
+            <a:endParaRPr lang="en-US" sz="710" dirty="0"/>
+          </a:p>
+        </p:txBody>
+      </p:sp>
+      <p:sp>
+        <p:nvSpPr>
+          <p:cNvPr id="54" name="Shape 52"/>
+          <p:cNvSpPr/>
+          <p:nvPr/>
+        </p:nvSpPr>
+        <p:spPr>
+          <a:xfrm>
+            <a:off x="6446520" y="2542032"/>
+            <a:ext cx="5285232" cy="621792"/>
+          </a:xfrm>
+          <a:prstGeom prst="roundRect">
+            <a:avLst/>
+          </a:prstGeom>
+          <a:solidFill>
+            <a:srgbClr val="FFFFFF"/>
+          </a:solidFill>
+          <a:ln w="8890">
+            <a:solidFill>
+              <a:srgbClr val="DDE4E1"/>
+            </a:solidFill>
+            <a:prstDash val="solid"/>
+          </a:ln>
+        </p:spPr>
+      </p:sp>
+      <p:sp>
+        <p:nvSpPr>
+          <p:cNvPr id="55" name="Shape 53"/>
+          <p:cNvSpPr/>
+          <p:nvPr/>
+        </p:nvSpPr>
+        <p:spPr>
+          <a:xfrm>
+            <a:off x="6446520" y="2542032"/>
+            <a:ext cx="77724" cy="621792"/>
+          </a:xfrm>
+          <a:prstGeom prst="rect">
+            <a:avLst/>
+          </a:prstGeom>
+          <a:solidFill>
+            <a:srgbClr val="E3A72F"/>
+          </a:solidFill>
+          <a:ln w="6350">
+            <a:solidFill>
+              <a:srgbClr val="E3A72F"/>
+            </a:solidFill>
+            <a:prstDash val="solid"/>
+          </a:ln>
+        </p:spPr>
+      </p:sp>
+      <p:sp>
+        <p:nvSpPr>
+          <p:cNvPr id="56" name="Shape 54"/>
+          <p:cNvSpPr/>
+          <p:nvPr/>
+        </p:nvSpPr>
+        <p:spPr>
+          <a:xfrm>
+            <a:off x="6656832" y="2734056"/>
+            <a:ext cx="237744" cy="237744"/>
+          </a:xfrm>
+          <a:prstGeom prst="ellipse">
+            <a:avLst/>
+          </a:prstGeom>
+          <a:solidFill>
+            <a:srgbClr val="E3A72F"/>
+          </a:solidFill>
+          <a:ln w="6350">
+            <a:solidFill>
+              <a:srgbClr val="E3A72F"/>
+            </a:solidFill>
+            <a:prstDash val="solid"/>
+          </a:ln>
+        </p:spPr>
+      </p:sp>
+      <p:sp>
+        <p:nvSpPr>
+          <p:cNvPr id="57" name="Text 55"/>
+          <p:cNvSpPr/>
+          <p:nvPr/>
+        </p:nvSpPr>
+        <p:spPr>
+          <a:xfrm>
+            <a:off x="6656832" y="2820924"/>
+            <a:ext cx="237744" cy="73152"/>
+          </a:xfrm>
+          <a:prstGeom prst="rect">
+            <a:avLst/>
+          </a:prstGeom>
+          <a:noFill/>
+          <a:ln/>
+        </p:spPr>
+        <p:txBody>
+          <a:bodyPr wrap="square" lIns="0" tIns="0" rIns="0" bIns="0" rtlCol="0" anchor="ctr">
+            <a:normAutofit/>
+          </a:bodyPr>
+          <a:lstStyle/>
+          <a:p>
+            <a:pPr algn="ctr" indent="0" marL="0">
+              <a:buNone/>
+            </a:pPr>
+            <a:r>
+              <a:rPr lang="en-US" sz="740" b="1" dirty="0">
+                <a:solidFill>
+                  <a:srgbClr val="FFFFFF"/>
+                </a:solidFill>
+                <a:latin typeface="Aptos" pitchFamily="34" charset="0"/>
+                <a:ea typeface="Aptos" pitchFamily="34" charset="-122"/>
+                <a:cs typeface="Aptos" pitchFamily="34" charset="-120"/>
+              </a:rPr>
+              <a:t>✓</a:t>
+            </a:r>
+            <a:endParaRPr lang="en-US" sz="740" dirty="0"/>
+          </a:p>
+        </p:txBody>
+      </p:sp>
+      <p:sp>
+        <p:nvSpPr>
+          <p:cNvPr id="58" name="Text 56"/>
+          <p:cNvSpPr/>
+          <p:nvPr/>
+        </p:nvSpPr>
+        <p:spPr>
+          <a:xfrm>
+            <a:off x="7022592" y="2660904"/>
+            <a:ext cx="4480560" cy="118872"/>
+          </a:xfrm>
+          <a:prstGeom prst="rect">
+            <a:avLst/>
+          </a:prstGeom>
+          <a:noFill/>
+          <a:ln/>
+        </p:spPr>
+        <p:txBody>
+          <a:bodyPr wrap="square" lIns="0" tIns="0" rIns="0" bIns="0" rtlCol="0" anchor="ctr">
+            <a:normAutofit/>
+          </a:bodyPr>
+          <a:lstStyle/>
+          <a:p>
+            <a:pPr algn="l" indent="0" marL="0">
+              <a:buNone/>
+            </a:pPr>
+            <a:r>
+              <a:rPr lang="en-US" sz="920" b="1" dirty="0">
+                <a:solidFill>
+                  <a:srgbClr val="202729"/>
+                </a:solidFill>
+                <a:latin typeface="Aptos" pitchFamily="34" charset="0"/>
+                <a:ea typeface="Aptos" pitchFamily="34" charset="-122"/>
+                <a:cs typeface="Aptos" pitchFamily="34" charset="-120"/>
+              </a:rPr>
+              <a:t>Maintenance work order</a:t>
+            </a:r>
+            <a:endParaRPr lang="en-US" sz="920" dirty="0"/>
+          </a:p>
+        </p:txBody>
+      </p:sp>
+      <p:sp>
+        <p:nvSpPr>
+          <p:cNvPr id="59" name="Text 57"/>
+          <p:cNvSpPr/>
+          <p:nvPr/>
+        </p:nvSpPr>
+        <p:spPr>
+          <a:xfrm>
+            <a:off x="7022592" y="2907792"/>
+            <a:ext cx="4480560" cy="100584"/>
+          </a:xfrm>
+          <a:prstGeom prst="rect">
+            <a:avLst/>
+          </a:prstGeom>
+          <a:noFill/>
+          <a:ln/>
+        </p:spPr>
+        <p:txBody>
+          <a:bodyPr wrap="square" lIns="0" tIns="0" rIns="0" bIns="0" rtlCol="0" anchor="ctr">
+            <a:normAutofit/>
+          </a:bodyPr>
+          <a:lstStyle/>
+          <a:p>
+            <a:pPr algn="l" indent="0" marL="0">
+              <a:buNone/>
+            </a:pPr>
+            <a:r>
+              <a:rPr lang="en-US" sz="710" dirty="0">
+                <a:solidFill>
+                  <a:srgbClr val="687373"/>
+                </a:solidFill>
+                <a:latin typeface="Consolas" pitchFamily="34" charset="0"/>
+                <a:ea typeface="Consolas" pitchFamily="34" charset="-122"/>
+                <a:cs typeface="Consolas" pitchFamily="34" charset="-120"/>
+              </a:rPr>
+              <a:t>POST /v1/workorders  —  from a lining-wear alert</a:t>
+            </a:r>
+            <a:endParaRPr lang="en-US" sz="710" dirty="0"/>
+          </a:p>
+        </p:txBody>
+      </p:sp>
+      <p:sp>
+        <p:nvSpPr>
+          <p:cNvPr id="60" name="Shape 58"/>
+          <p:cNvSpPr/>
+          <p:nvPr/>
+        </p:nvSpPr>
+        <p:spPr>
+          <a:xfrm>
+            <a:off x="6446520" y="3264408"/>
+            <a:ext cx="5285232" cy="621792"/>
+          </a:xfrm>
+          <a:prstGeom prst="roundRect">
+            <a:avLst/>
+          </a:prstGeom>
+          <a:solidFill>
+            <a:srgbClr val="FFFFFF"/>
+          </a:solidFill>
+          <a:ln w="8890">
+            <a:solidFill>
+              <a:srgbClr val="DDE4E1"/>
+            </a:solidFill>
+            <a:prstDash val="solid"/>
+          </a:ln>
+        </p:spPr>
+      </p:sp>
+      <p:sp>
+        <p:nvSpPr>
+          <p:cNvPr id="61" name="Shape 59"/>
+          <p:cNvSpPr/>
+          <p:nvPr/>
+        </p:nvSpPr>
+        <p:spPr>
+          <a:xfrm>
+            <a:off x="6446520" y="3264408"/>
+            <a:ext cx="77724" cy="621792"/>
+          </a:xfrm>
+          <a:prstGeom prst="rect">
+            <a:avLst/>
+          </a:prstGeom>
+          <a:solidFill>
+            <a:srgbClr val="6D9A6F"/>
+          </a:solidFill>
+          <a:ln w="6350">
+            <a:solidFill>
+              <a:srgbClr val="6D9A6F"/>
+            </a:solidFill>
+            <a:prstDash val="solid"/>
+          </a:ln>
+        </p:spPr>
+      </p:sp>
+      <p:sp>
+        <p:nvSpPr>
+          <p:cNvPr id="62" name="Shape 60"/>
+          <p:cNvSpPr/>
+          <p:nvPr/>
+        </p:nvSpPr>
+        <p:spPr>
+          <a:xfrm>
+            <a:off x="6656832" y="3456432"/>
+            <a:ext cx="237744" cy="237744"/>
+          </a:xfrm>
+          <a:prstGeom prst="ellipse">
+            <a:avLst/>
+          </a:prstGeom>
+          <a:solidFill>
+            <a:srgbClr val="6D9A6F"/>
+          </a:solidFill>
+          <a:ln w="6350">
+            <a:solidFill>
+              <a:srgbClr val="6D9A6F"/>
+            </a:solidFill>
+            <a:prstDash val="solid"/>
+          </a:ln>
+        </p:spPr>
+      </p:sp>
+      <p:sp>
+        <p:nvSpPr>
+          <p:cNvPr id="63" name="Text 61"/>
+          <p:cNvSpPr/>
+          <p:nvPr/>
+        </p:nvSpPr>
+        <p:spPr>
+          <a:xfrm>
+            <a:off x="6656832" y="3543300"/>
+            <a:ext cx="237744" cy="73152"/>
+          </a:xfrm>
+          <a:prstGeom prst="rect">
+            <a:avLst/>
+          </a:prstGeom>
+          <a:noFill/>
+          <a:ln/>
+        </p:spPr>
+        <p:txBody>
+          <a:bodyPr wrap="square" lIns="0" tIns="0" rIns="0" bIns="0" rtlCol="0" anchor="ctr">
+            <a:normAutofit/>
+          </a:bodyPr>
+          <a:lstStyle/>
+          <a:p>
+            <a:pPr algn="ctr" indent="0" marL="0">
+              <a:buNone/>
+            </a:pPr>
+            <a:r>
+              <a:rPr lang="en-US" sz="740" b="1" dirty="0">
+                <a:solidFill>
+                  <a:srgbClr val="FFFFFF"/>
+                </a:solidFill>
+                <a:latin typeface="Aptos" pitchFamily="34" charset="0"/>
+                <a:ea typeface="Aptos" pitchFamily="34" charset="-122"/>
+                <a:cs typeface="Aptos" pitchFamily="34" charset="-120"/>
+              </a:rPr>
+              <a:t>✓</a:t>
+            </a:r>
+            <a:endParaRPr lang="en-US" sz="740" dirty="0"/>
+          </a:p>
+        </p:txBody>
+      </p:sp>
+      <p:sp>
+        <p:nvSpPr>
+          <p:cNvPr id="64" name="Text 62"/>
+          <p:cNvSpPr/>
+          <p:nvPr/>
+        </p:nvSpPr>
+        <p:spPr>
+          <a:xfrm>
+            <a:off x="7022592" y="3383280"/>
+            <a:ext cx="4480560" cy="118872"/>
+          </a:xfrm>
+          <a:prstGeom prst="rect">
+            <a:avLst/>
+          </a:prstGeom>
+          <a:noFill/>
+          <a:ln/>
+        </p:spPr>
+        <p:txBody>
+          <a:bodyPr wrap="square" lIns="0" tIns="0" rIns="0" bIns="0" rtlCol="0" anchor="ctr">
+            <a:normAutofit/>
+          </a:bodyPr>
+          <a:lstStyle/>
+          <a:p>
+            <a:pPr algn="l" indent="0" marL="0">
+              <a:buNone/>
+            </a:pPr>
+            <a:r>
+              <a:rPr lang="en-US" sz="920" b="1" dirty="0">
+                <a:solidFill>
+                  <a:srgbClr val="202729"/>
+                </a:solidFill>
+                <a:latin typeface="Aptos" pitchFamily="34" charset="0"/>
+                <a:ea typeface="Aptos" pitchFamily="34" charset="-122"/>
+                <a:cs typeface="Aptos" pitchFamily="34" charset="-120"/>
+              </a:rPr>
+              <a:t>Procedure publication</a:t>
+            </a:r>
+            <a:endParaRPr lang="en-US" sz="920" dirty="0"/>
+          </a:p>
+        </p:txBody>
+      </p:sp>
+      <p:sp>
+        <p:nvSpPr>
+          <p:cNvPr id="65" name="Text 63"/>
+          <p:cNvSpPr/>
+          <p:nvPr/>
+        </p:nvSpPr>
+        <p:spPr>
+          <a:xfrm>
+            <a:off x="7022592" y="3630168"/>
+            <a:ext cx="4480560" cy="100584"/>
+          </a:xfrm>
+          <a:prstGeom prst="rect">
+            <a:avLst/>
+          </a:prstGeom>
+          <a:noFill/>
+          <a:ln/>
+        </p:spPr>
+        <p:txBody>
+          <a:bodyPr wrap="square" lIns="0" tIns="0" rIns="0" bIns="0" rtlCol="0" anchor="ctr">
+            <a:normAutofit/>
+          </a:bodyPr>
+          <a:lstStyle/>
+          <a:p>
+            <a:pPr algn="l" indent="0" marL="0">
+              <a:buNone/>
+            </a:pPr>
+            <a:r>
+              <a:rPr lang="en-US" sz="710" dirty="0">
+                <a:solidFill>
+                  <a:srgbClr val="687373"/>
+                </a:solidFill>
+                <a:latin typeface="Consolas" pitchFamily="34" charset="0"/>
+                <a:ea typeface="Consolas" pitchFamily="34" charset="-122"/>
+                <a:cs typeface="Consolas" pitchFamily="34" charset="-120"/>
+              </a:rPr>
+              <a:t>POST /v1/knowledge/procedures/{id}:approve</a:t>
+            </a:r>
+            <a:endParaRPr lang="en-US" sz="710" dirty="0"/>
+          </a:p>
+        </p:txBody>
+      </p:sp>
+      <p:sp>
+        <p:nvSpPr>
+          <p:cNvPr id="66" name="Shape 64"/>
+          <p:cNvSpPr/>
+          <p:nvPr/>
+        </p:nvSpPr>
+        <p:spPr>
+          <a:xfrm>
+            <a:off x="6446520" y="3986784"/>
+            <a:ext cx="5285232" cy="621792"/>
+          </a:xfrm>
+          <a:prstGeom prst="roundRect">
+            <a:avLst/>
+          </a:prstGeom>
+          <a:solidFill>
+            <a:srgbClr val="FFFFFF"/>
+          </a:solidFill>
+          <a:ln w="8890">
+            <a:solidFill>
+              <a:srgbClr val="DDE4E1"/>
+            </a:solidFill>
+            <a:prstDash val="solid"/>
+          </a:ln>
+        </p:spPr>
+      </p:sp>
+      <p:sp>
+        <p:nvSpPr>
+          <p:cNvPr id="67" name="Shape 65"/>
+          <p:cNvSpPr/>
+          <p:nvPr/>
+        </p:nvSpPr>
+        <p:spPr>
+          <a:xfrm>
+            <a:off x="6446520" y="3986784"/>
+            <a:ext cx="77724" cy="621792"/>
+          </a:xfrm>
+          <a:prstGeom prst="rect">
+            <a:avLst/>
+          </a:prstGeom>
+          <a:solidFill>
+            <a:srgbClr val="B64A2D"/>
+          </a:solidFill>
+          <a:ln w="6350">
+            <a:solidFill>
+              <a:srgbClr val="B64A2D"/>
+            </a:solidFill>
+            <a:prstDash val="solid"/>
+          </a:ln>
+        </p:spPr>
+      </p:sp>
+      <p:sp>
+        <p:nvSpPr>
+          <p:cNvPr id="68" name="Shape 66"/>
+          <p:cNvSpPr/>
+          <p:nvPr/>
+        </p:nvSpPr>
+        <p:spPr>
+          <a:xfrm>
+            <a:off x="6656832" y="4178808"/>
+            <a:ext cx="237744" cy="237744"/>
+          </a:xfrm>
+          <a:prstGeom prst="ellipse">
+            <a:avLst/>
+          </a:prstGeom>
+          <a:solidFill>
+            <a:srgbClr val="B64A2D"/>
+          </a:solidFill>
+          <a:ln w="6350">
+            <a:solidFill>
+              <a:srgbClr val="B64A2D"/>
+            </a:solidFill>
+            <a:prstDash val="solid"/>
+          </a:ln>
+        </p:spPr>
+      </p:sp>
+      <p:sp>
+        <p:nvSpPr>
+          <p:cNvPr id="69" name="Text 67"/>
+          <p:cNvSpPr/>
+          <p:nvPr/>
+        </p:nvSpPr>
+        <p:spPr>
+          <a:xfrm>
+            <a:off x="6656832" y="4265676"/>
+            <a:ext cx="237744" cy="73152"/>
+          </a:xfrm>
+          <a:prstGeom prst="rect">
+            <a:avLst/>
+          </a:prstGeom>
+          <a:noFill/>
+          <a:ln/>
+        </p:spPr>
+        <p:txBody>
+          <a:bodyPr wrap="square" lIns="0" tIns="0" rIns="0" bIns="0" rtlCol="0" anchor="ctr">
+            <a:normAutofit/>
+          </a:bodyPr>
+          <a:lstStyle/>
+          <a:p>
+            <a:pPr algn="ctr" indent="0" marL="0">
+              <a:buNone/>
+            </a:pPr>
+            <a:r>
+              <a:rPr lang="en-US" sz="740" b="1" dirty="0">
+                <a:solidFill>
+                  <a:srgbClr val="FFFFFF"/>
+                </a:solidFill>
+                <a:latin typeface="Aptos" pitchFamily="34" charset="0"/>
+                <a:ea typeface="Aptos" pitchFamily="34" charset="-122"/>
+                <a:cs typeface="Aptos" pitchFamily="34" charset="-120"/>
+              </a:rPr>
+              <a:t>✓</a:t>
+            </a:r>
+            <a:endParaRPr lang="en-US" sz="740" dirty="0"/>
+          </a:p>
+        </p:txBody>
+      </p:sp>
+      <p:sp>
+        <p:nvSpPr>
+          <p:cNvPr id="70" name="Text 68"/>
+          <p:cNvSpPr/>
+          <p:nvPr/>
+        </p:nvSpPr>
+        <p:spPr>
+          <a:xfrm>
+            <a:off x="7022592" y="4105656"/>
+            <a:ext cx="4480560" cy="118872"/>
+          </a:xfrm>
+          <a:prstGeom prst="rect">
+            <a:avLst/>
+          </a:prstGeom>
+          <a:noFill/>
+          <a:ln/>
+        </p:spPr>
+        <p:txBody>
+          <a:bodyPr wrap="square" lIns="0" tIns="0" rIns="0" bIns="0" rtlCol="0" anchor="ctr">
+            <a:normAutofit/>
+          </a:bodyPr>
+          <a:lstStyle/>
+          <a:p>
+            <a:pPr algn="l" indent="0" marL="0">
+              <a:buNone/>
+            </a:pPr>
+            <a:r>
+              <a:rPr lang="en-US" sz="920" b="1" dirty="0">
+                <a:solidFill>
+                  <a:srgbClr val="202729"/>
+                </a:solidFill>
+                <a:latin typeface="Aptos" pitchFamily="34" charset="0"/>
+                <a:ea typeface="Aptos" pitchFamily="34" charset="-122"/>
+                <a:cs typeface="Aptos" pitchFamily="34" charset="-120"/>
+              </a:rPr>
+              <a:t>Immutable decision record</a:t>
+            </a:r>
+            <a:endParaRPr lang="en-US" sz="920" dirty="0"/>
+          </a:p>
+        </p:txBody>
+      </p:sp>
+      <p:sp>
+        <p:nvSpPr>
+          <p:cNvPr id="71" name="Text 69"/>
+          <p:cNvSpPr/>
+          <p:nvPr/>
+        </p:nvSpPr>
+        <p:spPr>
+          <a:xfrm>
+            <a:off x="7022592" y="4352544"/>
+            <a:ext cx="4480560" cy="100584"/>
+          </a:xfrm>
+          <a:prstGeom prst="rect">
+            <a:avLst/>
+          </a:prstGeom>
+          <a:noFill/>
+          <a:ln/>
+        </p:spPr>
+        <p:txBody>
+          <a:bodyPr wrap="square" lIns="0" tIns="0" rIns="0" bIns="0" rtlCol="0" anchor="ctr">
+            <a:normAutofit/>
+          </a:bodyPr>
+          <a:lstStyle/>
+          <a:p>
+            <a:pPr algn="l" indent="0" marL="0">
+              <a:buNone/>
+            </a:pPr>
+            <a:r>
+              <a:rPr lang="en-US" sz="710" dirty="0">
+                <a:solidFill>
+                  <a:srgbClr val="687373"/>
+                </a:solidFill>
+                <a:latin typeface="Consolas" pitchFamily="34" charset="0"/>
+                <a:ea typeface="Consolas" pitchFamily="34" charset="-122"/>
+                <a:cs typeface="Consolas" pitchFamily="34" charset="-120"/>
+              </a:rPr>
+              <a:t>GET /v1/audit/decisions  —  hash-chained trail</a:t>
+            </a:r>
+            <a:endParaRPr lang="en-US" sz="710" dirty="0"/>
+          </a:p>
+        </p:txBody>
+      </p:sp>
+      <p:sp>
+        <p:nvSpPr>
+          <p:cNvPr id="72" name="Shape 70"/>
+          <p:cNvSpPr/>
+          <p:nvPr/>
+        </p:nvSpPr>
+        <p:spPr>
+          <a:xfrm>
+            <a:off x="6446520" y="4718304"/>
+            <a:ext cx="5285232" cy="566928"/>
+          </a:xfrm>
+          <a:prstGeom prst="roundRect">
+            <a:avLst/>
+          </a:prstGeom>
+          <a:solidFill>
+            <a:srgbClr val="F3E9CB"/>
+          </a:solidFill>
+          <a:ln w="8890">
+            <a:solidFill>
+              <a:srgbClr val="E3A72F"/>
+            </a:solidFill>
+            <a:prstDash val="solid"/>
+          </a:ln>
+        </p:spPr>
+      </p:sp>
+      <p:sp>
+        <p:nvSpPr>
+          <p:cNvPr id="73" name="Shape 71"/>
+          <p:cNvSpPr/>
+          <p:nvPr/>
+        </p:nvSpPr>
+        <p:spPr>
+          <a:xfrm>
+            <a:off x="6446520" y="4718304"/>
+            <a:ext cx="77724" cy="566928"/>
+          </a:xfrm>
+          <a:prstGeom prst="rect">
+            <a:avLst/>
+          </a:prstGeom>
+          <a:solidFill>
+            <a:srgbClr val="E3A72F"/>
+          </a:solidFill>
+          <a:ln w="6350">
+            <a:solidFill>
+              <a:srgbClr val="E3A72F"/>
+            </a:solidFill>
+            <a:prstDash val="solid"/>
+          </a:ln>
+        </p:spPr>
+      </p:sp>
+      <p:sp>
+        <p:nvSpPr>
+          <p:cNvPr id="74" name="Text 72"/>
+          <p:cNvSpPr/>
+          <p:nvPr/>
+        </p:nvSpPr>
+        <p:spPr>
+          <a:xfrm>
+            <a:off x="6693408" y="4828032"/>
+            <a:ext cx="4864608" cy="347472"/>
+          </a:xfrm>
+          <a:prstGeom prst="rect">
+            <a:avLst/>
+          </a:prstGeom>
+          <a:noFill/>
+          <a:ln/>
+        </p:spPr>
+        <p:txBody>
+          <a:bodyPr wrap="square" lIns="0" tIns="0" rIns="0" bIns="0" rtlCol="0" anchor="t">
+            <a:normAutofit/>
+          </a:bodyPr>
+          <a:lstStyle/>
+          <a:p>
+            <a:pPr algn="l" indent="0" marL="0">
+              <a:buNone/>
+            </a:pPr>
+            <a:r>
+              <a:rPr lang="en-US" sz="780" b="1" dirty="0">
+                <a:solidFill>
+                  <a:srgbClr val="202729"/>
+                </a:solidFill>
+                <a:latin typeface="Aptos" pitchFamily="34" charset="0"/>
+                <a:ea typeface="Aptos" pitchFamily="34" charset="-122"/>
+                <a:cs typeface="Aptos" pitchFamily="34" charset="-120"/>
+              </a:rPr>
+              <a:t>PHASE 2 — guarded write-back to CMMS / MES only: human-approved, threshold-bounded, reversible. Never a direct control action.</a:t>
+            </a:r>
+            <a:endParaRPr lang="en-US" sz="780" dirty="0"/>
+          </a:p>
+        </p:txBody>
+      </p:sp>
+      <p:sp>
+        <p:nvSpPr>
+          <p:cNvPr id="75" name="Shape 73"/>
+          <p:cNvSpPr/>
+          <p:nvPr/>
+        </p:nvSpPr>
+        <p:spPr>
+          <a:xfrm>
+            <a:off x="457200" y="5413248"/>
+            <a:ext cx="2708910" cy="676656"/>
+          </a:xfrm>
+          <a:prstGeom prst="roundRect">
+            <a:avLst/>
+          </a:prstGeom>
+          <a:solidFill>
+            <a:srgbClr val="FFFFFF"/>
+          </a:solidFill>
+          <a:ln w="8890">
+            <a:solidFill>
+              <a:srgbClr val="DDE4E1"/>
+            </a:solidFill>
+            <a:prstDash val="solid"/>
+          </a:ln>
+        </p:spPr>
+      </p:sp>
+      <p:sp>
+        <p:nvSpPr>
+          <p:cNvPr id="76" name="Shape 74"/>
+          <p:cNvSpPr/>
+          <p:nvPr/>
+        </p:nvSpPr>
+        <p:spPr>
+          <a:xfrm>
+            <a:off x="457200" y="5413248"/>
+            <a:ext cx="77724" cy="676656"/>
+          </a:xfrm>
+          <a:prstGeom prst="rect">
+            <a:avLst/>
+          </a:prstGeom>
+          <a:solidFill>
+            <a:srgbClr val="B64A2D"/>
+          </a:solidFill>
+          <a:ln w="6350">
+            <a:solidFill>
+              <a:srgbClr val="B64A2D"/>
+            </a:solidFill>
+            <a:prstDash val="solid"/>
+          </a:ln>
+        </p:spPr>
+      </p:sp>
+      <p:sp>
+        <p:nvSpPr>
+          <p:cNvPr id="77" name="Text 75"/>
+          <p:cNvSpPr/>
+          <p:nvPr/>
+        </p:nvSpPr>
+        <p:spPr>
+          <a:xfrm>
+            <a:off x="640080" y="5527548"/>
+            <a:ext cx="2377440" cy="100584"/>
+          </a:xfrm>
+          <a:prstGeom prst="rect">
+            <a:avLst/>
+          </a:prstGeom>
+          <a:noFill/>
+          <a:ln/>
+        </p:spPr>
+        <p:txBody>
+          <a:bodyPr wrap="square" lIns="0" tIns="0" rIns="0" bIns="0" rtlCol="0" anchor="ctr">
+            <a:normAutofit/>
+          </a:bodyPr>
+          <a:lstStyle/>
+          <a:p>
+            <a:pPr algn="l" indent="0" marL="0">
+              <a:buNone/>
+            </a:pPr>
+            <a:r>
+              <a:rPr lang="en-US" sz="800" b="1" spc="70" kern="0" dirty="0">
+                <a:solidFill>
+                  <a:srgbClr val="B64A2D"/>
+                </a:solidFill>
+                <a:latin typeface="Aptos" pitchFamily="34" charset="0"/>
+                <a:ea typeface="Aptos" pitchFamily="34" charset="-122"/>
+                <a:cs typeface="Aptos" pitchFamily="34" charset="-120"/>
+              </a:rPr>
+              <a:t>IEC 61511 / SIS</a:t>
+            </a:r>
+            <a:endParaRPr lang="en-US" sz="800" dirty="0"/>
+          </a:p>
+        </p:txBody>
+      </p:sp>
+      <p:sp>
+        <p:nvSpPr>
+          <p:cNvPr id="78" name="Text 76"/>
+          <p:cNvSpPr/>
+          <p:nvPr/>
+        </p:nvSpPr>
+        <p:spPr>
+          <a:xfrm>
+            <a:off x="640080" y="5733288"/>
+            <a:ext cx="2340864" cy="256032"/>
+          </a:xfrm>
+          <a:prstGeom prst="rect">
+            <a:avLst/>
+          </a:prstGeom>
+          <a:noFill/>
+          <a:ln/>
+        </p:spPr>
+        <p:txBody>
+          <a:bodyPr wrap="square" lIns="0" tIns="0" rIns="0" bIns="0" rtlCol="0" anchor="t">
+            <a:normAutofit/>
+          </a:bodyPr>
+          <a:lstStyle/>
+          <a:p>
+            <a:pPr algn="l" indent="0" marL="0">
+              <a:buNone/>
+            </a:pPr>
+            <a:r>
+              <a:rPr lang="en-US" sz="700" dirty="0">
+                <a:solidFill>
+                  <a:srgbClr val="687373"/>
+                </a:solidFill>
+                <a:latin typeface="Aptos" pitchFamily="34" charset="0"/>
+                <a:ea typeface="Aptos" pitchFamily="34" charset="-122"/>
+                <a:cs typeface="Aptos" pitchFamily="34" charset="-120"/>
+              </a:rPr>
+              <a:t>Safety-instrumented functions are not arbitrated by a cloud model.</a:t>
+            </a:r>
+            <a:endParaRPr lang="en-US" sz="700" dirty="0"/>
+          </a:p>
+        </p:txBody>
+      </p:sp>
+      <p:sp>
+        <p:nvSpPr>
+          <p:cNvPr id="79" name="Shape 77"/>
+          <p:cNvSpPr/>
+          <p:nvPr/>
+        </p:nvSpPr>
+        <p:spPr>
+          <a:xfrm>
+            <a:off x="3312414" y="5413248"/>
+            <a:ext cx="2708910" cy="676656"/>
+          </a:xfrm>
+          <a:prstGeom prst="roundRect">
+            <a:avLst/>
+          </a:prstGeom>
+          <a:solidFill>
+            <a:srgbClr val="FFFFFF"/>
+          </a:solidFill>
+          <a:ln w="8890">
+            <a:solidFill>
+              <a:srgbClr val="DDE4E1"/>
+            </a:solidFill>
+            <a:prstDash val="solid"/>
+          </a:ln>
+        </p:spPr>
+      </p:sp>
+      <p:sp>
+        <p:nvSpPr>
+          <p:cNvPr id="80" name="Shape 78"/>
+          <p:cNvSpPr/>
+          <p:nvPr/>
+        </p:nvSpPr>
+        <p:spPr>
+          <a:xfrm>
+            <a:off x="3312414" y="5413248"/>
+            <a:ext cx="77724" cy="676656"/>
+          </a:xfrm>
+          <a:prstGeom prst="rect">
+            <a:avLst/>
+          </a:prstGeom>
+          <a:solidFill>
+            <a:srgbClr val="E3A72F"/>
+          </a:solidFill>
+          <a:ln w="6350">
+            <a:solidFill>
+              <a:srgbClr val="E3A72F"/>
+            </a:solidFill>
+            <a:prstDash val="solid"/>
+          </a:ln>
+        </p:spPr>
+      </p:sp>
+      <p:sp>
+        <p:nvSpPr>
+          <p:cNvPr id="81" name="Text 79"/>
+          <p:cNvSpPr/>
+          <p:nvPr/>
+        </p:nvSpPr>
+        <p:spPr>
+          <a:xfrm>
+            <a:off x="3495294" y="5527548"/>
+            <a:ext cx="2377440" cy="100584"/>
+          </a:xfrm>
+          <a:prstGeom prst="rect">
+            <a:avLst/>
+          </a:prstGeom>
+          <a:noFill/>
+          <a:ln/>
+        </p:spPr>
+        <p:txBody>
+          <a:bodyPr wrap="square" lIns="0" tIns="0" rIns="0" bIns="0" rtlCol="0" anchor="ctr">
+            <a:normAutofit/>
+          </a:bodyPr>
+          <a:lstStyle/>
+          <a:p>
+            <a:pPr algn="l" indent="0" marL="0">
+              <a:buNone/>
+            </a:pPr>
+            <a:r>
+              <a:rPr lang="en-US" sz="800" b="1" spc="70" kern="0" dirty="0">
+                <a:solidFill>
+                  <a:srgbClr val="E3A72F"/>
+                </a:solidFill>
+                <a:latin typeface="Aptos" pitchFamily="34" charset="0"/>
+                <a:ea typeface="Aptos" pitchFamily="34" charset="-122"/>
+                <a:cs typeface="Aptos" pitchFamily="34" charset="-120"/>
+              </a:rPr>
+              <a:t>IEC 62443 ZONES</a:t>
+            </a:r>
+            <a:endParaRPr lang="en-US" sz="800" dirty="0"/>
+          </a:p>
+        </p:txBody>
+      </p:sp>
+      <p:sp>
+        <p:nvSpPr>
+          <p:cNvPr id="82" name="Text 80"/>
+          <p:cNvSpPr/>
+          <p:nvPr/>
+        </p:nvSpPr>
+        <p:spPr>
+          <a:xfrm>
+            <a:off x="3495294" y="5733288"/>
+            <a:ext cx="2340864" cy="256032"/>
+          </a:xfrm>
+          <a:prstGeom prst="rect">
+            <a:avLst/>
+          </a:prstGeom>
+          <a:noFill/>
+          <a:ln/>
+        </p:spPr>
+        <p:txBody>
+          <a:bodyPr wrap="square" lIns="0" tIns="0" rIns="0" bIns="0" rtlCol="0" anchor="t">
+            <a:normAutofit/>
+          </a:bodyPr>
+          <a:lstStyle/>
+          <a:p>
+            <a:pPr algn="l" indent="0" marL="0">
+              <a:buNone/>
+            </a:pPr>
+            <a:r>
+              <a:rPr lang="en-US" sz="700" dirty="0">
+                <a:solidFill>
+                  <a:srgbClr val="687373"/>
+                </a:solidFill>
+                <a:latin typeface="Aptos" pitchFamily="34" charset="0"/>
+                <a:ea typeface="Aptos" pitchFamily="34" charset="-122"/>
+                <a:cs typeface="Aptos" pitchFamily="34" charset="-120"/>
+              </a:rPr>
+              <a:t>The conduit is outbound-only; no inbound session reaches the cell.</a:t>
+            </a:r>
+            <a:endParaRPr lang="en-US" sz="700" dirty="0"/>
+          </a:p>
+        </p:txBody>
+      </p:sp>
+      <p:sp>
+        <p:nvSpPr>
+          <p:cNvPr id="83" name="Shape 81"/>
+          <p:cNvSpPr/>
+          <p:nvPr/>
+        </p:nvSpPr>
+        <p:spPr>
+          <a:xfrm>
+            <a:off x="6167628" y="5413248"/>
+            <a:ext cx="2708910" cy="676656"/>
+          </a:xfrm>
+          <a:prstGeom prst="roundRect">
+            <a:avLst/>
+          </a:prstGeom>
+          <a:solidFill>
+            <a:srgbClr val="FFFFFF"/>
+          </a:solidFill>
+          <a:ln w="8890">
+            <a:solidFill>
+              <a:srgbClr val="DDE4E1"/>
+            </a:solidFill>
+            <a:prstDash val="solid"/>
+          </a:ln>
+        </p:spPr>
+      </p:sp>
+      <p:sp>
+        <p:nvSpPr>
+          <p:cNvPr id="84" name="Shape 82"/>
+          <p:cNvSpPr/>
+          <p:nvPr/>
+        </p:nvSpPr>
+        <p:spPr>
+          <a:xfrm>
+            <a:off x="6167628" y="5413248"/>
+            <a:ext cx="77724" cy="676656"/>
+          </a:xfrm>
+          <a:prstGeom prst="rect">
+            <a:avLst/>
+          </a:prstGeom>
+          <a:solidFill>
+            <a:srgbClr val="147D74"/>
+          </a:solidFill>
+          <a:ln w="6350">
+            <a:solidFill>
+              <a:srgbClr val="147D74"/>
+            </a:solidFill>
+            <a:prstDash val="solid"/>
+          </a:ln>
+        </p:spPr>
+      </p:sp>
+      <p:sp>
+        <p:nvSpPr>
+          <p:cNvPr id="85" name="Text 83"/>
+          <p:cNvSpPr/>
+          <p:nvPr/>
+        </p:nvSpPr>
+        <p:spPr>
+          <a:xfrm>
+            <a:off x="6350508" y="5527548"/>
+            <a:ext cx="2377440" cy="100584"/>
+          </a:xfrm>
+          <a:prstGeom prst="rect">
+            <a:avLst/>
+          </a:prstGeom>
+          <a:noFill/>
+          <a:ln/>
+        </p:spPr>
+        <p:txBody>
+          <a:bodyPr wrap="square" lIns="0" tIns="0" rIns="0" bIns="0" rtlCol="0" anchor="ctr">
+            <a:normAutofit/>
+          </a:bodyPr>
+          <a:lstStyle/>
+          <a:p>
+            <a:pPr algn="l" indent="0" marL="0">
+              <a:buNone/>
+            </a:pPr>
+            <a:r>
+              <a:rPr lang="en-US" sz="800" b="1" spc="70" kern="0" dirty="0">
+                <a:solidFill>
+                  <a:srgbClr val="147D74"/>
+                </a:solidFill>
+                <a:latin typeface="Aptos" pitchFamily="34" charset="0"/>
+                <a:ea typeface="Aptos" pitchFamily="34" charset="-122"/>
+                <a:cs typeface="Aptos" pitchFamily="34" charset="-120"/>
+              </a:rPr>
+              <a:t>EU AI ACT</a:t>
+            </a:r>
+            <a:endParaRPr lang="en-US" sz="800" dirty="0"/>
+          </a:p>
+        </p:txBody>
+      </p:sp>
+      <p:sp>
+        <p:nvSpPr>
+          <p:cNvPr id="86" name="Text 84"/>
+          <p:cNvSpPr/>
+          <p:nvPr/>
+        </p:nvSpPr>
+        <p:spPr>
+          <a:xfrm>
+            <a:off x="6350508" y="5733288"/>
+            <a:ext cx="2340864" cy="256032"/>
+          </a:xfrm>
+          <a:prstGeom prst="rect">
+            <a:avLst/>
+          </a:prstGeom>
+          <a:noFill/>
+          <a:ln/>
+        </p:spPr>
+        <p:txBody>
+          <a:bodyPr wrap="square" lIns="0" tIns="0" rIns="0" bIns="0" rtlCol="0" anchor="t">
+            <a:normAutofit/>
+          </a:bodyPr>
+          <a:lstStyle/>
+          <a:p>
+            <a:pPr algn="l" indent="0" marL="0">
+              <a:buNone/>
+            </a:pPr>
+            <a:r>
+              <a:rPr lang="en-US" sz="700" dirty="0">
+                <a:solidFill>
+                  <a:srgbClr val="687373"/>
+                </a:solidFill>
+                <a:latin typeface="Aptos" pitchFamily="34" charset="0"/>
+                <a:ea typeface="Aptos" pitchFamily="34" charset="-122"/>
+                <a:cs typeface="Aptos" pitchFamily="34" charset="-120"/>
+              </a:rPr>
+              <a:t>Actuation would assume high-risk duties we cannot yet evidence.</a:t>
+            </a:r>
+            <a:endParaRPr lang="en-US" sz="700" dirty="0"/>
+          </a:p>
+        </p:txBody>
+      </p:sp>
+      <p:sp>
+        <p:nvSpPr>
+          <p:cNvPr id="87" name="Shape 85"/>
+          <p:cNvSpPr/>
+          <p:nvPr/>
+        </p:nvSpPr>
+        <p:spPr>
+          <a:xfrm>
+            <a:off x="9022842" y="5413248"/>
+            <a:ext cx="2708910" cy="676656"/>
+          </a:xfrm>
+          <a:prstGeom prst="roundRect">
+            <a:avLst/>
+          </a:prstGeom>
+          <a:solidFill>
+            <a:srgbClr val="FFFFFF"/>
+          </a:solidFill>
+          <a:ln w="8890">
+            <a:solidFill>
+              <a:srgbClr val="DDE4E1"/>
+            </a:solidFill>
+            <a:prstDash val="solid"/>
+          </a:ln>
+        </p:spPr>
+      </p:sp>
+      <p:sp>
+        <p:nvSpPr>
+          <p:cNvPr id="88" name="Shape 86"/>
+          <p:cNvSpPr/>
+          <p:nvPr/>
+        </p:nvSpPr>
+        <p:spPr>
+          <a:xfrm>
+            <a:off x="9022842" y="5413248"/>
+            <a:ext cx="77724" cy="676656"/>
+          </a:xfrm>
+          <a:prstGeom prst="rect">
+            <a:avLst/>
+          </a:prstGeom>
+          <a:solidFill>
+            <a:srgbClr val="465057"/>
+          </a:solidFill>
+          <a:ln w="6350">
+            <a:solidFill>
+              <a:srgbClr val="465057"/>
+            </a:solidFill>
+            <a:prstDash val="solid"/>
+          </a:ln>
+        </p:spPr>
+      </p:sp>
+      <p:sp>
+        <p:nvSpPr>
+          <p:cNvPr id="89" name="Text 87"/>
+          <p:cNvSpPr/>
+          <p:nvPr/>
+        </p:nvSpPr>
+        <p:spPr>
+          <a:xfrm>
+            <a:off x="9205722" y="5527548"/>
+            <a:ext cx="2377440" cy="100584"/>
+          </a:xfrm>
+          <a:prstGeom prst="rect">
+            <a:avLst/>
+          </a:prstGeom>
+          <a:noFill/>
+          <a:ln/>
+        </p:spPr>
+        <p:txBody>
+          <a:bodyPr wrap="square" lIns="0" tIns="0" rIns="0" bIns="0" rtlCol="0" anchor="ctr">
+            <a:normAutofit/>
+          </a:bodyPr>
+          <a:lstStyle/>
+          <a:p>
+            <a:pPr algn="l" indent="0" marL="0">
+              <a:buNone/>
+            </a:pPr>
+            <a:r>
+              <a:rPr lang="en-US" sz="800" b="1" spc="70" kern="0" dirty="0">
+                <a:solidFill>
+                  <a:srgbClr val="465057"/>
+                </a:solidFill>
+                <a:latin typeface="Aptos" pitchFamily="34" charset="0"/>
+                <a:ea typeface="Aptos" pitchFamily="34" charset="-122"/>
+                <a:cs typeface="Aptos" pitchFamily="34" charset="-120"/>
+              </a:rPr>
+              <a:t>REVERSIBILITY</a:t>
+            </a:r>
+            <a:endParaRPr lang="en-US" sz="800" dirty="0"/>
+          </a:p>
+        </p:txBody>
+      </p:sp>
+      <p:sp>
+        <p:nvSpPr>
+          <p:cNvPr id="90" name="Text 88"/>
+          <p:cNvSpPr/>
+          <p:nvPr/>
+        </p:nvSpPr>
+        <p:spPr>
+          <a:xfrm>
+            <a:off x="9205722" y="5733288"/>
+            <a:ext cx="2340864" cy="256032"/>
+          </a:xfrm>
+          <a:prstGeom prst="rect">
+            <a:avLst/>
+          </a:prstGeom>
+          <a:noFill/>
+          <a:ln/>
+        </p:spPr>
+        <p:txBody>
+          <a:bodyPr wrap="square" lIns="0" tIns="0" rIns="0" bIns="0" rtlCol="0" anchor="t">
+            <a:normAutofit/>
+          </a:bodyPr>
+          <a:lstStyle/>
+          <a:p>
+            <a:pPr algn="l" indent="0" marL="0">
+              <a:buNone/>
+            </a:pPr>
+            <a:r>
+              <a:rPr lang="en-US" sz="700" dirty="0">
+                <a:solidFill>
+                  <a:srgbClr val="687373"/>
+                </a:solidFill>
+                <a:latin typeface="Aptos" pitchFamily="34" charset="0"/>
+                <a:ea typeface="Aptos" pitchFamily="34" charset="-122"/>
+                <a:cs typeface="Aptos" pitchFamily="34" charset="-120"/>
+              </a:rPr>
+              <a:t>Rejected advice costs a click; a wrong setpoint can cost €8M.</a:t>
+            </a:r>
+            <a:endParaRPr lang="en-US" sz="700" dirty="0"/>
+          </a:p>
+        </p:txBody>
+      </p:sp>
+      <p:sp>
+        <p:nvSpPr>
+          <p:cNvPr id="91" name="Text 89"/>
+          <p:cNvSpPr/>
+          <p:nvPr/>
+        </p:nvSpPr>
+        <p:spPr>
+          <a:xfrm>
+            <a:off x="457200" y="6217920"/>
+            <a:ext cx="11155680" cy="128016"/>
+          </a:xfrm>
+          <a:prstGeom prst="rect">
+            <a:avLst/>
+          </a:prstGeom>
+          <a:noFill/>
+          <a:ln/>
+        </p:spPr>
+        <p:txBody>
+          <a:bodyPr wrap="square" lIns="0" tIns="0" rIns="0" bIns="0" rtlCol="0" anchor="ctr">
+            <a:normAutofit/>
+          </a:bodyPr>
+          <a:lstStyle/>
+          <a:p>
+            <a:pPr algn="l" indent="0" marL="0">
+              <a:buNone/>
+            </a:pPr>
+            <a:r>
+              <a:rPr lang="en-US" sz="660" i="1" dirty="0">
+                <a:solidFill>
+                  <a:srgbClr val="687373"/>
+                </a:solidFill>
+                <a:latin typeface="Aptos" pitchFamily="34" charset="0"/>
+                <a:ea typeface="Aptos" pitchFamily="34" charset="-122"/>
+                <a:cs typeface="Aptos" pitchFamily="34" charset="-120"/>
+              </a:rPr>
+              <a:t>Source cue | FAQ H — faq.md Q39b  •  solution-requirements.md O1, C-04, AI-05, §18 phasing  •  solution-architecture.md §1.1, ADR-007/008</a:t>
+            </a:r>
+            <a:endParaRPr lang="en-US" sz="660" dirty="0"/>
+          </a:p>
+        </p:txBody>
+      </p:sp>
+      <p:sp>
+        <p:nvSpPr>
+          <p:cNvPr id="92" name="Shape 90"/>
+          <p:cNvSpPr/>
+          <p:nvPr/>
+        </p:nvSpPr>
+        <p:spPr>
+          <a:xfrm>
+            <a:off x="0" y="6483096"/>
+            <a:ext cx="12191695" cy="374904"/>
+          </a:xfrm>
+          <a:prstGeom prst="rect">
+            <a:avLst/>
+          </a:prstGeom>
+          <a:solidFill>
+            <a:srgbClr val="E9E7E1"/>
+          </a:solidFill>
+          <a:ln w="6350">
+            <a:solidFill>
+              <a:srgbClr val="E9E7E1"/>
+            </a:solidFill>
+            <a:prstDash val="solid"/>
+          </a:ln>
+        </p:spPr>
+      </p:sp>
+      <p:sp>
+        <p:nvSpPr>
+          <p:cNvPr id="93" name="Shape 91"/>
+          <p:cNvSpPr/>
+          <p:nvPr/>
+        </p:nvSpPr>
+        <p:spPr>
+          <a:xfrm>
+            <a:off x="384048" y="6547104"/>
+            <a:ext cx="3547872" cy="182880"/>
+          </a:xfrm>
+          <a:prstGeom prst="roundRect">
+            <a:avLst/>
+          </a:prstGeom>
+          <a:solidFill>
+            <a:srgbClr val="FFFFFF"/>
+          </a:solidFill>
+          <a:ln w="3175">
+            <a:solidFill>
+              <a:srgbClr val="DDE4E1"/>
+            </a:solidFill>
+            <a:prstDash val="solid"/>
+          </a:ln>
+        </p:spPr>
+      </p:sp>
+      <p:sp>
+        <p:nvSpPr>
+          <p:cNvPr id="94" name="Text 92"/>
+          <p:cNvSpPr/>
+          <p:nvPr/>
+        </p:nvSpPr>
+        <p:spPr>
+          <a:xfrm>
+            <a:off x="512064" y="6588252"/>
+            <a:ext cx="3291840" cy="73152"/>
+          </a:xfrm>
+          <a:prstGeom prst="rect">
+            <a:avLst/>
+          </a:prstGeom>
+          <a:noFill/>
+          <a:ln/>
+        </p:spPr>
+        <p:txBody>
+          <a:bodyPr wrap="square" lIns="0" tIns="0" rIns="0" bIns="0" rtlCol="0" anchor="ctr">
+            <a:normAutofit/>
+          </a:bodyPr>
+          <a:lstStyle/>
+          <a:p>
+            <a:pPr algn="l" indent="0" marL="0">
+              <a:buNone/>
+            </a:pPr>
+            <a:r>
+              <a:rPr lang="en-US" sz="625" b="1" spc="65" kern="0" dirty="0">
+                <a:solidFill>
+                  <a:srgbClr val="465057"/>
+                </a:solidFill>
+                <a:latin typeface="Aptos" pitchFamily="34" charset="0"/>
+                <a:ea typeface="Aptos" pitchFamily="34" charset="-122"/>
+                <a:cs typeface="Aptos" pitchFamily="34" charset="-120"/>
+              </a:rPr>
+              <a:t>PHASE 0  |  SYNTHETIC DEMONSTRATION  |  NOT FOR OPERATIONAL CONTROL</a:t>
+            </a:r>
+            <a:endParaRPr lang="en-US" sz="625" dirty="0"/>
+          </a:p>
+        </p:txBody>
+      </p:sp>
+      <p:sp>
+        <p:nvSpPr>
+          <p:cNvPr id="95" name="Text 93"/>
+          <p:cNvSpPr/>
+          <p:nvPr/>
+        </p:nvSpPr>
+        <p:spPr>
+          <a:xfrm>
+            <a:off x="8732520" y="6588252"/>
+            <a:ext cx="3017520" cy="73152"/>
+          </a:xfrm>
+          <a:prstGeom prst="rect">
+            <a:avLst/>
+          </a:prstGeom>
+          <a:noFill/>
+          <a:ln/>
+        </p:spPr>
+        <p:txBody>
+          <a:bodyPr wrap="square" lIns="0" tIns="0" rIns="0" bIns="0" rtlCol="0" anchor="ctr">
+            <a:normAutofit/>
+          </a:bodyPr>
+          <a:lstStyle/>
+          <a:p>
+            <a:pPr algn="r" indent="0" marL="0">
+              <a:buNone/>
+            </a:pPr>
+            <a:r>
+              <a:rPr lang="en-US" sz="650" b="1" spc="50" kern="0" dirty="0">
+                <a:solidFill>
+                  <a:srgbClr val="465057"/>
+                </a:solidFill>
+                <a:latin typeface="Aptos" pitchFamily="34" charset="0"/>
+                <a:ea typeface="Aptos" pitchFamily="34" charset="-122"/>
+                <a:cs typeface="Aptos" pitchFamily="34" charset="-120"/>
+              </a:rPr>
+              <a:t>FAQ &amp; VALIDATION BACKUP  •  07 / 07</a:t>
             </a:r>
             <a:endParaRPr lang="en-US" sz="650" dirty="0"/>
           </a:p>

</xml_diff>

<commit_message>
docs(deck): add backup slide 8 — why not IoT Hub or IoT Operations
The panel will ask why an industrial platform has no IoT Hub. ADR-016 and
FAQ Q14b answer it in prose; the deck had nowhere to show it.

Adds slide 28 (FAQ/validation backup 8) to the generated oral-defense deck:
three candidates with one verdict each (Event Hubs chosen, IoT Hub rejected,
IoT Operations deferred), four reasons IoT Hub loses on our own guardrails,
and the revisit trigger — cloud-initiated action on plant equipment, which
also reopens the EU AI Act conformity assessment.

Also derives the backup-slide count in the footer from a constant instead of
the hard-coded "/ 07", and syncs the 27 -> 28 slide figures across docs.

Verified: npm run build emits 28 slides; validate_pptx.py passes
(28 slides, 799 text runs, no placeholders); slide 28 visually inspected.

Co-authored-by: Copilot <223556219+Copilot@users.noreply.github.com>
Copilot-Session: 6f86afe7-0a78-4753-8d86-653e8c200a26
</commit_message>
<xml_diff>
--- a/docs/presentation/NovaSteel-Oral-Defense.pptx
+++ b/docs/presentation/NovaSteel-Oral-Defense.pptx
@@ -32,9 +32,10 @@
     <p:sldId id="280" r:id="rId26"/>
     <p:sldId id="281" r:id="rId27"/>
     <p:sldId id="282" r:id="rId28"/>
+    <p:sldId id="283" r:id="rId29"/>
   </p:sldIdLst>
   <p:notesMasterIdLst>
-    <p:notesMasterId r:id="rId29"/>
+    <p:notesMasterId r:id="rId30"/>
   </p:notesMasterIdLst>
   <p:sldSz cx="12191695" cy="6858000"/>
   <p:notesSz cx="6858000" cy="12191695"/>
@@ -2242,6 +2243,94 @@
 </p:notes>
 </file>
 
+<file path=ppt/notesSlides/notesSlide28.xml><?xml version="1.0" encoding="utf-8"?>
+<p:notes xmlns:a="http://schemas.openxmlformats.org/drawingml/2006/main" xmlns:r="http://schemas.openxmlformats.org/officeDocument/2006/relationships" xmlns:p="http://schemas.openxmlformats.org/presentationml/2006/main">
+  <p:cSld>
+    <p:spTree>
+      <p:nvGrpSpPr>
+        <p:cNvPr id="1" name=""/>
+        <p:cNvGrpSpPr/>
+        <p:nvPr/>
+      </p:nvGrpSpPr>
+      <p:grpSpPr>
+        <a:xfrm>
+          <a:off x="0" y="0"/>
+          <a:ext cx="0" cy="0"/>
+          <a:chOff x="0" y="0"/>
+          <a:chExt cx="0" cy="0"/>
+        </a:xfrm>
+      </p:grpSpPr>
+      <p:sp>
+        <p:nvSpPr>
+          <p:cNvPr id="2" name="Slide Image Placeholder 1"/>
+          <p:cNvSpPr>
+            <a:spLocks noGrp="1" noRot="1" noChangeAspect="1"/>
+          </p:cNvSpPr>
+          <p:nvPr>
+            <p:ph type="sldImg"/>
+          </p:nvPr>
+        </p:nvSpPr>
+        <p:spPr/>
+      </p:sp>
+      <p:sp>
+        <p:nvSpPr>
+          <p:cNvPr id="3" name="Notes Placeholder 2"/>
+          <p:cNvSpPr>
+            <a:spLocks noGrp="1"/>
+          </p:cNvSpPr>
+          <p:nvPr>
+            <p:ph type="body" idx="1"/>
+          </p:nvPr>
+        </p:nvSpPr>
+        <p:spPr/>
+        <p:txBody>
+          <a:bodyPr/>
+          <a:lstStyle/>
+          <a:p>
+            <a:r>
+              <a:rPr lang="en-US" dirty="0"/>
+              <a:t>If the panel knows industrial Azure, this is the first question they ask: these are furnaces, so why is there no IoT Hub?,Because what IoT Hub adds over Event Hubs is a cloud-to-device control plane — device provisioning, twins, direct methods, jobs. Every one of those is an inbound path into the plant. Our advisory boundary is an acceptance criterion, not a gap, so we would be buying a capability we must never use, disabling it, and then carrying the burden of proving it stays disabled in every threat model review. Event Hubs simply cannot do it.,It would also cost us the no-standing-secret property. Our namespace runs with local authentication disabled, behind a private endpoint, and each plant gateway identity can write to exactly one hub. IoT Hub authenticates devices with per-device keys or certificates, and Fabric's IoT Hub source connector is a shared-access-policy connection — the exact pattern ADR-005 exists to eliminate.,And the shape is wrong: we have four plant gateways, not a fleet of thousands. Device identity already lives in the event envelope and in Device Operations.,The honest forward-looking answer is that if the OT edge itself ever comes into scope, the strategic path in 2026 is Azure IoT Operations — Arc-enabled, MQTT broker, OPC UA connector, native to Fabric. Not IoT Hub. Moving to IoT Hub today would be adopting the older device-centric service to solve a problem we do not have.</a:t>
+            </a:r>
+            <a:endParaRPr lang="en-US" dirty="0"/>
+          </a:p>
+        </p:txBody>
+      </p:sp>
+      <p:sp>
+        <p:nvSpPr>
+          <p:cNvPr id="4" name="Slide Number Placeholder 3"/>
+          <p:cNvSpPr>
+            <a:spLocks noGrp="1"/>
+          </p:cNvSpPr>
+          <p:nvPr>
+            <p:ph type="sldNum" sz="quarter" idx="10"/>
+          </p:nvPr>
+        </p:nvSpPr>
+        <p:spPr/>
+        <p:txBody>
+          <a:bodyPr/>
+          <a:lstStyle/>
+          <a:p>
+            <a:fld id="{F7021451-1387-4CA6-816F-3879F97B5CBC}" type="slidenum">
+              <a:rPr lang="en-US"/>
+              <a:t>28</a:t>
+            </a:fld>
+            <a:endParaRPr lang="en-US"/>
+          </a:p>
+        </p:txBody>
+      </p:sp>
+    </p:spTree>
+    <p:extLst>
+      <p:ext uri="{BB962C8B-B14F-4D97-AF65-F5344CB8AC3E}">
+        <p14:creationId xmlns:p14="http://schemas.microsoft.com/office/powerpoint/2010/main" val="1024086991"/>
+      </p:ext>
+    </p:extLst>
+  </p:cSld>
+  <p:clrMapOvr>
+    <a:masterClrMapping/>
+  </p:clrMapOvr>
+</p:notes>
+</file>
+
 <file path=ppt/notesSlides/notesSlide3.xml><?xml version="1.0" encoding="utf-8"?>
 <p:notes xmlns:a="http://schemas.openxmlformats.org/drawingml/2006/main" xmlns:r="http://schemas.openxmlformats.org/officeDocument/2006/relationships" xmlns:p="http://schemas.openxmlformats.org/presentationml/2006/main">
   <p:cSld>
@@ -27673,7 +27762,7 @@
                 <a:ea typeface="Aptos" pitchFamily="34" charset="-122"/>
                 <a:cs typeface="Aptos" pitchFamily="34" charset="-120"/>
               </a:rPr>
-              <a:t>FAQ &amp; VALIDATION BACKUP  •  01 / 07</a:t>
+              <a:t>FAQ &amp; VALIDATION BACKUP  •  01 / 08</a:t>
             </a:r>
             <a:endParaRPr lang="en-US" sz="650" dirty="0"/>
           </a:p>
@@ -28629,7 +28718,7 @@
                 <a:ea typeface="Aptos" pitchFamily="34" charset="-122"/>
                 <a:cs typeface="Aptos" pitchFamily="34" charset="-120"/>
               </a:rPr>
-              <a:t>FAQ &amp; VALIDATION BACKUP  •  02 / 07</a:t>
+              <a:t>FAQ &amp; VALIDATION BACKUP  •  02 / 08</a:t>
             </a:r>
             <a:endParaRPr lang="en-US" sz="650" dirty="0"/>
           </a:p>
@@ -30028,7 +30117,7 @@
                 <a:ea typeface="Aptos" pitchFamily="34" charset="-122"/>
                 <a:cs typeface="Aptos" pitchFamily="34" charset="-120"/>
               </a:rPr>
-              <a:t>FAQ &amp; VALIDATION BACKUP  •  03 / 07</a:t>
+              <a:t>FAQ &amp; VALIDATION BACKUP  •  03 / 08</a:t>
             </a:r>
             <a:endParaRPr lang="en-US" sz="650" dirty="0"/>
           </a:p>
@@ -31265,7 +31354,7 @@
                 <a:ea typeface="Aptos" pitchFamily="34" charset="-122"/>
                 <a:cs typeface="Aptos" pitchFamily="34" charset="-120"/>
               </a:rPr>
-              <a:t>FAQ &amp; VALIDATION BACKUP  •  04 / 07</a:t>
+              <a:t>FAQ &amp; VALIDATION BACKUP  •  04 / 08</a:t>
             </a:r>
             <a:endParaRPr lang="en-US" sz="650" dirty="0"/>
           </a:p>
@@ -32332,7 +32421,7 @@
                 <a:ea typeface="Aptos" pitchFamily="34" charset="-122"/>
                 <a:cs typeface="Aptos" pitchFamily="34" charset="-120"/>
               </a:rPr>
-              <a:t>FAQ &amp; VALIDATION BACKUP  •  05 / 07</a:t>
+              <a:t>FAQ &amp; VALIDATION BACKUP  •  05 / 08</a:t>
             </a:r>
             <a:endParaRPr lang="en-US" sz="650" dirty="0"/>
           </a:p>
@@ -33742,7 +33831,7 @@
                 <a:ea typeface="Aptos" pitchFamily="34" charset="-122"/>
                 <a:cs typeface="Aptos" pitchFamily="34" charset="-120"/>
               </a:rPr>
-              <a:t>FAQ &amp; VALIDATION BACKUP  •  06 / 07</a:t>
+              <a:t>FAQ &amp; VALIDATION BACKUP  •  06 / 08</a:t>
             </a:r>
             <a:endParaRPr lang="en-US" sz="650" dirty="0"/>
           </a:p>
@@ -36912,7 +37001,2285 @@
                 <a:ea typeface="Aptos" pitchFamily="34" charset="-122"/>
                 <a:cs typeface="Aptos" pitchFamily="34" charset="-120"/>
               </a:rPr>
-              <a:t>FAQ &amp; VALIDATION BACKUP  •  07 / 07</a:t>
+              <a:t>FAQ &amp; VALIDATION BACKUP  •  07 / 08</a:t>
+            </a:r>
+            <a:endParaRPr lang="en-US" sz="650" dirty="0"/>
+          </a:p>
+        </p:txBody>
+      </p:sp>
+    </p:spTree>
+  </p:cSld>
+  <p:clrMapOvr>
+    <a:masterClrMapping/>
+  </p:clrMapOvr>
+</p:sld>
+</file>
+
+<file path=ppt/slides/slide28.xml><?xml version="1.0" encoding="utf-8"?>
+<p:sld xmlns:a="http://schemas.openxmlformats.org/drawingml/2006/main" xmlns:r="http://schemas.openxmlformats.org/officeDocument/2006/relationships" xmlns:p="http://schemas.openxmlformats.org/presentationml/2006/main">
+  <p:cSld name="Slide 28">
+    <p:bg>
+      <p:bgPr>
+        <a:solidFill>
+          <a:srgbClr val="121719"/>
+        </a:solidFill>
+      </p:bgPr>
+    </p:bg>
+    <p:spTree>
+      <p:nvGrpSpPr>
+        <p:cNvPr id="1" name=""/>
+        <p:cNvGrpSpPr/>
+        <p:nvPr/>
+      </p:nvGrpSpPr>
+      <p:grpSpPr>
+        <a:xfrm>
+          <a:off x="0" y="0"/>
+          <a:ext cx="0" cy="0"/>
+          <a:chOff x="0" y="0"/>
+          <a:chExt cx="0" cy="0"/>
+        </a:xfrm>
+      </p:grpSpPr>
+      <p:pic>
+        <p:nvPicPr>
+          <p:cNvPr id="2" name="Image 0" descr="D:\work\20260724 - Novasteel 3\tools\presentation\assets\steel-texture.png">    </p:cNvPr>
+          <p:cNvPicPr>
+            <a:picLocks noChangeAspect="1"/>
+          </p:cNvPicPr>
+          <p:nvPr/>
+        </p:nvPicPr>
+        <p:blipFill>
+          <a:blip r:embed="rId1">
+            <a:alphaModFix amt="34000"/>
+          </a:blip>
+          <a:stretch>
+            <a:fillRect/>
+          </a:stretch>
+        </p:blipFill>
+        <p:spPr>
+          <a:xfrm>
+            <a:off x="0" y="0"/>
+            <a:ext cx="12191695" cy="6858000"/>
+          </a:xfrm>
+          <a:prstGeom prst="rect">
+            <a:avLst/>
+          </a:prstGeom>
+        </p:spPr>
+      </p:pic>
+      <p:sp>
+        <p:nvSpPr>
+          <p:cNvPr id="3" name="Shape 0"/>
+          <p:cNvSpPr/>
+          <p:nvPr/>
+        </p:nvSpPr>
+        <p:spPr>
+          <a:xfrm>
+            <a:off x="457200" y="274320"/>
+            <a:ext cx="822960" cy="246888"/>
+          </a:xfrm>
+          <a:prstGeom prst="roundRect">
+            <a:avLst/>
+          </a:prstGeom>
+          <a:solidFill>
+            <a:srgbClr val="7A261C"/>
+          </a:solidFill>
+          <a:ln w="5080">
+            <a:solidFill>
+              <a:srgbClr val="7A261C"/>
+            </a:solidFill>
+            <a:prstDash val="solid"/>
+          </a:ln>
+        </p:spPr>
+      </p:sp>
+      <p:sp>
+        <p:nvSpPr>
+          <p:cNvPr id="4" name="Text 1"/>
+          <p:cNvSpPr/>
+          <p:nvPr/>
+        </p:nvSpPr>
+        <p:spPr>
+          <a:xfrm>
+            <a:off x="576072" y="324612"/>
+            <a:ext cx="585216" cy="118872"/>
+          </a:xfrm>
+          <a:prstGeom prst="rect">
+            <a:avLst/>
+          </a:prstGeom>
+          <a:noFill/>
+          <a:ln/>
+        </p:spPr>
+        <p:txBody>
+          <a:bodyPr wrap="square" lIns="0" tIns="0" rIns="0" bIns="0" rtlCol="0" anchor="ctr">
+            <a:normAutofit/>
+          </a:bodyPr>
+          <a:lstStyle/>
+          <a:p>
+            <a:pPr algn="l" indent="0" marL="0">
+              <a:buNone/>
+            </a:pPr>
+            <a:r>
+              <a:rPr lang="en-US" sz="720" b="1" spc="110" kern="0" dirty="0">
+                <a:solidFill>
+                  <a:srgbClr val="FFFFFF"/>
+                </a:solidFill>
+                <a:latin typeface="Aptos" pitchFamily="34" charset="0"/>
+                <a:ea typeface="Aptos" pitchFamily="34" charset="-122"/>
+                <a:cs typeface="Aptos" pitchFamily="34" charset="-120"/>
+              </a:rPr>
+              <a:t>BACKUP 8</a:t>
+            </a:r>
+            <a:endParaRPr lang="en-US" sz="720" dirty="0"/>
+          </a:p>
+        </p:txBody>
+      </p:sp>
+      <p:sp>
+        <p:nvSpPr>
+          <p:cNvPr id="5" name="Text 2"/>
+          <p:cNvSpPr/>
+          <p:nvPr/>
+        </p:nvSpPr>
+        <p:spPr>
+          <a:xfrm>
+            <a:off x="1508760" y="310896"/>
+            <a:ext cx="6309360" cy="164592"/>
+          </a:xfrm>
+          <a:prstGeom prst="rect">
+            <a:avLst/>
+          </a:prstGeom>
+          <a:noFill/>
+          <a:ln/>
+        </p:spPr>
+        <p:txBody>
+          <a:bodyPr wrap="square" lIns="0" tIns="0" rIns="0" bIns="0" rtlCol="0" anchor="ctr">
+            <a:normAutofit/>
+          </a:bodyPr>
+          <a:lstStyle/>
+          <a:p>
+            <a:pPr algn="l" indent="0" marL="0">
+              <a:buNone/>
+            </a:pPr>
+            <a:r>
+              <a:rPr lang="en-US" sz="810" b="1" spc="130" kern="0" dirty="0">
+                <a:solidFill>
+                  <a:srgbClr val="AEB9BA"/>
+                </a:solidFill>
+                <a:latin typeface="Aptos" pitchFamily="34" charset="0"/>
+                <a:ea typeface="Aptos" pitchFamily="34" charset="-122"/>
+                <a:cs typeface="Aptos" pitchFamily="34" charset="-120"/>
+              </a:rPr>
+              <a:t>ARCHITECTURE DECISION ADR-016</a:t>
+            </a:r>
+            <a:endParaRPr lang="en-US" sz="810" dirty="0"/>
+          </a:p>
+        </p:txBody>
+      </p:sp>
+      <p:sp>
+        <p:nvSpPr>
+          <p:cNvPr id="6" name="Text 3"/>
+          <p:cNvSpPr/>
+          <p:nvPr/>
+        </p:nvSpPr>
+        <p:spPr>
+          <a:xfrm>
+            <a:off x="457200" y="630936"/>
+            <a:ext cx="11109960" cy="429768"/>
+          </a:xfrm>
+          <a:prstGeom prst="rect">
+            <a:avLst/>
+          </a:prstGeom>
+          <a:noFill/>
+          <a:ln/>
+        </p:spPr>
+        <p:txBody>
+          <a:bodyPr wrap="square" lIns="0" tIns="0" rIns="0" bIns="0" rtlCol="0" anchor="ctr">
+            <a:normAutofit/>
+          </a:bodyPr>
+          <a:lstStyle/>
+          <a:p>
+            <a:pPr algn="l" indent="0" marL="0">
+              <a:buNone/>
+            </a:pPr>
+            <a:r>
+              <a:rPr lang="en-US" sz="2550" b="1" dirty="0">
+                <a:solidFill>
+                  <a:srgbClr val="FFFFFF"/>
+                </a:solidFill>
+                <a:latin typeface="Bahnschrift SemiBold" pitchFamily="34" charset="0"/>
+                <a:ea typeface="Bahnschrift SemiBold" pitchFamily="34" charset="-122"/>
+                <a:cs typeface="Bahnschrift SemiBold" pitchFamily="34" charset="-120"/>
+              </a:rPr>
+              <a:t>Why not Azure IoT Hub — or IoT Operations?</a:t>
+            </a:r>
+            <a:endParaRPr lang="en-US" sz="2550" dirty="0"/>
+          </a:p>
+        </p:txBody>
+      </p:sp>
+      <p:sp>
+        <p:nvSpPr>
+          <p:cNvPr id="7" name="Shape 4"/>
+          <p:cNvSpPr/>
+          <p:nvPr/>
+        </p:nvSpPr>
+        <p:spPr>
+          <a:xfrm>
+            <a:off x="457200" y="1188720"/>
+            <a:ext cx="1371600" cy="246888"/>
+          </a:xfrm>
+          <a:prstGeom prst="roundRect">
+            <a:avLst/>
+          </a:prstGeom>
+          <a:solidFill>
+            <a:srgbClr val="B64A2D"/>
+          </a:solidFill>
+          <a:ln w="5080">
+            <a:solidFill>
+              <a:srgbClr val="B64A2D"/>
+            </a:solidFill>
+            <a:prstDash val="solid"/>
+          </a:ln>
+        </p:spPr>
+      </p:sp>
+      <p:sp>
+        <p:nvSpPr>
+          <p:cNvPr id="8" name="Text 5"/>
+          <p:cNvSpPr/>
+          <p:nvPr/>
+        </p:nvSpPr>
+        <p:spPr>
+          <a:xfrm>
+            <a:off x="576072" y="1239012"/>
+            <a:ext cx="1133856" cy="118872"/>
+          </a:xfrm>
+          <a:prstGeom prst="rect">
+            <a:avLst/>
+          </a:prstGeom>
+          <a:noFill/>
+          <a:ln/>
+        </p:spPr>
+        <p:txBody>
+          <a:bodyPr wrap="square" lIns="0" tIns="0" rIns="0" bIns="0" rtlCol="0" anchor="ctr">
+            <a:normAutofit/>
+          </a:bodyPr>
+          <a:lstStyle/>
+          <a:p>
+            <a:pPr algn="l" indent="0" marL="0">
+              <a:buNone/>
+            </a:pPr>
+            <a:r>
+              <a:rPr lang="en-US" sz="720" b="1" spc="110" kern="0" dirty="0">
+                <a:solidFill>
+                  <a:srgbClr val="FFFFFF"/>
+                </a:solidFill>
+                <a:latin typeface="Aptos" pitchFamily="34" charset="0"/>
+                <a:ea typeface="Aptos" pitchFamily="34" charset="-122"/>
+                <a:cs typeface="Aptos" pitchFamily="34" charset="-120"/>
+              </a:rPr>
+              <a:t>INGRESS DEFENSE</a:t>
+            </a:r>
+            <a:endParaRPr lang="en-US" sz="720" dirty="0"/>
+          </a:p>
+        </p:txBody>
+      </p:sp>
+      <p:sp>
+        <p:nvSpPr>
+          <p:cNvPr id="9" name="Text 6"/>
+          <p:cNvSpPr/>
+          <p:nvPr/>
+        </p:nvSpPr>
+        <p:spPr>
+          <a:xfrm>
+            <a:off x="1947672" y="1220724"/>
+            <a:ext cx="7863840" cy="164592"/>
+          </a:xfrm>
+          <a:prstGeom prst="rect">
+            <a:avLst/>
+          </a:prstGeom>
+          <a:noFill/>
+          <a:ln/>
+        </p:spPr>
+        <p:txBody>
+          <a:bodyPr wrap="square" lIns="0" tIns="0" rIns="0" bIns="0" rtlCol="0" anchor="ctr">
+            <a:normAutofit/>
+          </a:bodyPr>
+          <a:lstStyle/>
+          <a:p>
+            <a:pPr algn="l" indent="0" marL="0">
+              <a:buNone/>
+            </a:pPr>
+            <a:r>
+              <a:rPr lang="en-US" sz="840" b="1" dirty="0">
+                <a:solidFill>
+                  <a:srgbClr val="AEB9BA"/>
+                </a:solidFill>
+                <a:latin typeface="Aptos" pitchFamily="34" charset="0"/>
+                <a:ea typeface="Aptos" pitchFamily="34" charset="-122"/>
+                <a:cs typeface="Aptos" pitchFamily="34" charset="-120"/>
+              </a:rPr>
+              <a:t>The ingress can only receive. Choosing a device-management service would buy us the inbound control plane we promised not to build.</a:t>
+            </a:r>
+            <a:endParaRPr lang="en-US" sz="840" dirty="0"/>
+          </a:p>
+        </p:txBody>
+      </p:sp>
+      <p:sp>
+        <p:nvSpPr>
+          <p:cNvPr id="10" name="Text 7"/>
+          <p:cNvSpPr/>
+          <p:nvPr/>
+        </p:nvSpPr>
+        <p:spPr>
+          <a:xfrm>
+            <a:off x="457200" y="1627632"/>
+            <a:ext cx="3840480" cy="146304"/>
+          </a:xfrm>
+          <a:prstGeom prst="rect">
+            <a:avLst/>
+          </a:prstGeom>
+          <a:noFill/>
+          <a:ln/>
+        </p:spPr>
+        <p:txBody>
+          <a:bodyPr wrap="square" lIns="0" tIns="0" rIns="0" bIns="0" rtlCol="0" anchor="ctr">
+            <a:normAutofit/>
+          </a:bodyPr>
+          <a:lstStyle/>
+          <a:p>
+            <a:pPr algn="l" indent="0" marL="0">
+              <a:buNone/>
+            </a:pPr>
+            <a:r>
+              <a:rPr lang="en-US" sz="720" b="1" spc="120" kern="0" dirty="0">
+                <a:solidFill>
+                  <a:srgbClr val="AEB9BA"/>
+                </a:solidFill>
+                <a:latin typeface="Aptos" pitchFamily="34" charset="0"/>
+                <a:ea typeface="Aptos" pitchFamily="34" charset="-122"/>
+                <a:cs typeface="Aptos" pitchFamily="34" charset="-120"/>
+              </a:rPr>
+              <a:t>THREE CANDIDATES, ONE VERDICT EACH</a:t>
+            </a:r>
+            <a:endParaRPr lang="en-US" sz="720" dirty="0"/>
+          </a:p>
+        </p:txBody>
+      </p:sp>
+      <p:sp>
+        <p:nvSpPr>
+          <p:cNvPr id="11" name="Shape 8"/>
+          <p:cNvSpPr/>
+          <p:nvPr/>
+        </p:nvSpPr>
+        <p:spPr>
+          <a:xfrm>
+            <a:off x="457200" y="1819656"/>
+            <a:ext cx="5623560" cy="1078992"/>
+          </a:xfrm>
+          <a:prstGeom prst="roundRect">
+            <a:avLst/>
+          </a:prstGeom>
+          <a:solidFill>
+            <a:srgbClr val="1F2426"/>
+          </a:solidFill>
+          <a:ln w="11430">
+            <a:solidFill>
+              <a:srgbClr val="147D74"/>
+            </a:solidFill>
+            <a:prstDash val="solid"/>
+          </a:ln>
+        </p:spPr>
+      </p:sp>
+      <p:sp>
+        <p:nvSpPr>
+          <p:cNvPr id="12" name="Shape 9"/>
+          <p:cNvSpPr/>
+          <p:nvPr/>
+        </p:nvSpPr>
+        <p:spPr>
+          <a:xfrm>
+            <a:off x="457200" y="1819656"/>
+            <a:ext cx="77724" cy="1078992"/>
+          </a:xfrm>
+          <a:prstGeom prst="rect">
+            <a:avLst/>
+          </a:prstGeom>
+          <a:solidFill>
+            <a:srgbClr val="147D74"/>
+          </a:solidFill>
+          <a:ln w="6350">
+            <a:solidFill>
+              <a:srgbClr val="147D74"/>
+            </a:solidFill>
+            <a:prstDash val="solid"/>
+          </a:ln>
+        </p:spPr>
+      </p:sp>
+      <p:sp>
+        <p:nvSpPr>
+          <p:cNvPr id="13" name="Text 10"/>
+          <p:cNvSpPr/>
+          <p:nvPr/>
+        </p:nvSpPr>
+        <p:spPr>
+          <a:xfrm>
+            <a:off x="713232" y="1975104"/>
+            <a:ext cx="3200400" cy="128016"/>
+          </a:xfrm>
+          <a:prstGeom prst="rect">
+            <a:avLst/>
+          </a:prstGeom>
+          <a:noFill/>
+          <a:ln/>
+        </p:spPr>
+        <p:txBody>
+          <a:bodyPr wrap="square" lIns="0" tIns="0" rIns="0" bIns="0" rtlCol="0" anchor="ctr">
+            <a:normAutofit/>
+          </a:bodyPr>
+          <a:lstStyle/>
+          <a:p>
+            <a:pPr algn="l" indent="0" marL="0">
+              <a:buNone/>
+            </a:pPr>
+            <a:r>
+              <a:rPr lang="en-US" sz="940" b="1" spc="60" kern="0" dirty="0">
+                <a:solidFill>
+                  <a:srgbClr val="FFFFFF"/>
+                </a:solidFill>
+                <a:latin typeface="Aptos" pitchFamily="34" charset="0"/>
+                <a:ea typeface="Aptos" pitchFamily="34" charset="-122"/>
+                <a:cs typeface="Aptos" pitchFamily="34" charset="-120"/>
+              </a:rPr>
+              <a:t>AZURE EVENT HUBS</a:t>
+            </a:r>
+            <a:endParaRPr lang="en-US" sz="940" dirty="0"/>
+          </a:p>
+        </p:txBody>
+      </p:sp>
+      <p:sp>
+        <p:nvSpPr>
+          <p:cNvPr id="14" name="Shape 11"/>
+          <p:cNvSpPr/>
+          <p:nvPr/>
+        </p:nvSpPr>
+        <p:spPr>
+          <a:xfrm>
+            <a:off x="4864608" y="1947672"/>
+            <a:ext cx="1014984" cy="219456"/>
+          </a:xfrm>
+          <a:prstGeom prst="roundRect">
+            <a:avLst/>
+          </a:prstGeom>
+          <a:solidFill>
+            <a:srgbClr val="147D74"/>
+          </a:solidFill>
+          <a:ln w="5080">
+            <a:solidFill>
+              <a:srgbClr val="147D74"/>
+            </a:solidFill>
+            <a:prstDash val="solid"/>
+          </a:ln>
+        </p:spPr>
+      </p:sp>
+      <p:sp>
+        <p:nvSpPr>
+          <p:cNvPr id="15" name="Text 12"/>
+          <p:cNvSpPr/>
+          <p:nvPr/>
+        </p:nvSpPr>
+        <p:spPr>
+          <a:xfrm>
+            <a:off x="4910328" y="2025396"/>
+            <a:ext cx="923544" cy="82296"/>
+          </a:xfrm>
+          <a:prstGeom prst="rect">
+            <a:avLst/>
+          </a:prstGeom>
+          <a:noFill/>
+          <a:ln/>
+        </p:spPr>
+        <p:txBody>
+          <a:bodyPr wrap="square" lIns="0" tIns="0" rIns="0" bIns="0" rtlCol="0" anchor="ctr">
+            <a:normAutofit/>
+          </a:bodyPr>
+          <a:lstStyle/>
+          <a:p>
+            <a:pPr algn="ctr" indent="0" marL="0">
+              <a:buNone/>
+            </a:pPr>
+            <a:r>
+              <a:rPr lang="en-US" sz="640" b="1" dirty="0">
+                <a:solidFill>
+                  <a:srgbClr val="121719"/>
+                </a:solidFill>
+                <a:latin typeface="Aptos" pitchFamily="34" charset="0"/>
+                <a:ea typeface="Aptos" pitchFamily="34" charset="-122"/>
+                <a:cs typeface="Aptos" pitchFamily="34" charset="-120"/>
+              </a:rPr>
+              <a:t>CHOSEN</a:t>
+            </a:r>
+            <a:endParaRPr lang="en-US" sz="640" dirty="0"/>
+          </a:p>
+        </p:txBody>
+      </p:sp>
+      <p:sp>
+        <p:nvSpPr>
+          <p:cNvPr id="16" name="Text 13"/>
+          <p:cNvSpPr/>
+          <p:nvPr/>
+        </p:nvSpPr>
+        <p:spPr>
+          <a:xfrm>
+            <a:off x="713232" y="2240280"/>
+            <a:ext cx="5120640" cy="457200"/>
+          </a:xfrm>
+          <a:prstGeom prst="rect">
+            <a:avLst/>
+          </a:prstGeom>
+          <a:noFill/>
+          <a:ln/>
+        </p:spPr>
+        <p:txBody>
+          <a:bodyPr wrap="square" lIns="0" tIns="0" rIns="0" bIns="0" rtlCol="0" anchor="t">
+            <a:normAutofit/>
+          </a:bodyPr>
+          <a:lstStyle/>
+          <a:p>
+            <a:pPr algn="l" indent="0" marL="0">
+              <a:buNone/>
+            </a:pPr>
+            <a:r>
+              <a:rPr lang="en-US" sz="760" dirty="0">
+                <a:solidFill>
+                  <a:srgbClr val="AEB9BA"/>
+                </a:solidFill>
+                <a:latin typeface="Aptos" pitchFamily="34" charset="0"/>
+                <a:ea typeface="Aptos" pitchFamily="34" charset="-122"/>
+                <a:cs typeface="Aptos" pitchFamily="34" charset="-120"/>
+              </a:rPr>
+              <a:t>Outbound-only buffer, one hub per plant. Local auth disabled, private endpoint, and each mi-ns-otgw-&lt;plant&gt; identity scoped to its own hub — not the namespace. The relay then publishes to the Fabric Eventstream Custom Endpoint with a workload identity.</a:t>
+            </a:r>
+            <a:endParaRPr lang="en-US" sz="760" dirty="0"/>
+          </a:p>
+        </p:txBody>
+      </p:sp>
+      <p:sp>
+        <p:nvSpPr>
+          <p:cNvPr id="17" name="Shape 14"/>
+          <p:cNvSpPr/>
+          <p:nvPr/>
+        </p:nvSpPr>
+        <p:spPr>
+          <a:xfrm>
+            <a:off x="713232" y="2679192"/>
+            <a:ext cx="5120640" cy="0"/>
+          </a:xfrm>
+          <a:prstGeom prst="line">
+            <a:avLst/>
+          </a:prstGeom>
+          <a:noFill/>
+          <a:ln w="7620">
+            <a:solidFill>
+              <a:srgbClr val="465057"/>
+            </a:solidFill>
+            <a:prstDash val="solid"/>
+          </a:ln>
+        </p:spPr>
+      </p:sp>
+      <p:sp>
+        <p:nvSpPr>
+          <p:cNvPr id="18" name="Text 15"/>
+          <p:cNvSpPr/>
+          <p:nvPr/>
+        </p:nvSpPr>
+        <p:spPr>
+          <a:xfrm>
+            <a:off x="713232" y="2720340"/>
+            <a:ext cx="5120640" cy="91440"/>
+          </a:xfrm>
+          <a:prstGeom prst="rect">
+            <a:avLst/>
+          </a:prstGeom>
+          <a:noFill/>
+          <a:ln/>
+        </p:spPr>
+        <p:txBody>
+          <a:bodyPr wrap="square" lIns="0" tIns="0" rIns="0" bIns="0" rtlCol="0" anchor="ctr">
+            <a:normAutofit/>
+          </a:bodyPr>
+          <a:lstStyle/>
+          <a:p>
+            <a:pPr algn="l" indent="0" marL="0">
+              <a:buNone/>
+            </a:pPr>
+            <a:r>
+              <a:rPr lang="en-US" sz="660" dirty="0">
+                <a:solidFill>
+                  <a:srgbClr val="DDE4E1"/>
+                </a:solidFill>
+                <a:latin typeface="Consolas" pitchFamily="34" charset="0"/>
+                <a:ea typeface="Consolas" pitchFamily="34" charset="-122"/>
+                <a:cs typeface="Consolas" pitchFamily="34" charset="-120"/>
+              </a:rPr>
+              <a:t>1 TU  ·  disableLocalAuth: true  ·  private endpoint  ·  per-hub Data Sender</a:t>
+            </a:r>
+            <a:endParaRPr lang="en-US" sz="660" dirty="0"/>
+          </a:p>
+        </p:txBody>
+      </p:sp>
+      <p:sp>
+        <p:nvSpPr>
+          <p:cNvPr id="19" name="Shape 16"/>
+          <p:cNvSpPr/>
+          <p:nvPr/>
+        </p:nvSpPr>
+        <p:spPr>
+          <a:xfrm>
+            <a:off x="457200" y="3008376"/>
+            <a:ext cx="5623560" cy="1078992"/>
+          </a:xfrm>
+          <a:prstGeom prst="roundRect">
+            <a:avLst/>
+          </a:prstGeom>
+          <a:solidFill>
+            <a:srgbClr val="1F2426"/>
+          </a:solidFill>
+          <a:ln w="11430">
+            <a:solidFill>
+              <a:srgbClr val="B64A2D"/>
+            </a:solidFill>
+            <a:prstDash val="solid"/>
+          </a:ln>
+        </p:spPr>
+      </p:sp>
+      <p:sp>
+        <p:nvSpPr>
+          <p:cNvPr id="20" name="Shape 17"/>
+          <p:cNvSpPr/>
+          <p:nvPr/>
+        </p:nvSpPr>
+        <p:spPr>
+          <a:xfrm>
+            <a:off x="457200" y="3008376"/>
+            <a:ext cx="77724" cy="1078992"/>
+          </a:xfrm>
+          <a:prstGeom prst="rect">
+            <a:avLst/>
+          </a:prstGeom>
+          <a:solidFill>
+            <a:srgbClr val="B64A2D"/>
+          </a:solidFill>
+          <a:ln w="6350">
+            <a:solidFill>
+              <a:srgbClr val="B64A2D"/>
+            </a:solidFill>
+            <a:prstDash val="solid"/>
+          </a:ln>
+        </p:spPr>
+      </p:sp>
+      <p:sp>
+        <p:nvSpPr>
+          <p:cNvPr id="21" name="Text 18"/>
+          <p:cNvSpPr/>
+          <p:nvPr/>
+        </p:nvSpPr>
+        <p:spPr>
+          <a:xfrm>
+            <a:off x="713232" y="3163824"/>
+            <a:ext cx="3200400" cy="128016"/>
+          </a:xfrm>
+          <a:prstGeom prst="rect">
+            <a:avLst/>
+          </a:prstGeom>
+          <a:noFill/>
+          <a:ln/>
+        </p:spPr>
+        <p:txBody>
+          <a:bodyPr wrap="square" lIns="0" tIns="0" rIns="0" bIns="0" rtlCol="0" anchor="ctr">
+            <a:normAutofit/>
+          </a:bodyPr>
+          <a:lstStyle/>
+          <a:p>
+            <a:pPr algn="l" indent="0" marL="0">
+              <a:buNone/>
+            </a:pPr>
+            <a:r>
+              <a:rPr lang="en-US" sz="940" b="1" spc="60" kern="0" dirty="0">
+                <a:solidFill>
+                  <a:srgbClr val="FFFFFF"/>
+                </a:solidFill>
+                <a:latin typeface="Aptos" pitchFamily="34" charset="0"/>
+                <a:ea typeface="Aptos" pitchFamily="34" charset="-122"/>
+                <a:cs typeface="Aptos" pitchFamily="34" charset="-120"/>
+              </a:rPr>
+              <a:t>AZURE IOT HUB</a:t>
+            </a:r>
+            <a:endParaRPr lang="en-US" sz="940" dirty="0"/>
+          </a:p>
+        </p:txBody>
+      </p:sp>
+      <p:sp>
+        <p:nvSpPr>
+          <p:cNvPr id="22" name="Shape 19"/>
+          <p:cNvSpPr/>
+          <p:nvPr/>
+        </p:nvSpPr>
+        <p:spPr>
+          <a:xfrm>
+            <a:off x="4864608" y="3136392"/>
+            <a:ext cx="1014984" cy="219456"/>
+          </a:xfrm>
+          <a:prstGeom prst="roundRect">
+            <a:avLst/>
+          </a:prstGeom>
+          <a:solidFill>
+            <a:srgbClr val="B64A2D"/>
+          </a:solidFill>
+          <a:ln w="5080">
+            <a:solidFill>
+              <a:srgbClr val="B64A2D"/>
+            </a:solidFill>
+            <a:prstDash val="solid"/>
+          </a:ln>
+        </p:spPr>
+      </p:sp>
+      <p:sp>
+        <p:nvSpPr>
+          <p:cNvPr id="23" name="Text 20"/>
+          <p:cNvSpPr/>
+          <p:nvPr/>
+        </p:nvSpPr>
+        <p:spPr>
+          <a:xfrm>
+            <a:off x="4910328" y="3214116"/>
+            <a:ext cx="923544" cy="82296"/>
+          </a:xfrm>
+          <a:prstGeom prst="rect">
+            <a:avLst/>
+          </a:prstGeom>
+          <a:noFill/>
+          <a:ln/>
+        </p:spPr>
+        <p:txBody>
+          <a:bodyPr wrap="square" lIns="0" tIns="0" rIns="0" bIns="0" rtlCol="0" anchor="ctr">
+            <a:normAutofit/>
+          </a:bodyPr>
+          <a:lstStyle/>
+          <a:p>
+            <a:pPr algn="ctr" indent="0" marL="0">
+              <a:buNone/>
+            </a:pPr>
+            <a:r>
+              <a:rPr lang="en-US" sz="640" b="1" dirty="0">
+                <a:solidFill>
+                  <a:srgbClr val="121719"/>
+                </a:solidFill>
+                <a:latin typeface="Aptos" pitchFamily="34" charset="0"/>
+                <a:ea typeface="Aptos" pitchFamily="34" charset="-122"/>
+                <a:cs typeface="Aptos" pitchFamily="34" charset="-120"/>
+              </a:rPr>
+              <a:t>REJECTED</a:t>
+            </a:r>
+            <a:endParaRPr lang="en-US" sz="640" dirty="0"/>
+          </a:p>
+        </p:txBody>
+      </p:sp>
+      <p:sp>
+        <p:nvSpPr>
+          <p:cNvPr id="24" name="Text 21"/>
+          <p:cNvSpPr/>
+          <p:nvPr/>
+        </p:nvSpPr>
+        <p:spPr>
+          <a:xfrm>
+            <a:off x="713232" y="3429000"/>
+            <a:ext cx="5120640" cy="457200"/>
+          </a:xfrm>
+          <a:prstGeom prst="rect">
+            <a:avLst/>
+          </a:prstGeom>
+          <a:noFill/>
+          <a:ln/>
+        </p:spPr>
+        <p:txBody>
+          <a:bodyPr wrap="square" lIns="0" tIns="0" rIns="0" bIns="0" rtlCol="0" anchor="t">
+            <a:normAutofit/>
+          </a:bodyPr>
+          <a:lstStyle/>
+          <a:p>
+            <a:pPr algn="l" indent="0" marL="0">
+              <a:buNone/>
+            </a:pPr>
+            <a:r>
+              <a:rPr lang="en-US" sz="760" dirty="0">
+                <a:solidFill>
+                  <a:srgbClr val="AEB9BA"/>
+                </a:solidFill>
+                <a:latin typeface="Aptos" pitchFamily="34" charset="0"/>
+                <a:ea typeface="Aptos" pitchFamily="34" charset="-122"/>
+                <a:cs typeface="Aptos" pitchFamily="34" charset="-120"/>
+              </a:rPr>
+              <a:t>Its differentiators over Event Hubs are all cloud-to-device: provisioning (DPS), twins, direct methods, jobs. Every one of them is an inbound path into the plant, and device authentication is per-device key or certificate.</a:t>
+            </a:r>
+            <a:endParaRPr lang="en-US" sz="760" dirty="0"/>
+          </a:p>
+        </p:txBody>
+      </p:sp>
+      <p:sp>
+        <p:nvSpPr>
+          <p:cNvPr id="25" name="Shape 22"/>
+          <p:cNvSpPr/>
+          <p:nvPr/>
+        </p:nvSpPr>
+        <p:spPr>
+          <a:xfrm>
+            <a:off x="713232" y="3867912"/>
+            <a:ext cx="5120640" cy="0"/>
+          </a:xfrm>
+          <a:prstGeom prst="line">
+            <a:avLst/>
+          </a:prstGeom>
+          <a:noFill/>
+          <a:ln w="7620">
+            <a:solidFill>
+              <a:srgbClr val="465057"/>
+            </a:solidFill>
+            <a:prstDash val="solid"/>
+          </a:ln>
+        </p:spPr>
+      </p:sp>
+      <p:sp>
+        <p:nvSpPr>
+          <p:cNvPr id="26" name="Text 23"/>
+          <p:cNvSpPr/>
+          <p:nvPr/>
+        </p:nvSpPr>
+        <p:spPr>
+          <a:xfrm>
+            <a:off x="713232" y="3909060"/>
+            <a:ext cx="5120640" cy="91440"/>
+          </a:xfrm>
+          <a:prstGeom prst="rect">
+            <a:avLst/>
+          </a:prstGeom>
+          <a:noFill/>
+          <a:ln/>
+        </p:spPr>
+        <p:txBody>
+          <a:bodyPr wrap="square" lIns="0" tIns="0" rIns="0" bIns="0" rtlCol="0" anchor="ctr">
+            <a:normAutofit/>
+          </a:bodyPr>
+          <a:lstStyle/>
+          <a:p>
+            <a:pPr algn="l" indent="0" marL="0">
+              <a:buNone/>
+            </a:pPr>
+            <a:r>
+              <a:rPr lang="en-US" sz="660" dirty="0">
+                <a:solidFill>
+                  <a:srgbClr val="DDE4E1"/>
+                </a:solidFill>
+                <a:latin typeface="Consolas" pitchFamily="34" charset="0"/>
+                <a:ea typeface="Consolas" pitchFamily="34" charset="-122"/>
+                <a:cs typeface="Consolas" pitchFamily="34" charset="-120"/>
+              </a:rPr>
+              <a:t>Would add: DPS  ·  device twins  ·  direct methods  ·  jobs  —  all cloud-to-device</a:t>
+            </a:r>
+            <a:endParaRPr lang="en-US" sz="660" dirty="0"/>
+          </a:p>
+        </p:txBody>
+      </p:sp>
+      <p:sp>
+        <p:nvSpPr>
+          <p:cNvPr id="27" name="Shape 24"/>
+          <p:cNvSpPr/>
+          <p:nvPr/>
+        </p:nvSpPr>
+        <p:spPr>
+          <a:xfrm>
+            <a:off x="457200" y="4197096"/>
+            <a:ext cx="5623560" cy="1078992"/>
+          </a:xfrm>
+          <a:prstGeom prst="roundRect">
+            <a:avLst/>
+          </a:prstGeom>
+          <a:solidFill>
+            <a:srgbClr val="1F2426"/>
+          </a:solidFill>
+          <a:ln w="11430">
+            <a:solidFill>
+              <a:srgbClr val="E3A72F"/>
+            </a:solidFill>
+            <a:prstDash val="solid"/>
+          </a:ln>
+        </p:spPr>
+      </p:sp>
+      <p:sp>
+        <p:nvSpPr>
+          <p:cNvPr id="28" name="Shape 25"/>
+          <p:cNvSpPr/>
+          <p:nvPr/>
+        </p:nvSpPr>
+        <p:spPr>
+          <a:xfrm>
+            <a:off x="457200" y="4197096"/>
+            <a:ext cx="77724" cy="1078992"/>
+          </a:xfrm>
+          <a:prstGeom prst="rect">
+            <a:avLst/>
+          </a:prstGeom>
+          <a:solidFill>
+            <a:srgbClr val="E3A72F"/>
+          </a:solidFill>
+          <a:ln w="6350">
+            <a:solidFill>
+              <a:srgbClr val="E3A72F"/>
+            </a:solidFill>
+            <a:prstDash val="solid"/>
+          </a:ln>
+        </p:spPr>
+      </p:sp>
+      <p:sp>
+        <p:nvSpPr>
+          <p:cNvPr id="29" name="Text 26"/>
+          <p:cNvSpPr/>
+          <p:nvPr/>
+        </p:nvSpPr>
+        <p:spPr>
+          <a:xfrm>
+            <a:off x="713232" y="4352544"/>
+            <a:ext cx="3200400" cy="128016"/>
+          </a:xfrm>
+          <a:prstGeom prst="rect">
+            <a:avLst/>
+          </a:prstGeom>
+          <a:noFill/>
+          <a:ln/>
+        </p:spPr>
+        <p:txBody>
+          <a:bodyPr wrap="square" lIns="0" tIns="0" rIns="0" bIns="0" rtlCol="0" anchor="ctr">
+            <a:normAutofit/>
+          </a:bodyPr>
+          <a:lstStyle/>
+          <a:p>
+            <a:pPr algn="l" indent="0" marL="0">
+              <a:buNone/>
+            </a:pPr>
+            <a:r>
+              <a:rPr lang="en-US" sz="940" b="1" spc="60" kern="0" dirty="0">
+                <a:solidFill>
+                  <a:srgbClr val="FFFFFF"/>
+                </a:solidFill>
+                <a:latin typeface="Aptos" pitchFamily="34" charset="0"/>
+                <a:ea typeface="Aptos" pitchFamily="34" charset="-122"/>
+                <a:cs typeface="Aptos" pitchFamily="34" charset="-120"/>
+              </a:rPr>
+              <a:t>AZURE IOT OPERATIONS</a:t>
+            </a:r>
+            <a:endParaRPr lang="en-US" sz="940" dirty="0"/>
+          </a:p>
+        </p:txBody>
+      </p:sp>
+      <p:sp>
+        <p:nvSpPr>
+          <p:cNvPr id="30" name="Shape 27"/>
+          <p:cNvSpPr/>
+          <p:nvPr/>
+        </p:nvSpPr>
+        <p:spPr>
+          <a:xfrm>
+            <a:off x="4864608" y="4325112"/>
+            <a:ext cx="1014984" cy="219456"/>
+          </a:xfrm>
+          <a:prstGeom prst="roundRect">
+            <a:avLst/>
+          </a:prstGeom>
+          <a:solidFill>
+            <a:srgbClr val="E3A72F"/>
+          </a:solidFill>
+          <a:ln w="5080">
+            <a:solidFill>
+              <a:srgbClr val="E3A72F"/>
+            </a:solidFill>
+            <a:prstDash val="solid"/>
+          </a:ln>
+        </p:spPr>
+      </p:sp>
+      <p:sp>
+        <p:nvSpPr>
+          <p:cNvPr id="31" name="Text 28"/>
+          <p:cNvSpPr/>
+          <p:nvPr/>
+        </p:nvSpPr>
+        <p:spPr>
+          <a:xfrm>
+            <a:off x="4910328" y="4402836"/>
+            <a:ext cx="923544" cy="82296"/>
+          </a:xfrm>
+          <a:prstGeom prst="rect">
+            <a:avLst/>
+          </a:prstGeom>
+          <a:noFill/>
+          <a:ln/>
+        </p:spPr>
+        <p:txBody>
+          <a:bodyPr wrap="square" lIns="0" tIns="0" rIns="0" bIns="0" rtlCol="0" anchor="ctr">
+            <a:normAutofit/>
+          </a:bodyPr>
+          <a:lstStyle/>
+          <a:p>
+            <a:pPr algn="ctr" indent="0" marL="0">
+              <a:buNone/>
+            </a:pPr>
+            <a:r>
+              <a:rPr lang="en-US" sz="640" b="1" dirty="0">
+                <a:solidFill>
+                  <a:srgbClr val="121719"/>
+                </a:solidFill>
+                <a:latin typeface="Aptos" pitchFamily="34" charset="0"/>
+                <a:ea typeface="Aptos" pitchFamily="34" charset="-122"/>
+                <a:cs typeface="Aptos" pitchFamily="34" charset="-120"/>
+              </a:rPr>
+              <a:t>DEFERRED</a:t>
+            </a:r>
+            <a:endParaRPr lang="en-US" sz="640" dirty="0"/>
+          </a:p>
+        </p:txBody>
+      </p:sp>
+      <p:sp>
+        <p:nvSpPr>
+          <p:cNvPr id="32" name="Text 29"/>
+          <p:cNvSpPr/>
+          <p:nvPr/>
+        </p:nvSpPr>
+        <p:spPr>
+          <a:xfrm>
+            <a:off x="713232" y="4617720"/>
+            <a:ext cx="5120640" cy="457200"/>
+          </a:xfrm>
+          <a:prstGeom prst="rect">
+            <a:avLst/>
+          </a:prstGeom>
+          <a:noFill/>
+          <a:ln/>
+        </p:spPr>
+        <p:txBody>
+          <a:bodyPr wrap="square" lIns="0" tIns="0" rIns="0" bIns="0" rtlCol="0" anchor="t">
+            <a:normAutofit/>
+          </a:bodyPr>
+          <a:lstStyle/>
+          <a:p>
+            <a:pPr algn="l" indent="0" marL="0">
+              <a:buNone/>
+            </a:pPr>
+            <a:r>
+              <a:rPr lang="en-US" sz="760" dirty="0">
+                <a:solidFill>
+                  <a:srgbClr val="AEB9BA"/>
+                </a:solidFill>
+                <a:latin typeface="Aptos" pitchFamily="34" charset="0"/>
+                <a:ea typeface="Aptos" pitchFamily="34" charset="-122"/>
+                <a:cs typeface="Aptos" pitchFamily="34" charset="-120"/>
+              </a:rPr>
+              <a:t>The 2026 strategic industrial stack: Arc-enabled MQTT broker, OPC UA connector, data flows native to Fabric. The right answer the day the OT edge, gateway lifecycle, or per-sensor cloud identity enters scope — not before.</a:t>
+            </a:r>
+            <a:endParaRPr lang="en-US" sz="760" dirty="0"/>
+          </a:p>
+        </p:txBody>
+      </p:sp>
+      <p:sp>
+        <p:nvSpPr>
+          <p:cNvPr id="33" name="Shape 30"/>
+          <p:cNvSpPr/>
+          <p:nvPr/>
+        </p:nvSpPr>
+        <p:spPr>
+          <a:xfrm>
+            <a:off x="713232" y="5056632"/>
+            <a:ext cx="5120640" cy="0"/>
+          </a:xfrm>
+          <a:prstGeom prst="line">
+            <a:avLst/>
+          </a:prstGeom>
+          <a:noFill/>
+          <a:ln w="7620">
+            <a:solidFill>
+              <a:srgbClr val="465057"/>
+            </a:solidFill>
+            <a:prstDash val="solid"/>
+          </a:ln>
+        </p:spPr>
+      </p:sp>
+      <p:sp>
+        <p:nvSpPr>
+          <p:cNvPr id="34" name="Text 31"/>
+          <p:cNvSpPr/>
+          <p:nvPr/>
+        </p:nvSpPr>
+        <p:spPr>
+          <a:xfrm>
+            <a:off x="713232" y="5097780"/>
+            <a:ext cx="5120640" cy="91440"/>
+          </a:xfrm>
+          <a:prstGeom prst="rect">
+            <a:avLst/>
+          </a:prstGeom>
+          <a:noFill/>
+          <a:ln/>
+        </p:spPr>
+        <p:txBody>
+          <a:bodyPr wrap="square" lIns="0" tIns="0" rIns="0" bIns="0" rtlCol="0" anchor="ctr">
+            <a:normAutofit/>
+          </a:bodyPr>
+          <a:lstStyle/>
+          <a:p>
+            <a:pPr algn="l" indent="0" marL="0">
+              <a:buNone/>
+            </a:pPr>
+            <a:r>
+              <a:rPr lang="en-US" sz="660" dirty="0">
+                <a:solidFill>
+                  <a:srgbClr val="DDE4E1"/>
+                </a:solidFill>
+                <a:latin typeface="Consolas" pitchFamily="34" charset="0"/>
+                <a:ea typeface="Consolas" pitchFamily="34" charset="-122"/>
+                <a:cs typeface="Consolas" pitchFamily="34" charset="-120"/>
+              </a:rPr>
+              <a:t>Cost of entry: an Arc-enabled Kubernetes footprint inside every plant</a:t>
+            </a:r>
+            <a:endParaRPr lang="en-US" sz="660" dirty="0"/>
+          </a:p>
+        </p:txBody>
+      </p:sp>
+      <p:sp>
+        <p:nvSpPr>
+          <p:cNvPr id="35" name="Text 32"/>
+          <p:cNvSpPr/>
+          <p:nvPr/>
+        </p:nvSpPr>
+        <p:spPr>
+          <a:xfrm>
+            <a:off x="6446520" y="1627632"/>
+            <a:ext cx="4937760" cy="146304"/>
+          </a:xfrm>
+          <a:prstGeom prst="rect">
+            <a:avLst/>
+          </a:prstGeom>
+          <a:noFill/>
+          <a:ln/>
+        </p:spPr>
+        <p:txBody>
+          <a:bodyPr wrap="square" lIns="0" tIns="0" rIns="0" bIns="0" rtlCol="0" anchor="ctr">
+            <a:normAutofit/>
+          </a:bodyPr>
+          <a:lstStyle/>
+          <a:p>
+            <a:pPr algn="l" indent="0" marL="0">
+              <a:buNone/>
+            </a:pPr>
+            <a:r>
+              <a:rPr lang="en-US" sz="720" b="1" spc="120" kern="0" dirty="0">
+                <a:solidFill>
+                  <a:srgbClr val="AEB9BA"/>
+                </a:solidFill>
+                <a:latin typeface="Aptos" pitchFamily="34" charset="0"/>
+                <a:ea typeface="Aptos" pitchFamily="34" charset="-122"/>
+                <a:cs typeface="Aptos" pitchFamily="34" charset="-120"/>
+              </a:rPr>
+              <a:t>WHY IOT HUB LOSES ON OUR OWN GUARDRAILS</a:t>
+            </a:r>
+            <a:endParaRPr lang="en-US" sz="720" dirty="0"/>
+          </a:p>
+        </p:txBody>
+      </p:sp>
+      <p:sp>
+        <p:nvSpPr>
+          <p:cNvPr id="36" name="Shape 33"/>
+          <p:cNvSpPr/>
+          <p:nvPr/>
+        </p:nvSpPr>
+        <p:spPr>
+          <a:xfrm>
+            <a:off x="6446520" y="1819656"/>
+            <a:ext cx="5285232" cy="795528"/>
+          </a:xfrm>
+          <a:prstGeom prst="roundRect">
+            <a:avLst/>
+          </a:prstGeom>
+          <a:solidFill>
+            <a:srgbClr val="1F2426"/>
+          </a:solidFill>
+          <a:ln w="8890">
+            <a:solidFill>
+              <a:srgbClr val="465057"/>
+            </a:solidFill>
+            <a:prstDash val="solid"/>
+          </a:ln>
+        </p:spPr>
+      </p:sp>
+      <p:sp>
+        <p:nvSpPr>
+          <p:cNvPr id="37" name="Shape 34"/>
+          <p:cNvSpPr/>
+          <p:nvPr/>
+        </p:nvSpPr>
+        <p:spPr>
+          <a:xfrm>
+            <a:off x="6446520" y="1819656"/>
+            <a:ext cx="77724" cy="795528"/>
+          </a:xfrm>
+          <a:prstGeom prst="rect">
+            <a:avLst/>
+          </a:prstGeom>
+          <a:solidFill>
+            <a:srgbClr val="B64A2D"/>
+          </a:solidFill>
+          <a:ln w="6350">
+            <a:solidFill>
+              <a:srgbClr val="B64A2D"/>
+            </a:solidFill>
+            <a:prstDash val="solid"/>
+          </a:ln>
+        </p:spPr>
+      </p:sp>
+      <p:sp>
+        <p:nvSpPr>
+          <p:cNvPr id="38" name="Shape 35"/>
+          <p:cNvSpPr/>
+          <p:nvPr/>
+        </p:nvSpPr>
+        <p:spPr>
+          <a:xfrm>
+            <a:off x="6656832" y="1993392"/>
+            <a:ext cx="256032" cy="256032"/>
+          </a:xfrm>
+          <a:prstGeom prst="ellipse">
+            <a:avLst/>
+          </a:prstGeom>
+          <a:solidFill>
+            <a:srgbClr val="B64A2D"/>
+          </a:solidFill>
+          <a:ln w="6350">
+            <a:solidFill>
+              <a:srgbClr val="B64A2D"/>
+            </a:solidFill>
+            <a:prstDash val="solid"/>
+          </a:ln>
+        </p:spPr>
+      </p:sp>
+      <p:sp>
+        <p:nvSpPr>
+          <p:cNvPr id="39" name="Text 36"/>
+          <p:cNvSpPr/>
+          <p:nvPr/>
+        </p:nvSpPr>
+        <p:spPr>
+          <a:xfrm>
+            <a:off x="6656832" y="2083003"/>
+            <a:ext cx="256032" cy="82296"/>
+          </a:xfrm>
+          <a:prstGeom prst="rect">
+            <a:avLst/>
+          </a:prstGeom>
+          <a:noFill/>
+          <a:ln/>
+        </p:spPr>
+        <p:txBody>
+          <a:bodyPr wrap="square" lIns="0" tIns="0" rIns="0" bIns="0" rtlCol="0" anchor="ctr">
+            <a:normAutofit/>
+          </a:bodyPr>
+          <a:lstStyle/>
+          <a:p>
+            <a:pPr algn="ctr" indent="0" marL="0">
+              <a:buNone/>
+            </a:pPr>
+            <a:r>
+              <a:rPr lang="en-US" sz="700" b="1" dirty="0">
+                <a:solidFill>
+                  <a:srgbClr val="121719"/>
+                </a:solidFill>
+                <a:latin typeface="Aptos" pitchFamily="34" charset="0"/>
+                <a:ea typeface="Aptos" pitchFamily="34" charset="-122"/>
+                <a:cs typeface="Aptos" pitchFamily="34" charset="-120"/>
+              </a:rPr>
+              <a:t>01</a:t>
+            </a:r>
+            <a:endParaRPr lang="en-US" sz="700" dirty="0"/>
+          </a:p>
+        </p:txBody>
+      </p:sp>
+      <p:sp>
+        <p:nvSpPr>
+          <p:cNvPr id="40" name="Text 37"/>
+          <p:cNvSpPr/>
+          <p:nvPr/>
+        </p:nvSpPr>
+        <p:spPr>
+          <a:xfrm>
+            <a:off x="7059168" y="1965960"/>
+            <a:ext cx="4480560" cy="118872"/>
+          </a:xfrm>
+          <a:prstGeom prst="rect">
+            <a:avLst/>
+          </a:prstGeom>
+          <a:noFill/>
+          <a:ln/>
+        </p:spPr>
+        <p:txBody>
+          <a:bodyPr wrap="square" lIns="0" tIns="0" rIns="0" bIns="0" rtlCol="0" anchor="ctr">
+            <a:normAutofit/>
+          </a:bodyPr>
+          <a:lstStyle/>
+          <a:p>
+            <a:pPr algn="l" indent="0" marL="0">
+              <a:buNone/>
+            </a:pPr>
+            <a:r>
+              <a:rPr lang="en-US" sz="820" b="1" spc="40" kern="0" dirty="0">
+                <a:solidFill>
+                  <a:srgbClr val="FFFFFF"/>
+                </a:solidFill>
+                <a:latin typeface="Aptos" pitchFamily="34" charset="0"/>
+                <a:ea typeface="Aptos" pitchFamily="34" charset="-122"/>
+                <a:cs typeface="Aptos" pitchFamily="34" charset="-120"/>
+              </a:rPr>
+              <a:t>IT SELLS THE CONTROL PLANE WE BANNED</a:t>
+            </a:r>
+            <a:endParaRPr lang="en-US" sz="820" dirty="0"/>
+          </a:p>
+        </p:txBody>
+      </p:sp>
+      <p:sp>
+        <p:nvSpPr>
+          <p:cNvPr id="41" name="Text 38"/>
+          <p:cNvSpPr/>
+          <p:nvPr/>
+        </p:nvSpPr>
+        <p:spPr>
+          <a:xfrm>
+            <a:off x="7059168" y="2221992"/>
+            <a:ext cx="4480560" cy="329184"/>
+          </a:xfrm>
+          <a:prstGeom prst="rect">
+            <a:avLst/>
+          </a:prstGeom>
+          <a:noFill/>
+          <a:ln/>
+        </p:spPr>
+        <p:txBody>
+          <a:bodyPr wrap="square" lIns="0" tIns="0" rIns="0" bIns="0" rtlCol="0" anchor="t">
+            <a:normAutofit/>
+          </a:bodyPr>
+          <a:lstStyle/>
+          <a:p>
+            <a:pPr algn="l" indent="0" marL="0">
+              <a:buNone/>
+            </a:pPr>
+            <a:r>
+              <a:rPr lang="en-US" sz="710" dirty="0">
+                <a:solidFill>
+                  <a:srgbClr val="AEB9BA"/>
+                </a:solidFill>
+                <a:latin typeface="Aptos" pitchFamily="34" charset="0"/>
+                <a:ea typeface="Aptos" pitchFamily="34" charset="-122"/>
+                <a:cs typeface="Aptos" pitchFamily="34" charset="-120"/>
+              </a:rPr>
+              <a:t>O1 / C-04 / AI-05 forbid a write path to OT. We would acquire the capability, disable it, then keep proving it stays disabled.</a:t>
+            </a:r>
+            <a:endParaRPr lang="en-US" sz="710" dirty="0"/>
+          </a:p>
+        </p:txBody>
+      </p:sp>
+      <p:sp>
+        <p:nvSpPr>
+          <p:cNvPr id="42" name="Shape 39"/>
+          <p:cNvSpPr/>
+          <p:nvPr/>
+        </p:nvSpPr>
+        <p:spPr>
+          <a:xfrm>
+            <a:off x="6446520" y="2724912"/>
+            <a:ext cx="5285232" cy="795528"/>
+          </a:xfrm>
+          <a:prstGeom prst="roundRect">
+            <a:avLst/>
+          </a:prstGeom>
+          <a:solidFill>
+            <a:srgbClr val="1F2426"/>
+          </a:solidFill>
+          <a:ln w="8890">
+            <a:solidFill>
+              <a:srgbClr val="465057"/>
+            </a:solidFill>
+            <a:prstDash val="solid"/>
+          </a:ln>
+        </p:spPr>
+      </p:sp>
+      <p:sp>
+        <p:nvSpPr>
+          <p:cNvPr id="43" name="Shape 40"/>
+          <p:cNvSpPr/>
+          <p:nvPr/>
+        </p:nvSpPr>
+        <p:spPr>
+          <a:xfrm>
+            <a:off x="6446520" y="2724912"/>
+            <a:ext cx="77724" cy="795528"/>
+          </a:xfrm>
+          <a:prstGeom prst="rect">
+            <a:avLst/>
+          </a:prstGeom>
+          <a:solidFill>
+            <a:srgbClr val="E3A72F"/>
+          </a:solidFill>
+          <a:ln w="6350">
+            <a:solidFill>
+              <a:srgbClr val="E3A72F"/>
+            </a:solidFill>
+            <a:prstDash val="solid"/>
+          </a:ln>
+        </p:spPr>
+      </p:sp>
+      <p:sp>
+        <p:nvSpPr>
+          <p:cNvPr id="44" name="Shape 41"/>
+          <p:cNvSpPr/>
+          <p:nvPr/>
+        </p:nvSpPr>
+        <p:spPr>
+          <a:xfrm>
+            <a:off x="6656832" y="2898648"/>
+            <a:ext cx="256032" cy="256032"/>
+          </a:xfrm>
+          <a:prstGeom prst="ellipse">
+            <a:avLst/>
+          </a:prstGeom>
+          <a:solidFill>
+            <a:srgbClr val="E3A72F"/>
+          </a:solidFill>
+          <a:ln w="6350">
+            <a:solidFill>
+              <a:srgbClr val="E3A72F"/>
+            </a:solidFill>
+            <a:prstDash val="solid"/>
+          </a:ln>
+        </p:spPr>
+      </p:sp>
+      <p:sp>
+        <p:nvSpPr>
+          <p:cNvPr id="45" name="Text 42"/>
+          <p:cNvSpPr/>
+          <p:nvPr/>
+        </p:nvSpPr>
+        <p:spPr>
+          <a:xfrm>
+            <a:off x="6656832" y="2988259"/>
+            <a:ext cx="256032" cy="82296"/>
+          </a:xfrm>
+          <a:prstGeom prst="rect">
+            <a:avLst/>
+          </a:prstGeom>
+          <a:noFill/>
+          <a:ln/>
+        </p:spPr>
+        <p:txBody>
+          <a:bodyPr wrap="square" lIns="0" tIns="0" rIns="0" bIns="0" rtlCol="0" anchor="ctr">
+            <a:normAutofit/>
+          </a:bodyPr>
+          <a:lstStyle/>
+          <a:p>
+            <a:pPr algn="ctr" indent="0" marL="0">
+              <a:buNone/>
+            </a:pPr>
+            <a:r>
+              <a:rPr lang="en-US" sz="700" b="1" dirty="0">
+                <a:solidFill>
+                  <a:srgbClr val="121719"/>
+                </a:solidFill>
+                <a:latin typeface="Aptos" pitchFamily="34" charset="0"/>
+                <a:ea typeface="Aptos" pitchFamily="34" charset="-122"/>
+                <a:cs typeface="Aptos" pitchFamily="34" charset="-120"/>
+              </a:rPr>
+              <a:t>02</a:t>
+            </a:r>
+            <a:endParaRPr lang="en-US" sz="700" dirty="0"/>
+          </a:p>
+        </p:txBody>
+      </p:sp>
+      <p:sp>
+        <p:nvSpPr>
+          <p:cNvPr id="46" name="Text 43"/>
+          <p:cNvSpPr/>
+          <p:nvPr/>
+        </p:nvSpPr>
+        <p:spPr>
+          <a:xfrm>
+            <a:off x="7059168" y="2871216"/>
+            <a:ext cx="4480560" cy="118872"/>
+          </a:xfrm>
+          <a:prstGeom prst="rect">
+            <a:avLst/>
+          </a:prstGeom>
+          <a:noFill/>
+          <a:ln/>
+        </p:spPr>
+        <p:txBody>
+          <a:bodyPr wrap="square" lIns="0" tIns="0" rIns="0" bIns="0" rtlCol="0" anchor="ctr">
+            <a:normAutofit/>
+          </a:bodyPr>
+          <a:lstStyle/>
+          <a:p>
+            <a:pPr algn="l" indent="0" marL="0">
+              <a:buNone/>
+            </a:pPr>
+            <a:r>
+              <a:rPr lang="en-US" sz="820" b="1" spc="40" kern="0" dirty="0">
+                <a:solidFill>
+                  <a:srgbClr val="FFFFFF"/>
+                </a:solidFill>
+                <a:latin typeface="Aptos" pitchFamily="34" charset="0"/>
+                <a:ea typeface="Aptos" pitchFamily="34" charset="-122"/>
+                <a:cs typeface="Aptos" pitchFamily="34" charset="-120"/>
+              </a:rPr>
+              <a:t>IT WEAKENS THE NO-KEY POSTURE</a:t>
+            </a:r>
+            <a:endParaRPr lang="en-US" sz="820" dirty="0"/>
+          </a:p>
+        </p:txBody>
+      </p:sp>
+      <p:sp>
+        <p:nvSpPr>
+          <p:cNvPr id="47" name="Text 44"/>
+          <p:cNvSpPr/>
+          <p:nvPr/>
+        </p:nvSpPr>
+        <p:spPr>
+          <a:xfrm>
+            <a:off x="7059168" y="3127248"/>
+            <a:ext cx="4480560" cy="329184"/>
+          </a:xfrm>
+          <a:prstGeom prst="rect">
+            <a:avLst/>
+          </a:prstGeom>
+          <a:noFill/>
+          <a:ln/>
+        </p:spPr>
+        <p:txBody>
+          <a:bodyPr wrap="square" lIns="0" tIns="0" rIns="0" bIns="0" rtlCol="0" anchor="t">
+            <a:normAutofit/>
+          </a:bodyPr>
+          <a:lstStyle/>
+          <a:p>
+            <a:pPr algn="l" indent="0" marL="0">
+              <a:buNone/>
+            </a:pPr>
+            <a:r>
+              <a:rPr lang="en-US" sz="710" dirty="0">
+                <a:solidFill>
+                  <a:srgbClr val="AEB9BA"/>
+                </a:solidFill>
+                <a:latin typeface="Aptos" pitchFamily="34" charset="0"/>
+                <a:ea typeface="Aptos" pitchFamily="34" charset="-122"/>
+                <a:cs typeface="Aptos" pitchFamily="34" charset="-120"/>
+              </a:rPr>
+              <a:t>Event Hubs runs disableLocalAuth: true with Entra RBAC. IoT Hub device auth is SAS or X.509, and Fabric's IoT Hub source is key-based — the very thing ADR-005 avoids.</a:t>
+            </a:r>
+            <a:endParaRPr lang="en-US" sz="710" dirty="0"/>
+          </a:p>
+        </p:txBody>
+      </p:sp>
+      <p:sp>
+        <p:nvSpPr>
+          <p:cNvPr id="48" name="Shape 45"/>
+          <p:cNvSpPr/>
+          <p:nvPr/>
+        </p:nvSpPr>
+        <p:spPr>
+          <a:xfrm>
+            <a:off x="6446520" y="3630168"/>
+            <a:ext cx="5285232" cy="795528"/>
+          </a:xfrm>
+          <a:prstGeom prst="roundRect">
+            <a:avLst/>
+          </a:prstGeom>
+          <a:solidFill>
+            <a:srgbClr val="1F2426"/>
+          </a:solidFill>
+          <a:ln w="8890">
+            <a:solidFill>
+              <a:srgbClr val="465057"/>
+            </a:solidFill>
+            <a:prstDash val="solid"/>
+          </a:ln>
+        </p:spPr>
+      </p:sp>
+      <p:sp>
+        <p:nvSpPr>
+          <p:cNvPr id="49" name="Shape 46"/>
+          <p:cNvSpPr/>
+          <p:nvPr/>
+        </p:nvSpPr>
+        <p:spPr>
+          <a:xfrm>
+            <a:off x="6446520" y="3630168"/>
+            <a:ext cx="77724" cy="795528"/>
+          </a:xfrm>
+          <a:prstGeom prst="rect">
+            <a:avLst/>
+          </a:prstGeom>
+          <a:solidFill>
+            <a:srgbClr val="147D74"/>
+          </a:solidFill>
+          <a:ln w="6350">
+            <a:solidFill>
+              <a:srgbClr val="147D74"/>
+            </a:solidFill>
+            <a:prstDash val="solid"/>
+          </a:ln>
+        </p:spPr>
+      </p:sp>
+      <p:sp>
+        <p:nvSpPr>
+          <p:cNvPr id="50" name="Shape 47"/>
+          <p:cNvSpPr/>
+          <p:nvPr/>
+        </p:nvSpPr>
+        <p:spPr>
+          <a:xfrm>
+            <a:off x="6656832" y="3803904"/>
+            <a:ext cx="256032" cy="256032"/>
+          </a:xfrm>
+          <a:prstGeom prst="ellipse">
+            <a:avLst/>
+          </a:prstGeom>
+          <a:solidFill>
+            <a:srgbClr val="147D74"/>
+          </a:solidFill>
+          <a:ln w="6350">
+            <a:solidFill>
+              <a:srgbClr val="147D74"/>
+            </a:solidFill>
+            <a:prstDash val="solid"/>
+          </a:ln>
+        </p:spPr>
+      </p:sp>
+      <p:sp>
+        <p:nvSpPr>
+          <p:cNvPr id="51" name="Text 48"/>
+          <p:cNvSpPr/>
+          <p:nvPr/>
+        </p:nvSpPr>
+        <p:spPr>
+          <a:xfrm>
+            <a:off x="6656832" y="3893515"/>
+            <a:ext cx="256032" cy="82296"/>
+          </a:xfrm>
+          <a:prstGeom prst="rect">
+            <a:avLst/>
+          </a:prstGeom>
+          <a:noFill/>
+          <a:ln/>
+        </p:spPr>
+        <p:txBody>
+          <a:bodyPr wrap="square" lIns="0" tIns="0" rIns="0" bIns="0" rtlCol="0" anchor="ctr">
+            <a:normAutofit/>
+          </a:bodyPr>
+          <a:lstStyle/>
+          <a:p>
+            <a:pPr algn="ctr" indent="0" marL="0">
+              <a:buNone/>
+            </a:pPr>
+            <a:r>
+              <a:rPr lang="en-US" sz="700" b="1" dirty="0">
+                <a:solidFill>
+                  <a:srgbClr val="121719"/>
+                </a:solidFill>
+                <a:latin typeface="Aptos" pitchFamily="34" charset="0"/>
+                <a:ea typeface="Aptos" pitchFamily="34" charset="-122"/>
+                <a:cs typeface="Aptos" pitchFamily="34" charset="-120"/>
+              </a:rPr>
+              <a:t>03</a:t>
+            </a:r>
+            <a:endParaRPr lang="en-US" sz="700" dirty="0"/>
+          </a:p>
+        </p:txBody>
+      </p:sp>
+      <p:sp>
+        <p:nvSpPr>
+          <p:cNvPr id="52" name="Text 49"/>
+          <p:cNvSpPr/>
+          <p:nvPr/>
+        </p:nvSpPr>
+        <p:spPr>
+          <a:xfrm>
+            <a:off x="7059168" y="3776472"/>
+            <a:ext cx="4480560" cy="118872"/>
+          </a:xfrm>
+          <a:prstGeom prst="rect">
+            <a:avLst/>
+          </a:prstGeom>
+          <a:noFill/>
+          <a:ln/>
+        </p:spPr>
+        <p:txBody>
+          <a:bodyPr wrap="square" lIns="0" tIns="0" rIns="0" bIns="0" rtlCol="0" anchor="ctr">
+            <a:normAutofit/>
+          </a:bodyPr>
+          <a:lstStyle/>
+          <a:p>
+            <a:pPr algn="l" indent="0" marL="0">
+              <a:buNone/>
+            </a:pPr>
+            <a:r>
+              <a:rPr lang="en-US" sz="820" b="1" spc="40" kern="0" dirty="0">
+                <a:solidFill>
+                  <a:srgbClr val="FFFFFF"/>
+                </a:solidFill>
+                <a:latin typeface="Aptos" pitchFamily="34" charset="0"/>
+                <a:ea typeface="Aptos" pitchFamily="34" charset="-122"/>
+                <a:cs typeface="Aptos" pitchFamily="34" charset="-120"/>
+              </a:rPr>
+              <a:t>THE SENDERS ARE FOUR GATEWAYS</a:t>
+            </a:r>
+            <a:endParaRPr lang="en-US" sz="820" dirty="0"/>
+          </a:p>
+        </p:txBody>
+      </p:sp>
+      <p:sp>
+        <p:nvSpPr>
+          <p:cNvPr id="53" name="Text 50"/>
+          <p:cNvSpPr/>
+          <p:nvPr/>
+        </p:nvSpPr>
+        <p:spPr>
+          <a:xfrm>
+            <a:off x="7059168" y="4032504"/>
+            <a:ext cx="4480560" cy="329184"/>
+          </a:xfrm>
+          <a:prstGeom prst="rect">
+            <a:avLst/>
+          </a:prstGeom>
+          <a:noFill/>
+          <a:ln/>
+        </p:spPr>
+        <p:txBody>
+          <a:bodyPr wrap="square" lIns="0" tIns="0" rIns="0" bIns="0" rtlCol="0" anchor="t">
+            <a:normAutofit/>
+          </a:bodyPr>
+          <a:lstStyle/>
+          <a:p>
+            <a:pPr algn="l" indent="0" marL="0">
+              <a:buNone/>
+            </a:pPr>
+            <a:r>
+              <a:rPr lang="en-US" sz="710" dirty="0">
+                <a:solidFill>
+                  <a:srgbClr val="AEB9BA"/>
+                </a:solidFill>
+                <a:latin typeface="Aptos" pitchFamily="34" charset="0"/>
+                <a:ea typeface="Aptos" pitchFamily="34" charset="-122"/>
+                <a:cs typeface="Aptos" pitchFamily="34" charset="-120"/>
+              </a:rPr>
+              <a:t>Not a device fleet. Per-device identity already rides the envelope (source_id, asset_id) and the Device Operations registry — 17 devices, 91 sensors.</a:t>
+            </a:r>
+            <a:endParaRPr lang="en-US" sz="710" dirty="0"/>
+          </a:p>
+        </p:txBody>
+      </p:sp>
+      <p:sp>
+        <p:nvSpPr>
+          <p:cNvPr id="54" name="Shape 51"/>
+          <p:cNvSpPr/>
+          <p:nvPr/>
+        </p:nvSpPr>
+        <p:spPr>
+          <a:xfrm>
+            <a:off x="6446520" y="4535424"/>
+            <a:ext cx="5285232" cy="795528"/>
+          </a:xfrm>
+          <a:prstGeom prst="roundRect">
+            <a:avLst/>
+          </a:prstGeom>
+          <a:solidFill>
+            <a:srgbClr val="1F2426"/>
+          </a:solidFill>
+          <a:ln w="8890">
+            <a:solidFill>
+              <a:srgbClr val="465057"/>
+            </a:solidFill>
+            <a:prstDash val="solid"/>
+          </a:ln>
+        </p:spPr>
+      </p:sp>
+      <p:sp>
+        <p:nvSpPr>
+          <p:cNvPr id="55" name="Shape 52"/>
+          <p:cNvSpPr/>
+          <p:nvPr/>
+        </p:nvSpPr>
+        <p:spPr>
+          <a:xfrm>
+            <a:off x="6446520" y="4535424"/>
+            <a:ext cx="77724" cy="795528"/>
+          </a:xfrm>
+          <a:prstGeom prst="rect">
+            <a:avLst/>
+          </a:prstGeom>
+          <a:solidFill>
+            <a:srgbClr val="6D9A6F"/>
+          </a:solidFill>
+          <a:ln w="6350">
+            <a:solidFill>
+              <a:srgbClr val="6D9A6F"/>
+            </a:solidFill>
+            <a:prstDash val="solid"/>
+          </a:ln>
+        </p:spPr>
+      </p:sp>
+      <p:sp>
+        <p:nvSpPr>
+          <p:cNvPr id="56" name="Shape 53"/>
+          <p:cNvSpPr/>
+          <p:nvPr/>
+        </p:nvSpPr>
+        <p:spPr>
+          <a:xfrm>
+            <a:off x="6656832" y="4709160"/>
+            <a:ext cx="256032" cy="256032"/>
+          </a:xfrm>
+          <a:prstGeom prst="ellipse">
+            <a:avLst/>
+          </a:prstGeom>
+          <a:solidFill>
+            <a:srgbClr val="6D9A6F"/>
+          </a:solidFill>
+          <a:ln w="6350">
+            <a:solidFill>
+              <a:srgbClr val="6D9A6F"/>
+            </a:solidFill>
+            <a:prstDash val="solid"/>
+          </a:ln>
+        </p:spPr>
+      </p:sp>
+      <p:sp>
+        <p:nvSpPr>
+          <p:cNvPr id="57" name="Text 54"/>
+          <p:cNvSpPr/>
+          <p:nvPr/>
+        </p:nvSpPr>
+        <p:spPr>
+          <a:xfrm>
+            <a:off x="6656832" y="4798771"/>
+            <a:ext cx="256032" cy="82296"/>
+          </a:xfrm>
+          <a:prstGeom prst="rect">
+            <a:avLst/>
+          </a:prstGeom>
+          <a:noFill/>
+          <a:ln/>
+        </p:spPr>
+        <p:txBody>
+          <a:bodyPr wrap="square" lIns="0" tIns="0" rIns="0" bIns="0" rtlCol="0" anchor="ctr">
+            <a:normAutofit/>
+          </a:bodyPr>
+          <a:lstStyle/>
+          <a:p>
+            <a:pPr algn="ctr" indent="0" marL="0">
+              <a:buNone/>
+            </a:pPr>
+            <a:r>
+              <a:rPr lang="en-US" sz="700" b="1" dirty="0">
+                <a:solidFill>
+                  <a:srgbClr val="121719"/>
+                </a:solidFill>
+                <a:latin typeface="Aptos" pitchFamily="34" charset="0"/>
+                <a:ea typeface="Aptos" pitchFamily="34" charset="-122"/>
+                <a:cs typeface="Aptos" pitchFamily="34" charset="-120"/>
+              </a:rPr>
+              <a:t>04</a:t>
+            </a:r>
+            <a:endParaRPr lang="en-US" sz="700" dirty="0"/>
+          </a:p>
+        </p:txBody>
+      </p:sp>
+      <p:sp>
+        <p:nvSpPr>
+          <p:cNvPr id="58" name="Text 55"/>
+          <p:cNvSpPr/>
+          <p:nvPr/>
+        </p:nvSpPr>
+        <p:spPr>
+          <a:xfrm>
+            <a:off x="7059168" y="4681728"/>
+            <a:ext cx="4480560" cy="118872"/>
+          </a:xfrm>
+          <a:prstGeom prst="rect">
+            <a:avLst/>
+          </a:prstGeom>
+          <a:noFill/>
+          <a:ln/>
+        </p:spPr>
+        <p:txBody>
+          <a:bodyPr wrap="square" lIns="0" tIns="0" rIns="0" bIns="0" rtlCol="0" anchor="ctr">
+            <a:normAutofit/>
+          </a:bodyPr>
+          <a:lstStyle/>
+          <a:p>
+            <a:pPr algn="l" indent="0" marL="0">
+              <a:buNone/>
+            </a:pPr>
+            <a:r>
+              <a:rPr lang="en-US" sz="820" b="1" spc="40" kern="0" dirty="0">
+                <a:solidFill>
+                  <a:srgbClr val="FFFFFF"/>
+                </a:solidFill>
+                <a:latin typeface="Aptos" pitchFamily="34" charset="0"/>
+                <a:ea typeface="Aptos" pitchFamily="34" charset="-122"/>
+                <a:cs typeface="Aptos" pitchFamily="34" charset="-120"/>
+              </a:rPr>
+              <a:t>NO NEW CAPABILITY, A NEW BILL</a:t>
+            </a:r>
+            <a:endParaRPr lang="en-US" sz="820" dirty="0"/>
+          </a:p>
+        </p:txBody>
+      </p:sp>
+      <p:sp>
+        <p:nvSpPr>
+          <p:cNvPr id="59" name="Text 56"/>
+          <p:cNvSpPr/>
+          <p:nvPr/>
+        </p:nvSpPr>
+        <p:spPr>
+          <a:xfrm>
+            <a:off x="7059168" y="4937760"/>
+            <a:ext cx="4480560" cy="329184"/>
+          </a:xfrm>
+          <a:prstGeom prst="rect">
+            <a:avLst/>
+          </a:prstGeom>
+          <a:noFill/>
+          <a:ln/>
+        </p:spPr>
+        <p:txBody>
+          <a:bodyPr wrap="square" lIns="0" tIns="0" rIns="0" bIns="0" rtlCol="0" anchor="t">
+            <a:normAutofit/>
+          </a:bodyPr>
+          <a:lstStyle/>
+          <a:p>
+            <a:pPr algn="l" indent="0" marL="0">
+              <a:buNone/>
+            </a:pPr>
+            <a:r>
+              <a:rPr lang="en-US" sz="710" dirty="0">
+                <a:solidFill>
+                  <a:srgbClr val="AEB9BA"/>
+                </a:solidFill>
+                <a:latin typeface="Aptos" pitchFamily="34" charset="0"/>
+                <a:ea typeface="Aptos" pitchFamily="34" charset="-122"/>
+                <a:cs typeface="Aptos" pitchFamily="34" charset="-120"/>
+              </a:rPr>
+              <a:t>A second ingestion service on a deliberately minimal footprint: one throughput unit, small Fabric capacity, nightly pause.</a:t>
+            </a:r>
+            <a:endParaRPr lang="en-US" sz="710" dirty="0"/>
+          </a:p>
+        </p:txBody>
+      </p:sp>
+      <p:sp>
+        <p:nvSpPr>
+          <p:cNvPr id="60" name="Shape 57"/>
+          <p:cNvSpPr/>
+          <p:nvPr/>
+        </p:nvSpPr>
+        <p:spPr>
+          <a:xfrm>
+            <a:off x="457200" y="5440680"/>
+            <a:ext cx="11274552" cy="640080"/>
+          </a:xfrm>
+          <a:prstGeom prst="roundRect">
+            <a:avLst/>
+          </a:prstGeom>
+          <a:solidFill>
+            <a:srgbClr val="7A261C"/>
+          </a:solidFill>
+          <a:ln w="11430">
+            <a:solidFill>
+              <a:srgbClr val="B64A2D"/>
+            </a:solidFill>
+            <a:prstDash val="solid"/>
+          </a:ln>
+        </p:spPr>
+      </p:sp>
+      <p:sp>
+        <p:nvSpPr>
+          <p:cNvPr id="61" name="Shape 58"/>
+          <p:cNvSpPr/>
+          <p:nvPr/>
+        </p:nvSpPr>
+        <p:spPr>
+          <a:xfrm>
+            <a:off x="457200" y="5440680"/>
+            <a:ext cx="77724" cy="640080"/>
+          </a:xfrm>
+          <a:prstGeom prst="rect">
+            <a:avLst/>
+          </a:prstGeom>
+          <a:solidFill>
+            <a:srgbClr val="E3A72F"/>
+          </a:solidFill>
+          <a:ln w="6350">
+            <a:solidFill>
+              <a:srgbClr val="E3A72F"/>
+            </a:solidFill>
+            <a:prstDash val="solid"/>
+          </a:ln>
+        </p:spPr>
+      </p:sp>
+      <p:sp>
+        <p:nvSpPr>
+          <p:cNvPr id="62" name="Text 59"/>
+          <p:cNvSpPr/>
+          <p:nvPr/>
+        </p:nvSpPr>
+        <p:spPr>
+          <a:xfrm>
+            <a:off x="713232" y="5568696"/>
+            <a:ext cx="1371600" cy="109728"/>
+          </a:xfrm>
+          <a:prstGeom prst="rect">
+            <a:avLst/>
+          </a:prstGeom>
+          <a:noFill/>
+          <a:ln/>
+        </p:spPr>
+        <p:txBody>
+          <a:bodyPr wrap="square" lIns="0" tIns="0" rIns="0" bIns="0" rtlCol="0" anchor="ctr">
+            <a:normAutofit/>
+          </a:bodyPr>
+          <a:lstStyle/>
+          <a:p>
+            <a:pPr algn="l" indent="0" marL="0">
+              <a:buNone/>
+            </a:pPr>
+            <a:r>
+              <a:rPr lang="en-US" sz="760" b="1" spc="90" kern="0" dirty="0">
+                <a:solidFill>
+                  <a:srgbClr val="E3A72F"/>
+                </a:solidFill>
+                <a:latin typeface="Aptos" pitchFamily="34" charset="0"/>
+                <a:ea typeface="Aptos" pitchFamily="34" charset="-122"/>
+                <a:cs typeface="Aptos" pitchFamily="34" charset="-120"/>
+              </a:rPr>
+              <a:t>REVISIT WHEN</a:t>
+            </a:r>
+            <a:endParaRPr lang="en-US" sz="760" dirty="0"/>
+          </a:p>
+        </p:txBody>
+      </p:sp>
+      <p:sp>
+        <p:nvSpPr>
+          <p:cNvPr id="63" name="Text 60"/>
+          <p:cNvSpPr/>
+          <p:nvPr/>
+        </p:nvSpPr>
+        <p:spPr>
+          <a:xfrm>
+            <a:off x="1956816" y="5541264"/>
+            <a:ext cx="9555480" cy="402336"/>
+          </a:xfrm>
+          <a:prstGeom prst="rect">
+            <a:avLst/>
+          </a:prstGeom>
+          <a:noFill/>
+          <a:ln/>
+        </p:spPr>
+        <p:txBody>
+          <a:bodyPr wrap="square" lIns="0" tIns="0" rIns="0" bIns="0" rtlCol="0" anchor="t">
+            <a:normAutofit/>
+          </a:bodyPr>
+          <a:lstStyle/>
+          <a:p>
+            <a:pPr algn="l" indent="0" marL="0">
+              <a:buNone/>
+            </a:pPr>
+            <a:r>
+              <a:rPr lang="en-US" sz="770" b="1" dirty="0">
+                <a:solidFill>
+                  <a:srgbClr val="DDE4E1"/>
+                </a:solidFill>
+                <a:latin typeface="Aptos" pitchFamily="34" charset="0"/>
+                <a:ea typeface="Aptos" pitchFamily="34" charset="-122"/>
+                <a:cs typeface="Aptos" pitchFamily="34" charset="-120"/>
+              </a:rPr>
+              <a:t>a business requirement demands cloud-initiated action on plant equipment, or gateways can no longer aggregate upstream devices. The migration target is then IoT Operations, not IoT Hub — and closed-loop control of machinery changes the EU AI Act risk classification, so it reopens the conformity assessment.</a:t>
+            </a:r>
+            <a:endParaRPr lang="en-US" sz="770" dirty="0"/>
+          </a:p>
+        </p:txBody>
+      </p:sp>
+      <p:sp>
+        <p:nvSpPr>
+          <p:cNvPr id="64" name="Text 61"/>
+          <p:cNvSpPr/>
+          <p:nvPr/>
+        </p:nvSpPr>
+        <p:spPr>
+          <a:xfrm>
+            <a:off x="457200" y="6217920"/>
+            <a:ext cx="11155680" cy="128016"/>
+          </a:xfrm>
+          <a:prstGeom prst="rect">
+            <a:avLst/>
+          </a:prstGeom>
+          <a:noFill/>
+          <a:ln/>
+        </p:spPr>
+        <p:txBody>
+          <a:bodyPr wrap="square" lIns="0" tIns="0" rIns="0" bIns="0" rtlCol="0" anchor="ctr">
+            <a:normAutofit/>
+          </a:bodyPr>
+          <a:lstStyle/>
+          <a:p>
+            <a:pPr algn="l" indent="0" marL="0">
+              <a:buNone/>
+            </a:pPr>
+            <a:r>
+              <a:rPr lang="en-US" sz="660" i="1" dirty="0">
+                <a:solidFill>
+                  <a:srgbClr val="AEB9BA"/>
+                </a:solidFill>
+                <a:latin typeface="Aptos" pitchFamily="34" charset="0"/>
+                <a:ea typeface="Aptos" pitchFamily="34" charset="-122"/>
+                <a:cs typeface="Aptos" pitchFamily="34" charset="-120"/>
+              </a:rPr>
+              <a:t>Source cue | FAQ C — faq.md Q14b  •  solution-architecture.md ADR-016, ADR-005, §4.1  •  infra/bicep/modules/eventhubs.bicep</a:t>
+            </a:r>
+            <a:endParaRPr lang="en-US" sz="660" dirty="0"/>
+          </a:p>
+        </p:txBody>
+      </p:sp>
+      <p:sp>
+        <p:nvSpPr>
+          <p:cNvPr id="65" name="Shape 62"/>
+          <p:cNvSpPr/>
+          <p:nvPr/>
+        </p:nvSpPr>
+        <p:spPr>
+          <a:xfrm>
+            <a:off x="0" y="6483096"/>
+            <a:ext cx="12191695" cy="374904"/>
+          </a:xfrm>
+          <a:prstGeom prst="rect">
+            <a:avLst/>
+          </a:prstGeom>
+          <a:solidFill>
+            <a:srgbClr val="1F2426"/>
+          </a:solidFill>
+          <a:ln w="6350">
+            <a:solidFill>
+              <a:srgbClr val="1F2426"/>
+            </a:solidFill>
+            <a:prstDash val="solid"/>
+          </a:ln>
+        </p:spPr>
+      </p:sp>
+      <p:sp>
+        <p:nvSpPr>
+          <p:cNvPr id="66" name="Shape 63"/>
+          <p:cNvSpPr/>
+          <p:nvPr/>
+        </p:nvSpPr>
+        <p:spPr>
+          <a:xfrm>
+            <a:off x="384048" y="6547104"/>
+            <a:ext cx="3547872" cy="182880"/>
+          </a:xfrm>
+          <a:prstGeom prst="roundRect">
+            <a:avLst/>
+          </a:prstGeom>
+          <a:solidFill>
+            <a:srgbClr val="465057"/>
+          </a:solidFill>
+          <a:ln w="3175">
+            <a:solidFill>
+              <a:srgbClr val="465057"/>
+            </a:solidFill>
+            <a:prstDash val="solid"/>
+          </a:ln>
+        </p:spPr>
+      </p:sp>
+      <p:sp>
+        <p:nvSpPr>
+          <p:cNvPr id="67" name="Text 64"/>
+          <p:cNvSpPr/>
+          <p:nvPr/>
+        </p:nvSpPr>
+        <p:spPr>
+          <a:xfrm>
+            <a:off x="512064" y="6588252"/>
+            <a:ext cx="3291840" cy="73152"/>
+          </a:xfrm>
+          <a:prstGeom prst="rect">
+            <a:avLst/>
+          </a:prstGeom>
+          <a:noFill/>
+          <a:ln/>
+        </p:spPr>
+        <p:txBody>
+          <a:bodyPr wrap="square" lIns="0" tIns="0" rIns="0" bIns="0" rtlCol="0" anchor="ctr">
+            <a:normAutofit/>
+          </a:bodyPr>
+          <a:lstStyle/>
+          <a:p>
+            <a:pPr algn="l" indent="0" marL="0">
+              <a:buNone/>
+            </a:pPr>
+            <a:r>
+              <a:rPr lang="en-US" sz="625" b="1" spc="65" kern="0" dirty="0">
+                <a:solidFill>
+                  <a:srgbClr val="DDE4E1"/>
+                </a:solidFill>
+                <a:latin typeface="Aptos" pitchFamily="34" charset="0"/>
+                <a:ea typeface="Aptos" pitchFamily="34" charset="-122"/>
+                <a:cs typeface="Aptos" pitchFamily="34" charset="-120"/>
+              </a:rPr>
+              <a:t>PHASE 0  |  SYNTHETIC DEMONSTRATION  |  NOT FOR OPERATIONAL CONTROL</a:t>
+            </a:r>
+            <a:endParaRPr lang="en-US" sz="625" dirty="0"/>
+          </a:p>
+        </p:txBody>
+      </p:sp>
+      <p:sp>
+        <p:nvSpPr>
+          <p:cNvPr id="68" name="Text 65"/>
+          <p:cNvSpPr/>
+          <p:nvPr/>
+        </p:nvSpPr>
+        <p:spPr>
+          <a:xfrm>
+            <a:off x="8732520" y="6588252"/>
+            <a:ext cx="3017520" cy="73152"/>
+          </a:xfrm>
+          <a:prstGeom prst="rect">
+            <a:avLst/>
+          </a:prstGeom>
+          <a:noFill/>
+          <a:ln/>
+        </p:spPr>
+        <p:txBody>
+          <a:bodyPr wrap="square" lIns="0" tIns="0" rIns="0" bIns="0" rtlCol="0" anchor="ctr">
+            <a:normAutofit/>
+          </a:bodyPr>
+          <a:lstStyle/>
+          <a:p>
+            <a:pPr algn="r" indent="0" marL="0">
+              <a:buNone/>
+            </a:pPr>
+            <a:r>
+              <a:rPr lang="en-US" sz="650" b="1" spc="50" kern="0" dirty="0">
+                <a:solidFill>
+                  <a:srgbClr val="DDE4E1"/>
+                </a:solidFill>
+                <a:latin typeface="Aptos" pitchFamily="34" charset="0"/>
+                <a:ea typeface="Aptos" pitchFamily="34" charset="-122"/>
+                <a:cs typeface="Aptos" pitchFamily="34" charset="-120"/>
+              </a:rPr>
+              <a:t>FAQ &amp; VALIDATION BACKUP  •  08 / 08</a:t>
             </a:r>
             <a:endParaRPr lang="en-US" sz="650" dirty="0"/>
           </a:p>

</xml_diff>